<commit_message>
Add full team names to presentation
</commit_message>
<xml_diff>
--- a/docs/Smart_Grocery_Agents_Project_Proposal.pptx
+++ b/docs/Smart_Grocery_Agents_Project_Proposal.pptx
@@ -2,20 +2,20 @@
 <file path=ppt/presentation.xml><?xml version="1.0" encoding="utf-8"?>
 <p:presentation xmlns:p="http://schemas.openxmlformats.org/presentationml/2006/main">
   <p:sldMasterIdLst>
-    <p:sldMasterId xmlns:r="http://schemas.openxmlformats.org/officeDocument/2006/relationships" id="2147483648" r:id="R0f696629af37437c"/>
+    <p:sldMasterId xmlns:r="http://schemas.openxmlformats.org/officeDocument/2006/relationships" id="2147483648" r:id="R1390041177074e36"/>
   </p:sldMasterIdLst>
   <p:notesMasterIdLst>
-    <p:notesMasterId xmlns:r="http://schemas.openxmlformats.org/officeDocument/2006/relationships" r:id="R1fd12915f0aa496f"/>
+    <p:notesMasterId xmlns:r="http://schemas.openxmlformats.org/officeDocument/2006/relationships" r:id="Rdfde71b491514b24"/>
   </p:notesMasterIdLst>
   <p:sldIdLst>
-    <p:sldId xmlns:r="http://schemas.openxmlformats.org/officeDocument/2006/relationships" id="256" r:id="R8fa8869b39d34e20"/>
-    <p:sldId xmlns:r="http://schemas.openxmlformats.org/officeDocument/2006/relationships" id="257" r:id="R24756217f90443dc"/>
-    <p:sldId xmlns:r="http://schemas.openxmlformats.org/officeDocument/2006/relationships" id="258" r:id="Rd4c6c98783854c94"/>
-    <p:sldId xmlns:r="http://schemas.openxmlformats.org/officeDocument/2006/relationships" id="259" r:id="R6e561d55ba4d4bf9"/>
-    <p:sldId xmlns:r="http://schemas.openxmlformats.org/officeDocument/2006/relationships" id="260" r:id="Re4765c1bf32443d5"/>
-    <p:sldId xmlns:r="http://schemas.openxmlformats.org/officeDocument/2006/relationships" id="261" r:id="R284f471de7f4487f"/>
-    <p:sldId xmlns:r="http://schemas.openxmlformats.org/officeDocument/2006/relationships" id="262" r:id="Rc11e3ddd39a04e01"/>
-    <p:sldId xmlns:r="http://schemas.openxmlformats.org/officeDocument/2006/relationships" id="263" r:id="R3d64422dfa9649cd"/>
+    <p:sldId xmlns:r="http://schemas.openxmlformats.org/officeDocument/2006/relationships" id="256" r:id="R460552b6351c4427"/>
+    <p:sldId xmlns:r="http://schemas.openxmlformats.org/officeDocument/2006/relationships" id="257" r:id="R0d1a5d2677724e96"/>
+    <p:sldId xmlns:r="http://schemas.openxmlformats.org/officeDocument/2006/relationships" id="258" r:id="Rfed75943664044d2"/>
+    <p:sldId xmlns:r="http://schemas.openxmlformats.org/officeDocument/2006/relationships" id="259" r:id="R7eeb18bf5afd4de8"/>
+    <p:sldId xmlns:r="http://schemas.openxmlformats.org/officeDocument/2006/relationships" id="260" r:id="R01867d17bebe4a6d"/>
+    <p:sldId xmlns:r="http://schemas.openxmlformats.org/officeDocument/2006/relationships" id="261" r:id="Rc6cf3d4e42134e6e"/>
+    <p:sldId xmlns:r="http://schemas.openxmlformats.org/officeDocument/2006/relationships" id="262" r:id="R00b27dbfd3944f73"/>
+    <p:sldId xmlns:r="http://schemas.openxmlformats.org/officeDocument/2006/relationships" id="263" r:id="Rd09531c8cfa84146"/>
   </p:sldIdLst>
   <p:sldSz cx="12192000" cy="6858000"/>
   <p:notesSz cx="6858000" cy="9144000"/>
@@ -449,7 +449,7 @@
           <a:lstStyle xmlns:a="http://schemas.openxmlformats.org/drawingml/2006/main"/>
           <a:p xmlns:a="http://schemas.openxmlformats.org/drawingml/2006/main">
             <a:r>
-              <a:t>Спикер: Анастасия, 35–40 секунд. Представиться и назвать команду. Коротко: мы собрали работающий MVP, который из пользовательских ограничений формирует меню, считает корзину и проверяет результат. На слайде пока указаны имя и GitHub Максима и Риты; заменить на полные ФИО перед защитой.</a:t>
+              <a:t>Спикер: Анастасия, 35–40 секунд. Представиться и назвать команду. Коротко: мы собрали работающий MVP, который из пользовательских ограничений формирует меню, считает корзину и проверяет результат.</a:t>
             </a:r>
           </a:p>
         </p:txBody>
@@ -986,7 +986,7 @@
           <p:cNvPr id="3" name="Title">
             <a:extLst xmlns:a="http://schemas.openxmlformats.org/drawingml/2006/main">
               <a:ext uri="{FF2B5EF4-FFF2-40B4-BE49-F238E27FC236}">
-                <a16:creationId xmlns:a16="http://schemas.microsoft.com/office/drawing/2014/main" id="{E4A165B7-1F10-4E57-AB10-B9077A93E6CE}"/>
+                <a16:creationId xmlns:a16="http://schemas.microsoft.com/office/drawing/2014/main" id="{55D0161F-200C-4AE1-BAC8-3703C5B4AE51}"/>
               </a:ext>
             </a:extLst>
           </p:cNvPr>
@@ -1215,7 +1215,7 @@
           <p:cNvPr id="2" name="Subtitle">
             <a:extLst xmlns:a="http://schemas.openxmlformats.org/drawingml/2006/main">
               <a:ext uri="{FF2B5EF4-FFF2-40B4-BE49-F238E27FC236}">
-                <a16:creationId xmlns:a16="http://schemas.microsoft.com/office/drawing/2014/main" id="{97F0DE9A-B98C-4B06-B5D3-830B18013C62}"/>
+                <a16:creationId xmlns:a16="http://schemas.microsoft.com/office/drawing/2014/main" id="{BDE7BD8D-805B-408A-BF87-CA7E4CD88D8E}"/>
               </a:ext>
             </a:extLst>
           </p:cNvPr>
@@ -1461,7 +1461,7 @@
           <p:cNvPr id="2" name="Section title">
             <a:extLst xmlns:a="http://schemas.openxmlformats.org/drawingml/2006/main">
               <a:ext uri="{FF2B5EF4-FFF2-40B4-BE49-F238E27FC236}">
-                <a16:creationId xmlns:a16="http://schemas.microsoft.com/office/drawing/2014/main" id="{EE25B366-D5CB-4132-AFF5-8005D40B41EB}"/>
+                <a16:creationId xmlns:a16="http://schemas.microsoft.com/office/drawing/2014/main" id="{A9D86529-160F-4259-A314-E450924D5BA6}"/>
               </a:ext>
             </a:extLst>
           </p:cNvPr>
@@ -1707,7 +1707,7 @@
           <p:cNvPr id="3" name="Title">
             <a:extLst xmlns:a="http://schemas.openxmlformats.org/drawingml/2006/main">
               <a:ext uri="{FF2B5EF4-FFF2-40B4-BE49-F238E27FC236}">
-                <a16:creationId xmlns:a16="http://schemas.microsoft.com/office/drawing/2014/main" id="{328B096F-11ED-4500-84A0-2ACCA11D8ED9}"/>
+                <a16:creationId xmlns:a16="http://schemas.microsoft.com/office/drawing/2014/main" id="{97A9C4D1-983F-46EB-9BD3-81CAD3663814}"/>
               </a:ext>
             </a:extLst>
           </p:cNvPr>
@@ -1936,7 +1936,7 @@
           <p:cNvPr id="2" name="Body">
             <a:extLst xmlns:a="http://schemas.openxmlformats.org/drawingml/2006/main">
               <a:ext uri="{FF2B5EF4-FFF2-40B4-BE49-F238E27FC236}">
-                <a16:creationId xmlns:a16="http://schemas.microsoft.com/office/drawing/2014/main" id="{3E33B137-BC8F-435E-BFE4-108830DEE272}"/>
+                <a16:creationId xmlns:a16="http://schemas.microsoft.com/office/drawing/2014/main" id="{D8DFC3E8-CF35-4E47-A108-A31264B43CF8}"/>
               </a:ext>
             </a:extLst>
           </p:cNvPr>
@@ -2182,7 +2182,7 @@
           <p:cNvPr id="4" name="Title">
             <a:extLst xmlns:a="http://schemas.openxmlformats.org/drawingml/2006/main">
               <a:ext uri="{FF2B5EF4-FFF2-40B4-BE49-F238E27FC236}">
-                <a16:creationId xmlns:a16="http://schemas.microsoft.com/office/drawing/2014/main" id="{06C1EF28-1E69-4151-AAA0-BEF9FF497772}"/>
+                <a16:creationId xmlns:a16="http://schemas.microsoft.com/office/drawing/2014/main" id="{DB4C4E64-D9E7-4CFB-A394-E57B6C0A8445}"/>
               </a:ext>
             </a:extLst>
           </p:cNvPr>
@@ -2411,7 +2411,7 @@
           <p:cNvPr id="2" name="Left column">
             <a:extLst xmlns:a="http://schemas.openxmlformats.org/drawingml/2006/main">
               <a:ext uri="{FF2B5EF4-FFF2-40B4-BE49-F238E27FC236}">
-                <a16:creationId xmlns:a16="http://schemas.microsoft.com/office/drawing/2014/main" id="{8FD0EBD8-2809-461E-8011-28087B98C3ED}"/>
+                <a16:creationId xmlns:a16="http://schemas.microsoft.com/office/drawing/2014/main" id="{5C278160-954F-4358-BDC7-2F9E5DB4BF72}"/>
               </a:ext>
             </a:extLst>
           </p:cNvPr>
@@ -2640,7 +2640,7 @@
           <p:cNvPr id="3" name="Right column">
             <a:extLst xmlns:a="http://schemas.openxmlformats.org/drawingml/2006/main">
               <a:ext uri="{FF2B5EF4-FFF2-40B4-BE49-F238E27FC236}">
-                <a16:creationId xmlns:a16="http://schemas.microsoft.com/office/drawing/2014/main" id="{128E530B-5389-44CE-8ACE-EE7215C277F7}"/>
+                <a16:creationId xmlns:a16="http://schemas.microsoft.com/office/drawing/2014/main" id="{35B856BF-C02D-4DF2-A62A-17B484F15600}"/>
               </a:ext>
             </a:extLst>
           </p:cNvPr>
@@ -2886,7 +2886,7 @@
           <p:cNvPr id="3" name="Title">
             <a:extLst xmlns:a="http://schemas.openxmlformats.org/drawingml/2006/main">
               <a:ext uri="{FF2B5EF4-FFF2-40B4-BE49-F238E27FC236}">
-                <a16:creationId xmlns:a16="http://schemas.microsoft.com/office/drawing/2014/main" id="{7E9EE0A8-9FEE-4DAD-B7B4-F5E36FB46189}"/>
+                <a16:creationId xmlns:a16="http://schemas.microsoft.com/office/drawing/2014/main" id="{B3B928E1-FCFB-4063-BD8F-1DE2722BB565}"/>
               </a:ext>
             </a:extLst>
           </p:cNvPr>
@@ -3115,7 +3115,7 @@
           <p:cNvPr id="2" name="Left column">
             <a:extLst xmlns:a="http://schemas.openxmlformats.org/drawingml/2006/main">
               <a:ext uri="{FF2B5EF4-FFF2-40B4-BE49-F238E27FC236}">
-                <a16:creationId xmlns:a16="http://schemas.microsoft.com/office/drawing/2014/main" id="{CFA7ADDA-CF5D-4B88-8E58-94C9871C1C8F}"/>
+                <a16:creationId xmlns:a16="http://schemas.microsoft.com/office/drawing/2014/main" id="{E3BAFF14-C488-4F9A-B0D0-FE70C15365AF}"/>
               </a:ext>
             </a:extLst>
           </p:cNvPr>
@@ -3382,12 +3382,12 @@
   </p:cSld>
   <p:clrMap bg1="lt1" tx1="dk1" bg2="lt2" tx2="dk2" accent1="accent1" accent2="accent2" accent3="accent3" accent4="accent4" accent5="accent5" accent6="accent6" hlink="hlink" folHlink="folHlink"/>
   <p:sldLayoutIdLst>
-    <p:sldLayoutId xmlns:r="http://schemas.openxmlformats.org/officeDocument/2006/relationships" id="2147483649" r:id="Rf551ab4ccd1a407f"/>
-    <p:sldLayoutId xmlns:r="http://schemas.openxmlformats.org/officeDocument/2006/relationships" id="2147483650" r:id="R9731a73714e94977"/>
-    <p:sldLayoutId xmlns:r="http://schemas.openxmlformats.org/officeDocument/2006/relationships" id="2147483651" r:id="R126ae5ebea7247dc"/>
-    <p:sldLayoutId xmlns:r="http://schemas.openxmlformats.org/officeDocument/2006/relationships" id="2147483652" r:id="R271a8eb0239643e6"/>
-    <p:sldLayoutId xmlns:r="http://schemas.openxmlformats.org/officeDocument/2006/relationships" id="2147483653" r:id="R43ea08c1addb4414"/>
-    <p:sldLayoutId xmlns:r="http://schemas.openxmlformats.org/officeDocument/2006/relationships" id="2147483654" r:id="R0427149cfcb14eb2"/>
+    <p:sldLayoutId xmlns:r="http://schemas.openxmlformats.org/officeDocument/2006/relationships" id="2147483649" r:id="R915b2d94d6a642a8"/>
+    <p:sldLayoutId xmlns:r="http://schemas.openxmlformats.org/officeDocument/2006/relationships" id="2147483650" r:id="R7eec097a5a4248c1"/>
+    <p:sldLayoutId xmlns:r="http://schemas.openxmlformats.org/officeDocument/2006/relationships" id="2147483651" r:id="Rcddd5a17ea4846e4"/>
+    <p:sldLayoutId xmlns:r="http://schemas.openxmlformats.org/officeDocument/2006/relationships" id="2147483652" r:id="Rb98b80e4c4e143bb"/>
+    <p:sldLayoutId xmlns:r="http://schemas.openxmlformats.org/officeDocument/2006/relationships" id="2147483653" r:id="R66ec7d690b464a26"/>
+    <p:sldLayoutId xmlns:r="http://schemas.openxmlformats.org/officeDocument/2006/relationships" id="2147483654" r:id="R2c6d2f650b104fc0"/>
   </p:sldLayoutIdLst>
   <p:txStyles>
     <p:titleStyle>
@@ -3938,7 +3938,7 @@
           <p:cNvPr id="10" name="">
             <a:extLst xmlns:a="http://schemas.openxmlformats.org/drawingml/2006/main">
               <a:ext uri="{FF2B5EF4-FFF2-40B4-BE49-F238E27FC236}">
-                <a16:creationId xmlns:a16="http://schemas.microsoft.com/office/drawing/2014/main" id="{AE4B1CD2-19CE-4FBD-A1AE-BAE9FC9627CD}"/>
+                <a16:creationId xmlns:a16="http://schemas.microsoft.com/office/drawing/2014/main" id="{C1F73863-DC54-4FC3-A38F-285D079F8D6C}"/>
               </a:ext>
             </a:extLst>
           </p:cNvPr>
@@ -3969,7 +3969,7 @@
           <p:cNvPr id="2" name="">
             <a:extLst xmlns:a="http://schemas.openxmlformats.org/drawingml/2006/main">
               <a:ext uri="{FF2B5EF4-FFF2-40B4-BE49-F238E27FC236}">
-                <a16:creationId xmlns:a16="http://schemas.microsoft.com/office/drawing/2014/main" id="{5AF1FC7F-56D6-4610-8C42-93CB086C33D1}"/>
+                <a16:creationId xmlns:a16="http://schemas.microsoft.com/office/drawing/2014/main" id="{DE5F8C79-A4D4-46E0-A7B3-62274801AB62}"/>
               </a:ext>
             </a:extLst>
           </p:cNvPr>
@@ -4002,7 +4002,7 @@
           <p:cNvPr id="3" name="">
             <a:extLst xmlns:a="http://schemas.openxmlformats.org/drawingml/2006/main">
               <a:ext uri="{FF2B5EF4-FFF2-40B4-BE49-F238E27FC236}">
-                <a16:creationId xmlns:a16="http://schemas.microsoft.com/office/drawing/2014/main" id="{D8DA8A9B-7CED-4D57-AF6F-52EB9DB2184B}"/>
+                <a16:creationId xmlns:a16="http://schemas.microsoft.com/office/drawing/2014/main" id="{D66FCD5B-6128-4525-BAA3-900847119884}"/>
               </a:ext>
             </a:extLst>
           </p:cNvPr>
@@ -4165,7 +4165,7 @@
           <p:cNvPr id="4" name="">
             <a:extLst xmlns:a="http://schemas.openxmlformats.org/drawingml/2006/main">
               <a:ext uri="{FF2B5EF4-FFF2-40B4-BE49-F238E27FC236}">
-                <a16:creationId xmlns:a16="http://schemas.microsoft.com/office/drawing/2014/main" id="{C65965E0-84BB-4FEA-BD63-65EFFCCA5F6E}"/>
+                <a16:creationId xmlns:a16="http://schemas.microsoft.com/office/drawing/2014/main" id="{2A98268B-C236-4AC5-8C1B-4B40074CA3F6}"/>
               </a:ext>
             </a:extLst>
           </p:cNvPr>
@@ -4355,7 +4355,7 @@
           <p:cNvPr id="5" name="">
             <a:extLst xmlns:a="http://schemas.openxmlformats.org/drawingml/2006/main">
               <a:ext uri="{FF2B5EF4-FFF2-40B4-BE49-F238E27FC236}">
-                <a16:creationId xmlns:a16="http://schemas.microsoft.com/office/drawing/2014/main" id="{78584791-6750-40CE-B8E7-F0C88DBB04BA}"/>
+                <a16:creationId xmlns:a16="http://schemas.microsoft.com/office/drawing/2014/main" id="{058ACDC8-40BC-4CE4-8B2E-0B792EC70576}"/>
               </a:ext>
             </a:extLst>
           </p:cNvPr>
@@ -4545,7 +4545,7 @@
           <p:cNvPr id="6" name="">
             <a:extLst xmlns:a="http://schemas.openxmlformats.org/drawingml/2006/main">
               <a:ext uri="{FF2B5EF4-FFF2-40B4-BE49-F238E27FC236}">
-                <a16:creationId xmlns:a16="http://schemas.microsoft.com/office/drawing/2014/main" id="{1EE6DE72-62CC-437E-8839-5F72506B068C}"/>
+                <a16:creationId xmlns:a16="http://schemas.microsoft.com/office/drawing/2014/main" id="{6C25384D-3326-4508-9488-B40107AA7F86}"/>
               </a:ext>
             </a:extLst>
           </p:cNvPr>
@@ -4708,7 +4708,7 @@
           <p:cNvPr id="7" name="">
             <a:extLst xmlns:a="http://schemas.openxmlformats.org/drawingml/2006/main">
               <a:ext uri="{FF2B5EF4-FFF2-40B4-BE49-F238E27FC236}">
-                <a16:creationId xmlns:a16="http://schemas.microsoft.com/office/drawing/2014/main" id="{52D0B208-6025-44C0-A1DB-A637241247AF}"/>
+                <a16:creationId xmlns:a16="http://schemas.microsoft.com/office/drawing/2014/main" id="{B49D7BA4-3D34-4BE9-884A-83F205EC13BC}"/>
               </a:ext>
             </a:extLst>
           </p:cNvPr>
@@ -4720,7 +4720,7 @@
         <p:spPr>
           <a:xfrm xmlns:a="http://schemas.openxmlformats.org/drawingml/2006/main">
             <a:off x="723900" y="4572000"/>
-            <a:ext cx="5572125" cy="1219200"/>
+            <a:ext cx="6096000" cy="1219200"/>
           </a:xfrm>
           <a:prstGeom xmlns:a="http://schemas.openxmlformats.org/drawingml/2006/main" prst="rect">
             <a:avLst/>
@@ -4861,7 +4861,7 @@
                 <a:ea typeface="Arial"/>
                 <a:cs typeface="Arial"/>
               </a:rPr>
-              <a:t>Анастасия Сергеева · @asastyy</a:t>
+              <a:t>Сергеева Анастасия Вадимовна</a:t>
             </a:r>
           </a:p>
           <a:p xmlns:a="http://schemas.openxmlformats.org/drawingml/2006/main">
@@ -4888,7 +4888,7 @@
                 <a:ea typeface="Arial"/>
                 <a:cs typeface="Arial"/>
               </a:rPr>
-              <a:t>Александра Федорова · @fedorova-av</a:t>
+              <a:t>Федорова Александра Вадимовна</a:t>
             </a:r>
           </a:p>
           <a:p xmlns:a="http://schemas.openxmlformats.org/drawingml/2006/main">
@@ -4915,7 +4915,7 @@
                 <a:ea typeface="Arial"/>
                 <a:cs typeface="Arial"/>
               </a:rPr>
-              <a:t>Максим · @jeweller9</a:t>
+              <a:t>Уразметова Маргарита Руслановна</a:t>
             </a:r>
           </a:p>
           <a:p xmlns:a="http://schemas.openxmlformats.org/drawingml/2006/main">
@@ -4942,7 +4942,7 @@
                 <a:ea typeface="Arial"/>
                 <a:cs typeface="Arial"/>
               </a:rPr>
-              <a:t>Рита · @marritau</a:t>
+              <a:t>Афонин Максим Константинович</a:t>
             </a:r>
           </a:p>
         </p:txBody>
@@ -4952,7 +4952,7 @@
           <p:cNvPr id="8" name="">
             <a:extLst xmlns:a="http://schemas.openxmlformats.org/drawingml/2006/main">
               <a:ext uri="{FF2B5EF4-FFF2-40B4-BE49-F238E27FC236}">
-                <a16:creationId xmlns:a16="http://schemas.microsoft.com/office/drawing/2014/main" id="{932023B6-A5C9-47A4-AAE2-FFD027F28352}"/>
+                <a16:creationId xmlns:a16="http://schemas.microsoft.com/office/drawing/2014/main" id="{0F5278A2-AE49-4224-8F40-AA6ED8AFCE28}"/>
               </a:ext>
             </a:extLst>
           </p:cNvPr>
@@ -4985,7 +4985,7 @@
           <p:cNvPr id="9" name="">
             <a:extLst xmlns:a="http://schemas.openxmlformats.org/drawingml/2006/main">
               <a:ext uri="{FF2B5EF4-FFF2-40B4-BE49-F238E27FC236}">
-                <a16:creationId xmlns:a16="http://schemas.microsoft.com/office/drawing/2014/main" id="{839E5D14-92D5-412C-93D6-5CC406331459}"/>
+                <a16:creationId xmlns:a16="http://schemas.microsoft.com/office/drawing/2014/main" id="{C06979D4-A9E1-4E84-8AAA-158DFD3305B7}"/>
               </a:ext>
             </a:extLst>
           </p:cNvPr>
@@ -4995,7 +4995,7 @@
           <p:nvPr/>
         </p:nvPicPr>
         <p:blipFill>
-          <a:blip xmlns:r="http://schemas.openxmlformats.org/officeDocument/2006/relationships" xmlns:a="http://schemas.openxmlformats.org/drawingml/2006/main" r:embed="R4c3354ffa91b4228"/>
+          <a:blip xmlns:r="http://schemas.openxmlformats.org/officeDocument/2006/relationships" xmlns:a="http://schemas.openxmlformats.org/drawingml/2006/main" r:embed="R2808d3f4e9574eb9"/>
           <a:srcRect xmlns:a="http://schemas.openxmlformats.org/drawingml/2006/main" l="0" t="2000" r="0" b="2000"/>
           <a:stretch xmlns:a="http://schemas.openxmlformats.org/drawingml/2006/main"/>
         </p:blipFill>
@@ -5014,7 +5014,7 @@
     </p:spTree>
     <p:extLst>
       <p:ext uri="{BB962C8B-B14F-4D97-AF65-F5344CB8AC3E}">
-        <p14:creationId xmlns:p14="http://schemas.microsoft.com/office/powerpoint/2010/main" val="353344488"/>
+        <p14:creationId xmlns:p14="http://schemas.microsoft.com/office/powerpoint/2010/main" val="118121208"/>
       </p:ext>
     </p:extLst>
   </p:cSld>
@@ -5045,7 +5045,7 @@
           <p:cNvPr id="29" name="">
             <a:extLst xmlns:a="http://schemas.openxmlformats.org/drawingml/2006/main">
               <a:ext uri="{FF2B5EF4-FFF2-40B4-BE49-F238E27FC236}">
-                <a16:creationId xmlns:a16="http://schemas.microsoft.com/office/drawing/2014/main" id="{D8BF8362-4EB2-4BD6-B7A2-091612D67565}"/>
+                <a16:creationId xmlns:a16="http://schemas.microsoft.com/office/drawing/2014/main" id="{64C38AA2-C471-4E52-B6A8-CD4F10D0BB31}"/>
               </a:ext>
             </a:extLst>
           </p:cNvPr>
@@ -5079,7 +5079,7 @@
           <p:cNvPr id="28" name="">
             <a:extLst xmlns:a="http://schemas.openxmlformats.org/drawingml/2006/main">
               <a:ext uri="{FF2B5EF4-FFF2-40B4-BE49-F238E27FC236}">
-                <a16:creationId xmlns:a16="http://schemas.microsoft.com/office/drawing/2014/main" id="{B8B18C81-C5AD-4DB8-95FB-9818DB4CA3A3}"/>
+                <a16:creationId xmlns:a16="http://schemas.microsoft.com/office/drawing/2014/main" id="{0DA54567-AC38-448B-90EA-01C885B1F02B}"/>
               </a:ext>
             </a:extLst>
           </p:cNvPr>
@@ -5113,7 +5113,7 @@
           <p:cNvPr id="36" name="">
             <a:extLst xmlns:a="http://schemas.openxmlformats.org/drawingml/2006/main">
               <a:ext uri="{FF2B5EF4-FFF2-40B4-BE49-F238E27FC236}">
-                <a16:creationId xmlns:a16="http://schemas.microsoft.com/office/drawing/2014/main" id="{1CBD4570-2A08-41FC-8F4E-7D13BC7F36D5}"/>
+                <a16:creationId xmlns:a16="http://schemas.microsoft.com/office/drawing/2014/main" id="{C30E3823-8011-411D-89E6-B01DBDA96448}"/>
               </a:ext>
             </a:extLst>
           </p:cNvPr>
@@ -5276,7 +5276,7 @@
           <p:cNvPr id="2" name="">
             <a:extLst xmlns:a="http://schemas.openxmlformats.org/drawingml/2006/main">
               <a:ext uri="{FF2B5EF4-FFF2-40B4-BE49-F238E27FC236}">
-                <a16:creationId xmlns:a16="http://schemas.microsoft.com/office/drawing/2014/main" id="{72536B01-010A-426E-8128-559D31093D0B}"/>
+                <a16:creationId xmlns:a16="http://schemas.microsoft.com/office/drawing/2014/main" id="{63E39FB8-4D4C-472C-9B3D-19958489DA6F}"/>
               </a:ext>
             </a:extLst>
           </p:cNvPr>
@@ -5439,7 +5439,7 @@
           <p:cNvPr id="3" name="">
             <a:extLst xmlns:a="http://schemas.openxmlformats.org/drawingml/2006/main">
               <a:ext uri="{FF2B5EF4-FFF2-40B4-BE49-F238E27FC236}">
-                <a16:creationId xmlns:a16="http://schemas.microsoft.com/office/drawing/2014/main" id="{99436414-B4D3-43C1-A39E-CFBDEBAAD1C8}"/>
+                <a16:creationId xmlns:a16="http://schemas.microsoft.com/office/drawing/2014/main" id="{7CC0E9AB-7923-4588-B080-53B209E3887F}"/>
               </a:ext>
             </a:extLst>
           </p:cNvPr>
@@ -5602,7 +5602,7 @@
           <p:cNvPr id="4" name="">
             <a:extLst xmlns:a="http://schemas.openxmlformats.org/drawingml/2006/main">
               <a:ext uri="{FF2B5EF4-FFF2-40B4-BE49-F238E27FC236}">
-                <a16:creationId xmlns:a16="http://schemas.microsoft.com/office/drawing/2014/main" id="{6CF5C424-32DC-4120-B617-731E3F132F2E}"/>
+                <a16:creationId xmlns:a16="http://schemas.microsoft.com/office/drawing/2014/main" id="{A1EF9567-7A75-4045-AF22-683197E52974}"/>
               </a:ext>
             </a:extLst>
           </p:cNvPr>
@@ -5635,7 +5635,7 @@
           <p:cNvPr id="5" name="">
             <a:extLst xmlns:a="http://schemas.openxmlformats.org/drawingml/2006/main">
               <a:ext uri="{FF2B5EF4-FFF2-40B4-BE49-F238E27FC236}">
-                <a16:creationId xmlns:a16="http://schemas.microsoft.com/office/drawing/2014/main" id="{57243D60-3817-4D75-9D99-F44348422215}"/>
+                <a16:creationId xmlns:a16="http://schemas.microsoft.com/office/drawing/2014/main" id="{AAA5FF94-4808-4F06-A8D5-1B31D0684326}"/>
               </a:ext>
             </a:extLst>
           </p:cNvPr>
@@ -5798,7 +5798,7 @@
           <p:cNvPr id="6" name="">
             <a:extLst xmlns:a="http://schemas.openxmlformats.org/drawingml/2006/main">
               <a:ext uri="{FF2B5EF4-FFF2-40B4-BE49-F238E27FC236}">
-                <a16:creationId xmlns:a16="http://schemas.microsoft.com/office/drawing/2014/main" id="{2398BFFC-982B-4E48-A760-C29B4844BF71}"/>
+                <a16:creationId xmlns:a16="http://schemas.microsoft.com/office/drawing/2014/main" id="{E3F22DB2-1D88-4116-BBEF-63E0BF2C6E03}"/>
               </a:ext>
             </a:extLst>
           </p:cNvPr>
@@ -5961,7 +5961,7 @@
           <p:cNvPr id="7" name="">
             <a:extLst xmlns:a="http://schemas.openxmlformats.org/drawingml/2006/main">
               <a:ext uri="{FF2B5EF4-FFF2-40B4-BE49-F238E27FC236}">
-                <a16:creationId xmlns:a16="http://schemas.microsoft.com/office/drawing/2014/main" id="{5F222D53-8306-4893-A185-1BD791E869EE}"/>
+                <a16:creationId xmlns:a16="http://schemas.microsoft.com/office/drawing/2014/main" id="{529A7A30-60A2-450A-9D39-21FCB73502E7}"/>
               </a:ext>
             </a:extLst>
           </p:cNvPr>
@@ -5994,7 +5994,7 @@
           <p:cNvPr id="8" name="">
             <a:extLst xmlns:a="http://schemas.openxmlformats.org/drawingml/2006/main">
               <a:ext uri="{FF2B5EF4-FFF2-40B4-BE49-F238E27FC236}">
-                <a16:creationId xmlns:a16="http://schemas.microsoft.com/office/drawing/2014/main" id="{23B1B680-2E32-4ADA-86E1-5E17745FF228}"/>
+                <a16:creationId xmlns:a16="http://schemas.microsoft.com/office/drawing/2014/main" id="{A402C0AB-6AD6-4AFA-A83E-C886821E6855}"/>
               </a:ext>
             </a:extLst>
           </p:cNvPr>
@@ -6157,7 +6157,7 @@
           <p:cNvPr id="9" name="">
             <a:extLst xmlns:a="http://schemas.openxmlformats.org/drawingml/2006/main">
               <a:ext uri="{FF2B5EF4-FFF2-40B4-BE49-F238E27FC236}">
-                <a16:creationId xmlns:a16="http://schemas.microsoft.com/office/drawing/2014/main" id="{36737FC9-8171-494D-AC29-33ACF74BB133}"/>
+                <a16:creationId xmlns:a16="http://schemas.microsoft.com/office/drawing/2014/main" id="{743D6AE8-071E-4287-9648-D98D5E787922}"/>
               </a:ext>
             </a:extLst>
           </p:cNvPr>
@@ -6320,7 +6320,7 @@
           <p:cNvPr id="10" name="">
             <a:extLst xmlns:a="http://schemas.openxmlformats.org/drawingml/2006/main">
               <a:ext uri="{FF2B5EF4-FFF2-40B4-BE49-F238E27FC236}">
-                <a16:creationId xmlns:a16="http://schemas.microsoft.com/office/drawing/2014/main" id="{657B4010-736A-4865-93F4-F645047AF7FE}"/>
+                <a16:creationId xmlns:a16="http://schemas.microsoft.com/office/drawing/2014/main" id="{6F70B1E1-E4FF-43C9-ADDA-AB9698969B2B}"/>
               </a:ext>
             </a:extLst>
           </p:cNvPr>
@@ -6353,7 +6353,7 @@
           <p:cNvPr id="11" name="">
             <a:extLst xmlns:a="http://schemas.openxmlformats.org/drawingml/2006/main">
               <a:ext uri="{FF2B5EF4-FFF2-40B4-BE49-F238E27FC236}">
-                <a16:creationId xmlns:a16="http://schemas.microsoft.com/office/drawing/2014/main" id="{B7CD7367-964F-4105-870D-3888D8C6828F}"/>
+                <a16:creationId xmlns:a16="http://schemas.microsoft.com/office/drawing/2014/main" id="{9C4F5576-DD32-4484-A795-136D4224FBBF}"/>
               </a:ext>
             </a:extLst>
           </p:cNvPr>
@@ -6516,7 +6516,7 @@
           <p:cNvPr id="12" name="">
             <a:extLst xmlns:a="http://schemas.openxmlformats.org/drawingml/2006/main">
               <a:ext uri="{FF2B5EF4-FFF2-40B4-BE49-F238E27FC236}">
-                <a16:creationId xmlns:a16="http://schemas.microsoft.com/office/drawing/2014/main" id="{393F8F80-F9CD-4C0A-BE7D-5ED65AA760E4}"/>
+                <a16:creationId xmlns:a16="http://schemas.microsoft.com/office/drawing/2014/main" id="{73274D9F-65F0-4C09-ACF4-FAE06ACBE0A8}"/>
               </a:ext>
             </a:extLst>
           </p:cNvPr>
@@ -6679,7 +6679,7 @@
           <p:cNvPr id="13" name="">
             <a:extLst xmlns:a="http://schemas.openxmlformats.org/drawingml/2006/main">
               <a:ext uri="{FF2B5EF4-FFF2-40B4-BE49-F238E27FC236}">
-                <a16:creationId xmlns:a16="http://schemas.microsoft.com/office/drawing/2014/main" id="{8DE0A1FC-EFEC-41D3-ACF5-B85CCC507EF7}"/>
+                <a16:creationId xmlns:a16="http://schemas.microsoft.com/office/drawing/2014/main" id="{9E76BD70-E82D-48CD-B6A1-F8B678DE4EFF}"/>
               </a:ext>
             </a:extLst>
           </p:cNvPr>
@@ -6712,7 +6712,7 @@
           <p:cNvPr id="14" name="">
             <a:extLst xmlns:a="http://schemas.openxmlformats.org/drawingml/2006/main">
               <a:ext uri="{FF2B5EF4-FFF2-40B4-BE49-F238E27FC236}">
-                <a16:creationId xmlns:a16="http://schemas.microsoft.com/office/drawing/2014/main" id="{843FB565-D5A6-4409-A3ED-D4BDE7C7A864}"/>
+                <a16:creationId xmlns:a16="http://schemas.microsoft.com/office/drawing/2014/main" id="{AE2B42C1-38B5-4811-9249-BDE83119E833}"/>
               </a:ext>
             </a:extLst>
           </p:cNvPr>
@@ -6875,7 +6875,7 @@
           <p:cNvPr id="15" name="">
             <a:extLst xmlns:a="http://schemas.openxmlformats.org/drawingml/2006/main">
               <a:ext uri="{FF2B5EF4-FFF2-40B4-BE49-F238E27FC236}">
-                <a16:creationId xmlns:a16="http://schemas.microsoft.com/office/drawing/2014/main" id="{4798C2C1-C1B9-44BB-8781-592250E6B213}"/>
+                <a16:creationId xmlns:a16="http://schemas.microsoft.com/office/drawing/2014/main" id="{957B2752-FBE4-4B9B-90B4-FDAFCA424CF8}"/>
               </a:ext>
             </a:extLst>
           </p:cNvPr>
@@ -7038,7 +7038,7 @@
           <p:cNvPr id="16" name="">
             <a:extLst xmlns:a="http://schemas.openxmlformats.org/drawingml/2006/main">
               <a:ext uri="{FF2B5EF4-FFF2-40B4-BE49-F238E27FC236}">
-                <a16:creationId xmlns:a16="http://schemas.microsoft.com/office/drawing/2014/main" id="{A21D7EC3-E3B3-4958-AB28-4D6CE9896F77}"/>
+                <a16:creationId xmlns:a16="http://schemas.microsoft.com/office/drawing/2014/main" id="{07366B94-3621-429A-8284-CFB0036CBFC1}"/>
               </a:ext>
             </a:extLst>
           </p:cNvPr>
@@ -7071,7 +7071,7 @@
           <p:cNvPr id="17" name="">
             <a:extLst xmlns:a="http://schemas.openxmlformats.org/drawingml/2006/main">
               <a:ext uri="{FF2B5EF4-FFF2-40B4-BE49-F238E27FC236}">
-                <a16:creationId xmlns:a16="http://schemas.microsoft.com/office/drawing/2014/main" id="{C39BAD57-7A08-43AF-8AE4-56E3C1D68545}"/>
+                <a16:creationId xmlns:a16="http://schemas.microsoft.com/office/drawing/2014/main" id="{D226E60B-5210-44CC-960E-380F63BA1FD9}"/>
               </a:ext>
             </a:extLst>
           </p:cNvPr>
@@ -7234,7 +7234,7 @@
           <p:cNvPr id="18" name="">
             <a:extLst xmlns:a="http://schemas.openxmlformats.org/drawingml/2006/main">
               <a:ext uri="{FF2B5EF4-FFF2-40B4-BE49-F238E27FC236}">
-                <a16:creationId xmlns:a16="http://schemas.microsoft.com/office/drawing/2014/main" id="{26A927BB-5DEE-48DE-A5D7-A7CCDABF34CB}"/>
+                <a16:creationId xmlns:a16="http://schemas.microsoft.com/office/drawing/2014/main" id="{A08DE946-8F1B-4AC8-AE54-E636B0326E4E}"/>
               </a:ext>
             </a:extLst>
           </p:cNvPr>
@@ -7397,7 +7397,7 @@
           <p:cNvPr id="19" name="">
             <a:extLst xmlns:a="http://schemas.openxmlformats.org/drawingml/2006/main">
               <a:ext uri="{FF2B5EF4-FFF2-40B4-BE49-F238E27FC236}">
-                <a16:creationId xmlns:a16="http://schemas.microsoft.com/office/drawing/2014/main" id="{05EA9646-2BA6-4FC3-A27C-B83818973A47}"/>
+                <a16:creationId xmlns:a16="http://schemas.microsoft.com/office/drawing/2014/main" id="{9BE1182F-0883-40CC-945E-E9B6F9FC6F2E}"/>
               </a:ext>
             </a:extLst>
           </p:cNvPr>
@@ -7432,7 +7432,7 @@
           <p:cNvPr id="20" name="">
             <a:extLst xmlns:a="http://schemas.openxmlformats.org/drawingml/2006/main">
               <a:ext uri="{FF2B5EF4-FFF2-40B4-BE49-F238E27FC236}">
-                <a16:creationId xmlns:a16="http://schemas.microsoft.com/office/drawing/2014/main" id="{BADE899C-FBBB-4818-AE9D-A8E75A65F5F4}"/>
+                <a16:creationId xmlns:a16="http://schemas.microsoft.com/office/drawing/2014/main" id="{9BBF888B-B1D2-45AA-A814-8945F4D6410E}"/>
               </a:ext>
             </a:extLst>
           </p:cNvPr>
@@ -7595,7 +7595,7 @@
           <p:cNvPr id="21" name="">
             <a:extLst xmlns:a="http://schemas.openxmlformats.org/drawingml/2006/main">
               <a:ext uri="{FF2B5EF4-FFF2-40B4-BE49-F238E27FC236}">
-                <a16:creationId xmlns:a16="http://schemas.microsoft.com/office/drawing/2014/main" id="{B0DFA741-D112-4569-92F9-67BD028D693A}"/>
+                <a16:creationId xmlns:a16="http://schemas.microsoft.com/office/drawing/2014/main" id="{256315EC-E389-4D1D-A821-27ACA7E1D973}"/>
               </a:ext>
             </a:extLst>
           </p:cNvPr>
@@ -7758,7 +7758,7 @@
           <p:cNvPr id="22" name="">
             <a:extLst xmlns:a="http://schemas.openxmlformats.org/drawingml/2006/main">
               <a:ext uri="{FF2B5EF4-FFF2-40B4-BE49-F238E27FC236}">
-                <a16:creationId xmlns:a16="http://schemas.microsoft.com/office/drawing/2014/main" id="{D26BFA01-02B6-4947-B509-AEDF9C0668CD}"/>
+                <a16:creationId xmlns:a16="http://schemas.microsoft.com/office/drawing/2014/main" id="{2FC70669-769E-444F-86D7-DD165C16CCA3}"/>
               </a:ext>
             </a:extLst>
           </p:cNvPr>
@@ -7793,7 +7793,7 @@
           <p:cNvPr id="23" name="">
             <a:extLst xmlns:a="http://schemas.openxmlformats.org/drawingml/2006/main">
               <a:ext uri="{FF2B5EF4-FFF2-40B4-BE49-F238E27FC236}">
-                <a16:creationId xmlns:a16="http://schemas.microsoft.com/office/drawing/2014/main" id="{43E0EB3E-A045-4113-A5AD-B9E28A4876A8}"/>
+                <a16:creationId xmlns:a16="http://schemas.microsoft.com/office/drawing/2014/main" id="{DF973FC0-44C5-493B-83EC-59455D7B8956}"/>
               </a:ext>
             </a:extLst>
           </p:cNvPr>
@@ -7956,7 +7956,7 @@
           <p:cNvPr id="24" name="">
             <a:extLst xmlns:a="http://schemas.openxmlformats.org/drawingml/2006/main">
               <a:ext uri="{FF2B5EF4-FFF2-40B4-BE49-F238E27FC236}">
-                <a16:creationId xmlns:a16="http://schemas.microsoft.com/office/drawing/2014/main" id="{9C1A4D3E-DDE7-4419-864B-990E7C69C799}"/>
+                <a16:creationId xmlns:a16="http://schemas.microsoft.com/office/drawing/2014/main" id="{35DD4E91-FF9A-4C8F-A544-CD391EB16D96}"/>
               </a:ext>
             </a:extLst>
           </p:cNvPr>
@@ -8119,7 +8119,7 @@
           <p:cNvPr id="25" name="">
             <a:extLst xmlns:a="http://schemas.openxmlformats.org/drawingml/2006/main">
               <a:ext uri="{FF2B5EF4-FFF2-40B4-BE49-F238E27FC236}">
-                <a16:creationId xmlns:a16="http://schemas.microsoft.com/office/drawing/2014/main" id="{1A160652-1820-41C6-9102-B06B5AA9781E}"/>
+                <a16:creationId xmlns:a16="http://schemas.microsoft.com/office/drawing/2014/main" id="{ADD886D3-1726-4BAE-8A13-A364B75AF8F0}"/>
               </a:ext>
             </a:extLst>
           </p:cNvPr>
@@ -8154,7 +8154,7 @@
           <p:cNvPr id="26" name="">
             <a:extLst xmlns:a="http://schemas.openxmlformats.org/drawingml/2006/main">
               <a:ext uri="{FF2B5EF4-FFF2-40B4-BE49-F238E27FC236}">
-                <a16:creationId xmlns:a16="http://schemas.microsoft.com/office/drawing/2014/main" id="{75889EFF-20BE-4E28-A19C-FF1BC2F72F48}"/>
+                <a16:creationId xmlns:a16="http://schemas.microsoft.com/office/drawing/2014/main" id="{90035769-E036-4042-B89B-63432102907E}"/>
               </a:ext>
             </a:extLst>
           </p:cNvPr>
@@ -8317,7 +8317,7 @@
           <p:cNvPr id="27" name="">
             <a:extLst xmlns:a="http://schemas.openxmlformats.org/drawingml/2006/main">
               <a:ext uri="{FF2B5EF4-FFF2-40B4-BE49-F238E27FC236}">
-                <a16:creationId xmlns:a16="http://schemas.microsoft.com/office/drawing/2014/main" id="{0416C7FD-C431-479E-A8CC-12B13667CFCA}"/>
+                <a16:creationId xmlns:a16="http://schemas.microsoft.com/office/drawing/2014/main" id="{8283B4AA-5189-4ABC-A1FD-33F89FD26476}"/>
               </a:ext>
             </a:extLst>
           </p:cNvPr>
@@ -8480,7 +8480,7 @@
           <p:cNvPr id="30" name="">
             <a:extLst xmlns:a="http://schemas.openxmlformats.org/drawingml/2006/main">
               <a:ext uri="{FF2B5EF4-FFF2-40B4-BE49-F238E27FC236}">
-                <a16:creationId xmlns:a16="http://schemas.microsoft.com/office/drawing/2014/main" id="{E54B2135-C217-48AB-A3EF-36C522DD70C7}"/>
+                <a16:creationId xmlns:a16="http://schemas.microsoft.com/office/drawing/2014/main" id="{255B3581-F099-4DF2-A4D2-CE4FF850639E}"/>
               </a:ext>
             </a:extLst>
           </p:cNvPr>
@@ -8513,7 +8513,7 @@
           <p:cNvPr id="31" name="">
             <a:extLst xmlns:a="http://schemas.openxmlformats.org/drawingml/2006/main">
               <a:ext uri="{FF2B5EF4-FFF2-40B4-BE49-F238E27FC236}">
-                <a16:creationId xmlns:a16="http://schemas.microsoft.com/office/drawing/2014/main" id="{BB6A9847-9B48-45C6-8A12-5E1E14AB0871}"/>
+                <a16:creationId xmlns:a16="http://schemas.microsoft.com/office/drawing/2014/main" id="{BA5442CD-0F02-4EC7-85B0-64E3C3424C8F}"/>
               </a:ext>
             </a:extLst>
           </p:cNvPr>
@@ -8676,7 +8676,7 @@
           <p:cNvPr id="32" name="">
             <a:extLst xmlns:a="http://schemas.openxmlformats.org/drawingml/2006/main">
               <a:ext uri="{FF2B5EF4-FFF2-40B4-BE49-F238E27FC236}">
-                <a16:creationId xmlns:a16="http://schemas.microsoft.com/office/drawing/2014/main" id="{B40E6C20-F633-4CDE-B95F-7110C8E42E1B}"/>
+                <a16:creationId xmlns:a16="http://schemas.microsoft.com/office/drawing/2014/main" id="{20984D5E-5989-44C7-A842-DE1BE8A6DBEC}"/>
               </a:ext>
             </a:extLst>
           </p:cNvPr>
@@ -8709,7 +8709,7 @@
           <p:cNvPr id="33" name="">
             <a:extLst xmlns:a="http://schemas.openxmlformats.org/drawingml/2006/main">
               <a:ext uri="{FF2B5EF4-FFF2-40B4-BE49-F238E27FC236}">
-                <a16:creationId xmlns:a16="http://schemas.microsoft.com/office/drawing/2014/main" id="{F90FCC0F-B6A9-4F56-8275-23187DA157CF}"/>
+                <a16:creationId xmlns:a16="http://schemas.microsoft.com/office/drawing/2014/main" id="{5E4F5F84-D1A5-4D3B-A2AC-7BBA56AEA519}"/>
               </a:ext>
             </a:extLst>
           </p:cNvPr>
@@ -8872,7 +8872,7 @@
           <p:cNvPr id="34" name="">
             <a:extLst xmlns:a="http://schemas.openxmlformats.org/drawingml/2006/main">
               <a:ext uri="{FF2B5EF4-FFF2-40B4-BE49-F238E27FC236}">
-                <a16:creationId xmlns:a16="http://schemas.microsoft.com/office/drawing/2014/main" id="{DAA72FC1-B248-4EBC-9BA1-490D6DE4FB12}"/>
+                <a16:creationId xmlns:a16="http://schemas.microsoft.com/office/drawing/2014/main" id="{484EFC64-3898-438C-84E5-04B9A5A1E378}"/>
               </a:ext>
             </a:extLst>
           </p:cNvPr>
@@ -9035,7 +9035,7 @@
           <p:cNvPr id="35" name="">
             <a:extLst xmlns:a="http://schemas.openxmlformats.org/drawingml/2006/main">
               <a:ext uri="{FF2B5EF4-FFF2-40B4-BE49-F238E27FC236}">
-                <a16:creationId xmlns:a16="http://schemas.microsoft.com/office/drawing/2014/main" id="{5C7B3BBD-219C-4A96-BFCB-860E78330012}"/>
+                <a16:creationId xmlns:a16="http://schemas.microsoft.com/office/drawing/2014/main" id="{55E97283-E387-4B49-8B94-5F13BF8B42D2}"/>
               </a:ext>
             </a:extLst>
           </p:cNvPr>
@@ -9196,7 +9196,7 @@
     </p:spTree>
     <p:extLst>
       <p:ext uri="{BB962C8B-B14F-4D97-AF65-F5344CB8AC3E}">
-        <p14:creationId xmlns:p14="http://schemas.microsoft.com/office/powerpoint/2010/main" val="89248029"/>
+        <p14:creationId xmlns:p14="http://schemas.microsoft.com/office/powerpoint/2010/main" val="204449391"/>
       </p:ext>
     </p:extLst>
   </p:cSld>
@@ -9227,7 +9227,7 @@
           <p:cNvPr id="24" name="">
             <a:extLst xmlns:a="http://schemas.openxmlformats.org/drawingml/2006/main">
               <a:ext uri="{FF2B5EF4-FFF2-40B4-BE49-F238E27FC236}">
-                <a16:creationId xmlns:a16="http://schemas.microsoft.com/office/drawing/2014/main" id="{12D7BA02-813C-426B-9BA3-E38B12B4849F}"/>
+                <a16:creationId xmlns:a16="http://schemas.microsoft.com/office/drawing/2014/main" id="{3E3E2732-567C-4770-9913-B8FA6BD0E8D5}"/>
               </a:ext>
             </a:extLst>
           </p:cNvPr>
@@ -9259,7 +9259,7 @@
           <p:cNvPr id="23" name="">
             <a:extLst xmlns:a="http://schemas.openxmlformats.org/drawingml/2006/main">
               <a:ext uri="{FF2B5EF4-FFF2-40B4-BE49-F238E27FC236}">
-                <a16:creationId xmlns:a16="http://schemas.microsoft.com/office/drawing/2014/main" id="{75C0877D-4889-409F-8904-8DDB6F94A238}"/>
+                <a16:creationId xmlns:a16="http://schemas.microsoft.com/office/drawing/2014/main" id="{DAE5F4A4-7ABC-4709-839F-112715BAA4D8}"/>
               </a:ext>
             </a:extLst>
           </p:cNvPr>
@@ -9291,7 +9291,7 @@
           <p:cNvPr id="22" name="">
             <a:extLst xmlns:a="http://schemas.openxmlformats.org/drawingml/2006/main">
               <a:ext uri="{FF2B5EF4-FFF2-40B4-BE49-F238E27FC236}">
-                <a16:creationId xmlns:a16="http://schemas.microsoft.com/office/drawing/2014/main" id="{D4D774DE-CCEA-41ED-BB2D-53B1D4CEA9B5}"/>
+                <a16:creationId xmlns:a16="http://schemas.microsoft.com/office/drawing/2014/main" id="{D9ADD5FC-627E-4046-8969-F29C00C4DB46}"/>
               </a:ext>
             </a:extLst>
           </p:cNvPr>
@@ -9323,7 +9323,7 @@
           <p:cNvPr id="28" name="">
             <a:extLst xmlns:a="http://schemas.openxmlformats.org/drawingml/2006/main">
               <a:ext uri="{FF2B5EF4-FFF2-40B4-BE49-F238E27FC236}">
-                <a16:creationId xmlns:a16="http://schemas.microsoft.com/office/drawing/2014/main" id="{48F03936-DC3F-438C-AEF0-7FF0925EA460}"/>
+                <a16:creationId xmlns:a16="http://schemas.microsoft.com/office/drawing/2014/main" id="{E0AF72F3-4937-439C-817A-6D6101CEBE60}"/>
               </a:ext>
             </a:extLst>
           </p:cNvPr>
@@ -9486,7 +9486,7 @@
           <p:cNvPr id="2" name="">
             <a:extLst xmlns:a="http://schemas.openxmlformats.org/drawingml/2006/main">
               <a:ext uri="{FF2B5EF4-FFF2-40B4-BE49-F238E27FC236}">
-                <a16:creationId xmlns:a16="http://schemas.microsoft.com/office/drawing/2014/main" id="{1967192F-6EF8-4FA8-BBCC-DFACA7AD64B8}"/>
+                <a16:creationId xmlns:a16="http://schemas.microsoft.com/office/drawing/2014/main" id="{4578794D-68EA-4EE8-A2B8-A3D9316C2A26}"/>
               </a:ext>
             </a:extLst>
           </p:cNvPr>
@@ -9649,7 +9649,7 @@
           <p:cNvPr id="3" name="">
             <a:extLst xmlns:a="http://schemas.openxmlformats.org/drawingml/2006/main">
               <a:ext uri="{FF2B5EF4-FFF2-40B4-BE49-F238E27FC236}">
-                <a16:creationId xmlns:a16="http://schemas.microsoft.com/office/drawing/2014/main" id="{271C4DF0-46BC-4CAB-AF28-9B450CB7E7A2}"/>
+                <a16:creationId xmlns:a16="http://schemas.microsoft.com/office/drawing/2014/main" id="{D851BF6C-73FC-4295-8B7D-523A823B08DE}"/>
               </a:ext>
             </a:extLst>
           </p:cNvPr>
@@ -9812,7 +9812,7 @@
           <p:cNvPr id="4" name="">
             <a:extLst xmlns:a="http://schemas.openxmlformats.org/drawingml/2006/main">
               <a:ext uri="{FF2B5EF4-FFF2-40B4-BE49-F238E27FC236}">
-                <a16:creationId xmlns:a16="http://schemas.microsoft.com/office/drawing/2014/main" id="{CFA82612-4A16-4128-9AB7-CC59899EDC01}"/>
+                <a16:creationId xmlns:a16="http://schemas.microsoft.com/office/drawing/2014/main" id="{98ADF1F7-7C00-4A1A-B035-8A518E79CB42}"/>
               </a:ext>
             </a:extLst>
           </p:cNvPr>
@@ -9975,7 +9975,7 @@
           <p:cNvPr id="5" name="">
             <a:extLst xmlns:a="http://schemas.openxmlformats.org/drawingml/2006/main">
               <a:ext uri="{FF2B5EF4-FFF2-40B4-BE49-F238E27FC236}">
-                <a16:creationId xmlns:a16="http://schemas.microsoft.com/office/drawing/2014/main" id="{E2698549-6CAF-423D-8795-6D78ADF528D2}"/>
+                <a16:creationId xmlns:a16="http://schemas.microsoft.com/office/drawing/2014/main" id="{C40E5CAD-7C0F-480E-9F4A-DA14446B509A}"/>
               </a:ext>
             </a:extLst>
           </p:cNvPr>
@@ -10138,7 +10138,7 @@
           <p:cNvPr id="6" name="">
             <a:extLst xmlns:a="http://schemas.openxmlformats.org/drawingml/2006/main">
               <a:ext uri="{FF2B5EF4-FFF2-40B4-BE49-F238E27FC236}">
-                <a16:creationId xmlns:a16="http://schemas.microsoft.com/office/drawing/2014/main" id="{8DD50C52-9554-4F8A-8346-A5F8C34A2A63}"/>
+                <a16:creationId xmlns:a16="http://schemas.microsoft.com/office/drawing/2014/main" id="{772F2EC5-D8C3-48F7-981B-49B8BA0A2078}"/>
               </a:ext>
             </a:extLst>
           </p:cNvPr>
@@ -10301,7 +10301,7 @@
           <p:cNvPr id="7" name="">
             <a:extLst xmlns:a="http://schemas.openxmlformats.org/drawingml/2006/main">
               <a:ext uri="{FF2B5EF4-FFF2-40B4-BE49-F238E27FC236}">
-                <a16:creationId xmlns:a16="http://schemas.microsoft.com/office/drawing/2014/main" id="{7C58AE52-B920-445D-8AA4-07972F78E14E}"/>
+                <a16:creationId xmlns:a16="http://schemas.microsoft.com/office/drawing/2014/main" id="{2B2C2532-AA3A-4CB0-B6A8-41AC6FD79108}"/>
               </a:ext>
             </a:extLst>
           </p:cNvPr>
@@ -10464,7 +10464,7 @@
           <p:cNvPr id="8" name="">
             <a:extLst xmlns:a="http://schemas.openxmlformats.org/drawingml/2006/main">
               <a:ext uri="{FF2B5EF4-FFF2-40B4-BE49-F238E27FC236}">
-                <a16:creationId xmlns:a16="http://schemas.microsoft.com/office/drawing/2014/main" id="{0B3729D2-2386-47B5-BD54-A4397FC6CB03}"/>
+                <a16:creationId xmlns:a16="http://schemas.microsoft.com/office/drawing/2014/main" id="{44B94821-B92A-402B-9439-1798C143B998}"/>
               </a:ext>
             </a:extLst>
           </p:cNvPr>
@@ -10627,7 +10627,7 @@
           <p:cNvPr id="9" name="">
             <a:extLst xmlns:a="http://schemas.openxmlformats.org/drawingml/2006/main">
               <a:ext uri="{FF2B5EF4-FFF2-40B4-BE49-F238E27FC236}">
-                <a16:creationId xmlns:a16="http://schemas.microsoft.com/office/drawing/2014/main" id="{5C258F40-66FB-483E-8C0C-851363DA2430}"/>
+                <a16:creationId xmlns:a16="http://schemas.microsoft.com/office/drawing/2014/main" id="{86E4F560-CBDA-4D57-AD00-7A3D8B62DDE1}"/>
               </a:ext>
             </a:extLst>
           </p:cNvPr>
@@ -10790,7 +10790,7 @@
           <p:cNvPr id="10" name="">
             <a:extLst xmlns:a="http://schemas.openxmlformats.org/drawingml/2006/main">
               <a:ext uri="{FF2B5EF4-FFF2-40B4-BE49-F238E27FC236}">
-                <a16:creationId xmlns:a16="http://schemas.microsoft.com/office/drawing/2014/main" id="{D9203AAD-3DC6-4D20-AD23-196F081DAE83}"/>
+                <a16:creationId xmlns:a16="http://schemas.microsoft.com/office/drawing/2014/main" id="{D0C3C103-60AF-4F98-9EA9-53A092269C88}"/>
               </a:ext>
             </a:extLst>
           </p:cNvPr>
@@ -10825,7 +10825,7 @@
           <p:cNvPr id="11" name="">
             <a:extLst xmlns:a="http://schemas.openxmlformats.org/drawingml/2006/main">
               <a:ext uri="{FF2B5EF4-FFF2-40B4-BE49-F238E27FC236}">
-                <a16:creationId xmlns:a16="http://schemas.microsoft.com/office/drawing/2014/main" id="{17461397-6C88-47AE-962A-C03C6F0D9A99}"/>
+                <a16:creationId xmlns:a16="http://schemas.microsoft.com/office/drawing/2014/main" id="{801F214E-37AE-4E48-9BE9-76C87482EA58}"/>
               </a:ext>
             </a:extLst>
           </p:cNvPr>
@@ -10988,7 +10988,7 @@
           <p:cNvPr id="12" name="">
             <a:extLst xmlns:a="http://schemas.openxmlformats.org/drawingml/2006/main">
               <a:ext uri="{FF2B5EF4-FFF2-40B4-BE49-F238E27FC236}">
-                <a16:creationId xmlns:a16="http://schemas.microsoft.com/office/drawing/2014/main" id="{1A92A0D5-6EF2-488E-A97F-E4105FF82F82}"/>
+                <a16:creationId xmlns:a16="http://schemas.microsoft.com/office/drawing/2014/main" id="{7A29B443-AA3F-4E18-BB47-D7EE1BC5B4C3}"/>
               </a:ext>
             </a:extLst>
           </p:cNvPr>
@@ -11151,7 +11151,7 @@
           <p:cNvPr id="13" name="">
             <a:extLst xmlns:a="http://schemas.openxmlformats.org/drawingml/2006/main">
               <a:ext uri="{FF2B5EF4-FFF2-40B4-BE49-F238E27FC236}">
-                <a16:creationId xmlns:a16="http://schemas.microsoft.com/office/drawing/2014/main" id="{1C6118AE-3AC3-4852-9375-3201FD47ECBC}"/>
+                <a16:creationId xmlns:a16="http://schemas.microsoft.com/office/drawing/2014/main" id="{9908A3C0-D7D4-45D2-BFF1-28D0A25BFC03}"/>
               </a:ext>
             </a:extLst>
           </p:cNvPr>
@@ -11186,7 +11186,7 @@
           <p:cNvPr id="14" name="">
             <a:extLst xmlns:a="http://schemas.openxmlformats.org/drawingml/2006/main">
               <a:ext uri="{FF2B5EF4-FFF2-40B4-BE49-F238E27FC236}">
-                <a16:creationId xmlns:a16="http://schemas.microsoft.com/office/drawing/2014/main" id="{EB8F9EC1-0692-4780-9A0A-881F1095195B}"/>
+                <a16:creationId xmlns:a16="http://schemas.microsoft.com/office/drawing/2014/main" id="{431F72E1-BBED-41B9-9F1E-10910D64E461}"/>
               </a:ext>
             </a:extLst>
           </p:cNvPr>
@@ -11349,7 +11349,7 @@
           <p:cNvPr id="15" name="">
             <a:extLst xmlns:a="http://schemas.openxmlformats.org/drawingml/2006/main">
               <a:ext uri="{FF2B5EF4-FFF2-40B4-BE49-F238E27FC236}">
-                <a16:creationId xmlns:a16="http://schemas.microsoft.com/office/drawing/2014/main" id="{6C29C04E-0337-40CB-B4A0-57A476C66E89}"/>
+                <a16:creationId xmlns:a16="http://schemas.microsoft.com/office/drawing/2014/main" id="{9F543161-F69C-4AE6-A903-EDBEE4A23381}"/>
               </a:ext>
             </a:extLst>
           </p:cNvPr>
@@ -11512,7 +11512,7 @@
           <p:cNvPr id="16" name="">
             <a:extLst xmlns:a="http://schemas.openxmlformats.org/drawingml/2006/main">
               <a:ext uri="{FF2B5EF4-FFF2-40B4-BE49-F238E27FC236}">
-                <a16:creationId xmlns:a16="http://schemas.microsoft.com/office/drawing/2014/main" id="{68716E4D-7F1E-4DAC-B721-A2C160390511}"/>
+                <a16:creationId xmlns:a16="http://schemas.microsoft.com/office/drawing/2014/main" id="{11742661-F734-41B6-A11E-AF89E75AA9C9}"/>
               </a:ext>
             </a:extLst>
           </p:cNvPr>
@@ -11547,7 +11547,7 @@
           <p:cNvPr id="17" name="">
             <a:extLst xmlns:a="http://schemas.openxmlformats.org/drawingml/2006/main">
               <a:ext uri="{FF2B5EF4-FFF2-40B4-BE49-F238E27FC236}">
-                <a16:creationId xmlns:a16="http://schemas.microsoft.com/office/drawing/2014/main" id="{F3366902-E6E7-4D5D-8412-52FA262E7AD7}"/>
+                <a16:creationId xmlns:a16="http://schemas.microsoft.com/office/drawing/2014/main" id="{84D6C7E8-6C1A-472F-ABC4-6AB88486CDDB}"/>
               </a:ext>
             </a:extLst>
           </p:cNvPr>
@@ -11710,7 +11710,7 @@
           <p:cNvPr id="18" name="">
             <a:extLst xmlns:a="http://schemas.openxmlformats.org/drawingml/2006/main">
               <a:ext uri="{FF2B5EF4-FFF2-40B4-BE49-F238E27FC236}">
-                <a16:creationId xmlns:a16="http://schemas.microsoft.com/office/drawing/2014/main" id="{DB0027BC-FC3E-439D-88CC-0E8AC0643DE8}"/>
+                <a16:creationId xmlns:a16="http://schemas.microsoft.com/office/drawing/2014/main" id="{BDD4041E-8675-4B60-9502-B1478D80D3B6}"/>
               </a:ext>
             </a:extLst>
           </p:cNvPr>
@@ -11873,7 +11873,7 @@
           <p:cNvPr id="19" name="">
             <a:extLst xmlns:a="http://schemas.openxmlformats.org/drawingml/2006/main">
               <a:ext uri="{FF2B5EF4-FFF2-40B4-BE49-F238E27FC236}">
-                <a16:creationId xmlns:a16="http://schemas.microsoft.com/office/drawing/2014/main" id="{56910E0F-19EB-42F3-8B3A-798AD69C6BF4}"/>
+                <a16:creationId xmlns:a16="http://schemas.microsoft.com/office/drawing/2014/main" id="{8420F111-85D9-4AEB-AD2C-E85C80DFBF75}"/>
               </a:ext>
             </a:extLst>
           </p:cNvPr>
@@ -11908,7 +11908,7 @@
           <p:cNvPr id="20" name="">
             <a:extLst xmlns:a="http://schemas.openxmlformats.org/drawingml/2006/main">
               <a:ext uri="{FF2B5EF4-FFF2-40B4-BE49-F238E27FC236}">
-                <a16:creationId xmlns:a16="http://schemas.microsoft.com/office/drawing/2014/main" id="{A960A3CD-D394-46C9-99F1-2696B007D7B3}"/>
+                <a16:creationId xmlns:a16="http://schemas.microsoft.com/office/drawing/2014/main" id="{2522A159-1C2D-4F86-94D0-02E818D2577E}"/>
               </a:ext>
             </a:extLst>
           </p:cNvPr>
@@ -12071,7 +12071,7 @@
           <p:cNvPr id="21" name="">
             <a:extLst xmlns:a="http://schemas.openxmlformats.org/drawingml/2006/main">
               <a:ext uri="{FF2B5EF4-FFF2-40B4-BE49-F238E27FC236}">
-                <a16:creationId xmlns:a16="http://schemas.microsoft.com/office/drawing/2014/main" id="{5C7FCD89-CA79-43BE-95D6-9B7EA6ACEFB9}"/>
+                <a16:creationId xmlns:a16="http://schemas.microsoft.com/office/drawing/2014/main" id="{B946DBF9-0579-43D6-9C9C-8DD9E42B031F}"/>
               </a:ext>
             </a:extLst>
           </p:cNvPr>
@@ -12234,7 +12234,7 @@
           <p:cNvPr id="25" name="">
             <a:extLst xmlns:a="http://schemas.openxmlformats.org/drawingml/2006/main">
               <a:ext uri="{FF2B5EF4-FFF2-40B4-BE49-F238E27FC236}">
-                <a16:creationId xmlns:a16="http://schemas.microsoft.com/office/drawing/2014/main" id="{E1195FB5-B7B9-4C18-B213-87056F403D6F}"/>
+                <a16:creationId xmlns:a16="http://schemas.microsoft.com/office/drawing/2014/main" id="{010C1F4B-4BD5-41C7-A83D-9286546CF333}"/>
               </a:ext>
             </a:extLst>
           </p:cNvPr>
@@ -12397,7 +12397,7 @@
           <p:cNvPr id="26" name="">
             <a:extLst xmlns:a="http://schemas.openxmlformats.org/drawingml/2006/main">
               <a:ext uri="{FF2B5EF4-FFF2-40B4-BE49-F238E27FC236}">
-                <a16:creationId xmlns:a16="http://schemas.microsoft.com/office/drawing/2014/main" id="{DF38857E-DA2F-4B04-85DB-CE85C55F6A99}"/>
+                <a16:creationId xmlns:a16="http://schemas.microsoft.com/office/drawing/2014/main" id="{700A504B-AAA7-40B2-9A0D-C796F15164F3}"/>
               </a:ext>
             </a:extLst>
           </p:cNvPr>
@@ -12560,7 +12560,7 @@
           <p:cNvPr id="27" name="">
             <a:extLst xmlns:a="http://schemas.openxmlformats.org/drawingml/2006/main">
               <a:ext uri="{FF2B5EF4-FFF2-40B4-BE49-F238E27FC236}">
-                <a16:creationId xmlns:a16="http://schemas.microsoft.com/office/drawing/2014/main" id="{12A7D5ED-B5B5-4DDA-8ABB-B4D15AF40D61}"/>
+                <a16:creationId xmlns:a16="http://schemas.microsoft.com/office/drawing/2014/main" id="{0C7FFF05-9358-43C5-9F1E-38E49B8D2B03}"/>
               </a:ext>
             </a:extLst>
           </p:cNvPr>
@@ -12721,7 +12721,7 @@
     </p:spTree>
     <p:extLst>
       <p:ext uri="{BB962C8B-B14F-4D97-AF65-F5344CB8AC3E}">
-        <p14:creationId xmlns:p14="http://schemas.microsoft.com/office/powerpoint/2010/main" val="904619594"/>
+        <p14:creationId xmlns:p14="http://schemas.microsoft.com/office/powerpoint/2010/main" val="1399814575"/>
       </p:ext>
     </p:extLst>
   </p:cSld>
@@ -12752,7 +12752,7 @@
           <p:cNvPr id="18" name="">
             <a:extLst xmlns:a="http://schemas.openxmlformats.org/drawingml/2006/main">
               <a:ext uri="{FF2B5EF4-FFF2-40B4-BE49-F238E27FC236}">
-                <a16:creationId xmlns:a16="http://schemas.microsoft.com/office/drawing/2014/main" id="{A33D24C5-29D8-48B5-95C2-5E62AAC29BAA}"/>
+                <a16:creationId xmlns:a16="http://schemas.microsoft.com/office/drawing/2014/main" id="{3040E921-63DF-4CCE-A332-2AACB67364D9}"/>
               </a:ext>
             </a:extLst>
           </p:cNvPr>
@@ -12784,7 +12784,7 @@
           <p:cNvPr id="17" name="">
             <a:extLst xmlns:a="http://schemas.openxmlformats.org/drawingml/2006/main">
               <a:ext uri="{FF2B5EF4-FFF2-40B4-BE49-F238E27FC236}">
-                <a16:creationId xmlns:a16="http://schemas.microsoft.com/office/drawing/2014/main" id="{F6C7C1FF-467B-405E-8131-A16BA2F8A91D}"/>
+                <a16:creationId xmlns:a16="http://schemas.microsoft.com/office/drawing/2014/main" id="{208AAE9A-3292-4D4D-9D14-DCA69154E206}"/>
               </a:ext>
             </a:extLst>
           </p:cNvPr>
@@ -12816,7 +12816,7 @@
           <p:cNvPr id="16" name="">
             <a:extLst xmlns:a="http://schemas.openxmlformats.org/drawingml/2006/main">
               <a:ext uri="{FF2B5EF4-FFF2-40B4-BE49-F238E27FC236}">
-                <a16:creationId xmlns:a16="http://schemas.microsoft.com/office/drawing/2014/main" id="{C6551460-E427-47E8-941E-95788ACEB177}"/>
+                <a16:creationId xmlns:a16="http://schemas.microsoft.com/office/drawing/2014/main" id="{E0F5920B-44F5-4C5B-8234-70BA3008A39F}"/>
               </a:ext>
             </a:extLst>
           </p:cNvPr>
@@ -12848,7 +12848,7 @@
           <p:cNvPr id="30" name="">
             <a:extLst xmlns:a="http://schemas.openxmlformats.org/drawingml/2006/main">
               <a:ext uri="{FF2B5EF4-FFF2-40B4-BE49-F238E27FC236}">
-                <a16:creationId xmlns:a16="http://schemas.microsoft.com/office/drawing/2014/main" id="{1CBDB302-4B6C-41B0-A373-8BF8C884240B}"/>
+                <a16:creationId xmlns:a16="http://schemas.microsoft.com/office/drawing/2014/main" id="{13637341-713D-46CA-9BF4-D4308AACBEA9}"/>
               </a:ext>
             </a:extLst>
           </p:cNvPr>
@@ -13011,7 +13011,7 @@
           <p:cNvPr id="2" name="">
             <a:extLst xmlns:a="http://schemas.openxmlformats.org/drawingml/2006/main">
               <a:ext uri="{FF2B5EF4-FFF2-40B4-BE49-F238E27FC236}">
-                <a16:creationId xmlns:a16="http://schemas.microsoft.com/office/drawing/2014/main" id="{0B44D56D-A575-4FE6-A313-DC873A7ABEF8}"/>
+                <a16:creationId xmlns:a16="http://schemas.microsoft.com/office/drawing/2014/main" id="{47A8DEC1-DEA2-4773-9A60-EE518E64C600}"/>
               </a:ext>
             </a:extLst>
           </p:cNvPr>
@@ -13174,7 +13174,7 @@
           <p:cNvPr id="3" name="">
             <a:extLst xmlns:a="http://schemas.openxmlformats.org/drawingml/2006/main">
               <a:ext uri="{FF2B5EF4-FFF2-40B4-BE49-F238E27FC236}">
-                <a16:creationId xmlns:a16="http://schemas.microsoft.com/office/drawing/2014/main" id="{D988F3EE-1E33-4EEB-923C-4C2CA3FA5B16}"/>
+                <a16:creationId xmlns:a16="http://schemas.microsoft.com/office/drawing/2014/main" id="{2D345704-3032-47DB-A4AD-95BF424CA5FD}"/>
               </a:ext>
             </a:extLst>
           </p:cNvPr>
@@ -13337,7 +13337,7 @@
           <p:cNvPr id="4" name="">
             <a:extLst xmlns:a="http://schemas.openxmlformats.org/drawingml/2006/main">
               <a:ext uri="{FF2B5EF4-FFF2-40B4-BE49-F238E27FC236}">
-                <a16:creationId xmlns:a16="http://schemas.microsoft.com/office/drawing/2014/main" id="{7B58F35F-D17F-4319-8927-A347888AF1AC}"/>
+                <a16:creationId xmlns:a16="http://schemas.microsoft.com/office/drawing/2014/main" id="{577C1B75-6C3A-49D5-858C-9489989D42BE}"/>
               </a:ext>
             </a:extLst>
           </p:cNvPr>
@@ -13372,7 +13372,7 @@
           <p:cNvPr id="5" name="">
             <a:extLst xmlns:a="http://schemas.openxmlformats.org/drawingml/2006/main">
               <a:ext uri="{FF2B5EF4-FFF2-40B4-BE49-F238E27FC236}">
-                <a16:creationId xmlns:a16="http://schemas.microsoft.com/office/drawing/2014/main" id="{2F4B16E9-DA4B-4C2C-ACB6-8DF562187C12}"/>
+                <a16:creationId xmlns:a16="http://schemas.microsoft.com/office/drawing/2014/main" id="{3578251D-04B8-4960-A6F4-8A8E417EA5D4}"/>
               </a:ext>
             </a:extLst>
           </p:cNvPr>
@@ -13535,7 +13535,7 @@
           <p:cNvPr id="6" name="">
             <a:extLst xmlns:a="http://schemas.openxmlformats.org/drawingml/2006/main">
               <a:ext uri="{FF2B5EF4-FFF2-40B4-BE49-F238E27FC236}">
-                <a16:creationId xmlns:a16="http://schemas.microsoft.com/office/drawing/2014/main" id="{75A4A8BB-84E3-416E-9F4E-67D090C96433}"/>
+                <a16:creationId xmlns:a16="http://schemas.microsoft.com/office/drawing/2014/main" id="{BF154404-FD0C-4AEB-8C09-FD03A1C4340D}"/>
               </a:ext>
             </a:extLst>
           </p:cNvPr>
@@ -13698,7 +13698,7 @@
           <p:cNvPr id="7" name="">
             <a:extLst xmlns:a="http://schemas.openxmlformats.org/drawingml/2006/main">
               <a:ext uri="{FF2B5EF4-FFF2-40B4-BE49-F238E27FC236}">
-                <a16:creationId xmlns:a16="http://schemas.microsoft.com/office/drawing/2014/main" id="{B1BF7552-40C6-4624-88C4-810907D8004D}"/>
+                <a16:creationId xmlns:a16="http://schemas.microsoft.com/office/drawing/2014/main" id="{305B6439-36AB-48EE-8B54-5C753E95DC14}"/>
               </a:ext>
             </a:extLst>
           </p:cNvPr>
@@ -13733,7 +13733,7 @@
           <p:cNvPr id="8" name="">
             <a:extLst xmlns:a="http://schemas.openxmlformats.org/drawingml/2006/main">
               <a:ext uri="{FF2B5EF4-FFF2-40B4-BE49-F238E27FC236}">
-                <a16:creationId xmlns:a16="http://schemas.microsoft.com/office/drawing/2014/main" id="{2F0BB7A9-4010-47A7-AC5D-0603D00C4DB2}"/>
+                <a16:creationId xmlns:a16="http://schemas.microsoft.com/office/drawing/2014/main" id="{56956BA3-7812-43D3-B460-45AC9C21F2A2}"/>
               </a:ext>
             </a:extLst>
           </p:cNvPr>
@@ -13896,7 +13896,7 @@
           <p:cNvPr id="9" name="">
             <a:extLst xmlns:a="http://schemas.openxmlformats.org/drawingml/2006/main">
               <a:ext uri="{FF2B5EF4-FFF2-40B4-BE49-F238E27FC236}">
-                <a16:creationId xmlns:a16="http://schemas.microsoft.com/office/drawing/2014/main" id="{42DA0723-6B73-46F6-ACD4-B475CF062842}"/>
+                <a16:creationId xmlns:a16="http://schemas.microsoft.com/office/drawing/2014/main" id="{EDBE7E27-1A3D-40C5-8BCE-D2FF3AA214A3}"/>
               </a:ext>
             </a:extLst>
           </p:cNvPr>
@@ -14059,7 +14059,7 @@
           <p:cNvPr id="10" name="">
             <a:extLst xmlns:a="http://schemas.openxmlformats.org/drawingml/2006/main">
               <a:ext uri="{FF2B5EF4-FFF2-40B4-BE49-F238E27FC236}">
-                <a16:creationId xmlns:a16="http://schemas.microsoft.com/office/drawing/2014/main" id="{C5883E23-2531-4BBB-9581-62DBFC67B1A8}"/>
+                <a16:creationId xmlns:a16="http://schemas.microsoft.com/office/drawing/2014/main" id="{60E036C0-08BB-4AB9-9CE3-918FF597BD79}"/>
               </a:ext>
             </a:extLst>
           </p:cNvPr>
@@ -14094,7 +14094,7 @@
           <p:cNvPr id="11" name="">
             <a:extLst xmlns:a="http://schemas.openxmlformats.org/drawingml/2006/main">
               <a:ext uri="{FF2B5EF4-FFF2-40B4-BE49-F238E27FC236}">
-                <a16:creationId xmlns:a16="http://schemas.microsoft.com/office/drawing/2014/main" id="{13847BEB-617D-4E89-AB2F-E2E3504C5076}"/>
+                <a16:creationId xmlns:a16="http://schemas.microsoft.com/office/drawing/2014/main" id="{971B795E-D40A-49A3-89BA-4D7261B10509}"/>
               </a:ext>
             </a:extLst>
           </p:cNvPr>
@@ -14257,7 +14257,7 @@
           <p:cNvPr id="12" name="">
             <a:extLst xmlns:a="http://schemas.openxmlformats.org/drawingml/2006/main">
               <a:ext uri="{FF2B5EF4-FFF2-40B4-BE49-F238E27FC236}">
-                <a16:creationId xmlns:a16="http://schemas.microsoft.com/office/drawing/2014/main" id="{9427E14D-686C-4B0D-A378-8FC9F8F3FAEF}"/>
+                <a16:creationId xmlns:a16="http://schemas.microsoft.com/office/drawing/2014/main" id="{F0270832-AA7D-4173-B30A-8C1DE6C2BFA6}"/>
               </a:ext>
             </a:extLst>
           </p:cNvPr>
@@ -14420,7 +14420,7 @@
           <p:cNvPr id="13" name="">
             <a:extLst xmlns:a="http://schemas.openxmlformats.org/drawingml/2006/main">
               <a:ext uri="{FF2B5EF4-FFF2-40B4-BE49-F238E27FC236}">
-                <a16:creationId xmlns:a16="http://schemas.microsoft.com/office/drawing/2014/main" id="{00F20666-C69D-4AD1-AB96-74271C487622}"/>
+                <a16:creationId xmlns:a16="http://schemas.microsoft.com/office/drawing/2014/main" id="{822B5469-00E0-4EEB-BCA9-2C82A74D3E06}"/>
               </a:ext>
             </a:extLst>
           </p:cNvPr>
@@ -14455,7 +14455,7 @@
           <p:cNvPr id="14" name="">
             <a:extLst xmlns:a="http://schemas.openxmlformats.org/drawingml/2006/main">
               <a:ext uri="{FF2B5EF4-FFF2-40B4-BE49-F238E27FC236}">
-                <a16:creationId xmlns:a16="http://schemas.microsoft.com/office/drawing/2014/main" id="{3A723250-3D65-412C-B621-0C2A46CE8BD5}"/>
+                <a16:creationId xmlns:a16="http://schemas.microsoft.com/office/drawing/2014/main" id="{4537FC12-702D-4876-9634-B969853268C6}"/>
               </a:ext>
             </a:extLst>
           </p:cNvPr>
@@ -14618,7 +14618,7 @@
           <p:cNvPr id="15" name="">
             <a:extLst xmlns:a="http://schemas.openxmlformats.org/drawingml/2006/main">
               <a:ext uri="{FF2B5EF4-FFF2-40B4-BE49-F238E27FC236}">
-                <a16:creationId xmlns:a16="http://schemas.microsoft.com/office/drawing/2014/main" id="{AED16D88-C089-4738-9C6B-34929CB60DBB}"/>
+                <a16:creationId xmlns:a16="http://schemas.microsoft.com/office/drawing/2014/main" id="{D7679E8B-6756-48C5-A1FD-C8B2496FA288}"/>
               </a:ext>
             </a:extLst>
           </p:cNvPr>
@@ -14781,7 +14781,7 @@
           <p:cNvPr id="19" name="">
             <a:extLst xmlns:a="http://schemas.openxmlformats.org/drawingml/2006/main">
               <a:ext uri="{FF2B5EF4-FFF2-40B4-BE49-F238E27FC236}">
-                <a16:creationId xmlns:a16="http://schemas.microsoft.com/office/drawing/2014/main" id="{1E69179B-A721-4CFA-9C62-EA329EC9CCCA}"/>
+                <a16:creationId xmlns:a16="http://schemas.microsoft.com/office/drawing/2014/main" id="{4A5B5502-30FC-4F8E-8F98-67F6DEE91D6E}"/>
               </a:ext>
             </a:extLst>
           </p:cNvPr>
@@ -14816,7 +14816,7 @@
           <p:cNvPr id="20" name="">
             <a:extLst xmlns:a="http://schemas.openxmlformats.org/drawingml/2006/main">
               <a:ext uri="{FF2B5EF4-FFF2-40B4-BE49-F238E27FC236}">
-                <a16:creationId xmlns:a16="http://schemas.microsoft.com/office/drawing/2014/main" id="{D26438CE-5026-4A68-B444-BCB5D57DD2F3}"/>
+                <a16:creationId xmlns:a16="http://schemas.microsoft.com/office/drawing/2014/main" id="{9B79DE2C-7C25-4DF8-9DDF-39E010C21708}"/>
               </a:ext>
             </a:extLst>
           </p:cNvPr>
@@ -15087,7 +15087,7 @@
           <p:cNvPr id="21" name="">
             <a:extLst xmlns:a="http://schemas.openxmlformats.org/drawingml/2006/main">
               <a:ext uri="{FF2B5EF4-FFF2-40B4-BE49-F238E27FC236}">
-                <a16:creationId xmlns:a16="http://schemas.microsoft.com/office/drawing/2014/main" id="{1BC1B2C6-D545-4B4F-9E41-9BE64214E326}"/>
+                <a16:creationId xmlns:a16="http://schemas.microsoft.com/office/drawing/2014/main" id="{56ADE043-A8A1-414D-AA60-974033CB3C97}"/>
               </a:ext>
             </a:extLst>
           </p:cNvPr>
@@ -15250,7 +15250,7 @@
           <p:cNvPr id="22" name="">
             <a:extLst xmlns:a="http://schemas.openxmlformats.org/drawingml/2006/main">
               <a:ext uri="{FF2B5EF4-FFF2-40B4-BE49-F238E27FC236}">
-                <a16:creationId xmlns:a16="http://schemas.microsoft.com/office/drawing/2014/main" id="{477FC4E4-C405-4CF6-BFF5-E1BD0CB8B4A8}"/>
+                <a16:creationId xmlns:a16="http://schemas.microsoft.com/office/drawing/2014/main" id="{F76450F0-3AF3-4A38-A166-A0300A7ED24D}"/>
               </a:ext>
             </a:extLst>
           </p:cNvPr>
@@ -15283,7 +15283,7 @@
           <p:cNvPr id="23" name="">
             <a:extLst xmlns:a="http://schemas.openxmlformats.org/drawingml/2006/main">
               <a:ext uri="{FF2B5EF4-FFF2-40B4-BE49-F238E27FC236}">
-                <a16:creationId xmlns:a16="http://schemas.microsoft.com/office/drawing/2014/main" id="{008A7883-61E8-4991-9421-23A347D1B506}"/>
+                <a16:creationId xmlns:a16="http://schemas.microsoft.com/office/drawing/2014/main" id="{14A9F078-A6E4-4A66-A720-3D81D381179C}"/>
               </a:ext>
             </a:extLst>
           </p:cNvPr>
@@ -15446,7 +15446,7 @@
           <p:cNvPr id="24" name="">
             <a:extLst xmlns:a="http://schemas.openxmlformats.org/drawingml/2006/main">
               <a:ext uri="{FF2B5EF4-FFF2-40B4-BE49-F238E27FC236}">
-                <a16:creationId xmlns:a16="http://schemas.microsoft.com/office/drawing/2014/main" id="{31656D6B-FEF7-4B9B-B8CB-632084A02C7F}"/>
+                <a16:creationId xmlns:a16="http://schemas.microsoft.com/office/drawing/2014/main" id="{34047CBA-EED6-4E3F-9EE2-883CC060B474}"/>
               </a:ext>
             </a:extLst>
           </p:cNvPr>
@@ -15479,7 +15479,7 @@
           <p:cNvPr id="25" name="">
             <a:extLst xmlns:a="http://schemas.openxmlformats.org/drawingml/2006/main">
               <a:ext uri="{FF2B5EF4-FFF2-40B4-BE49-F238E27FC236}">
-                <a16:creationId xmlns:a16="http://schemas.microsoft.com/office/drawing/2014/main" id="{66ABBFAA-C43D-4DDC-A28B-A0C9E2E4F781}"/>
+                <a16:creationId xmlns:a16="http://schemas.microsoft.com/office/drawing/2014/main" id="{9243E448-2140-4C4C-B68A-1DD1DD66D35D}"/>
               </a:ext>
             </a:extLst>
           </p:cNvPr>
@@ -15642,7 +15642,7 @@
           <p:cNvPr id="26" name="">
             <a:extLst xmlns:a="http://schemas.openxmlformats.org/drawingml/2006/main">
               <a:ext uri="{FF2B5EF4-FFF2-40B4-BE49-F238E27FC236}">
-                <a16:creationId xmlns:a16="http://schemas.microsoft.com/office/drawing/2014/main" id="{BC34FCA6-5CF2-4938-AA16-5E929C38943B}"/>
+                <a16:creationId xmlns:a16="http://schemas.microsoft.com/office/drawing/2014/main" id="{4560F6EC-BC56-40C9-A613-F2C8486F8DC3}"/>
               </a:ext>
             </a:extLst>
           </p:cNvPr>
@@ -15675,7 +15675,7 @@
           <p:cNvPr id="27" name="">
             <a:extLst xmlns:a="http://schemas.openxmlformats.org/drawingml/2006/main">
               <a:ext uri="{FF2B5EF4-FFF2-40B4-BE49-F238E27FC236}">
-                <a16:creationId xmlns:a16="http://schemas.microsoft.com/office/drawing/2014/main" id="{553AA8F7-F566-4784-931A-BD35B352600E}"/>
+                <a16:creationId xmlns:a16="http://schemas.microsoft.com/office/drawing/2014/main" id="{2BB2C8FC-398E-48BC-A296-00546C0F780E}"/>
               </a:ext>
             </a:extLst>
           </p:cNvPr>
@@ -15838,7 +15838,7 @@
           <p:cNvPr id="28" name="">
             <a:extLst xmlns:a="http://schemas.openxmlformats.org/drawingml/2006/main">
               <a:ext uri="{FF2B5EF4-FFF2-40B4-BE49-F238E27FC236}">
-                <a16:creationId xmlns:a16="http://schemas.microsoft.com/office/drawing/2014/main" id="{010CD7DA-71BA-4468-BABC-52D373A77AA8}"/>
+                <a16:creationId xmlns:a16="http://schemas.microsoft.com/office/drawing/2014/main" id="{19E68CF6-FB4F-45B0-9753-FA90501DE5C2}"/>
               </a:ext>
             </a:extLst>
           </p:cNvPr>
@@ -16001,7 +16001,7 @@
           <p:cNvPr id="29" name="">
             <a:extLst xmlns:a="http://schemas.openxmlformats.org/drawingml/2006/main">
               <a:ext uri="{FF2B5EF4-FFF2-40B4-BE49-F238E27FC236}">
-                <a16:creationId xmlns:a16="http://schemas.microsoft.com/office/drawing/2014/main" id="{FF405BA1-6981-45C3-926B-49A5889B02C7}"/>
+                <a16:creationId xmlns:a16="http://schemas.microsoft.com/office/drawing/2014/main" id="{27BC4821-2760-4BC2-89AE-390D379C5C6A}"/>
               </a:ext>
             </a:extLst>
           </p:cNvPr>
@@ -16162,7 +16162,7 @@
     </p:spTree>
     <p:extLst>
       <p:ext uri="{BB962C8B-B14F-4D97-AF65-F5344CB8AC3E}">
-        <p14:creationId xmlns:p14="http://schemas.microsoft.com/office/powerpoint/2010/main" val="1132804325"/>
+        <p14:creationId xmlns:p14="http://schemas.microsoft.com/office/powerpoint/2010/main" val="1204632368"/>
       </p:ext>
     </p:extLst>
   </p:cSld>
@@ -16193,7 +16193,7 @@
           <p:cNvPr id="18" name="">
             <a:extLst xmlns:a="http://schemas.openxmlformats.org/drawingml/2006/main">
               <a:ext uri="{FF2B5EF4-FFF2-40B4-BE49-F238E27FC236}">
-                <a16:creationId xmlns:a16="http://schemas.microsoft.com/office/drawing/2014/main" id="{68886708-38A8-4529-B0AF-069BB6925C1F}"/>
+                <a16:creationId xmlns:a16="http://schemas.microsoft.com/office/drawing/2014/main" id="{88C395A4-7F50-4254-8389-10EFB0B403BB}"/>
               </a:ext>
             </a:extLst>
           </p:cNvPr>
@@ -16225,7 +16225,7 @@
           <p:cNvPr id="17" name="">
             <a:extLst xmlns:a="http://schemas.openxmlformats.org/drawingml/2006/main">
               <a:ext uri="{FF2B5EF4-FFF2-40B4-BE49-F238E27FC236}">
-                <a16:creationId xmlns:a16="http://schemas.microsoft.com/office/drawing/2014/main" id="{3CF57F33-6A52-40E1-BBEB-CEA80D9464FD}"/>
+                <a16:creationId xmlns:a16="http://schemas.microsoft.com/office/drawing/2014/main" id="{A3FFF509-E20D-4F88-B71B-E25E06E595D2}"/>
               </a:ext>
             </a:extLst>
           </p:cNvPr>
@@ -16257,7 +16257,7 @@
           <p:cNvPr id="16" name="">
             <a:extLst xmlns:a="http://schemas.openxmlformats.org/drawingml/2006/main">
               <a:ext uri="{FF2B5EF4-FFF2-40B4-BE49-F238E27FC236}">
-                <a16:creationId xmlns:a16="http://schemas.microsoft.com/office/drawing/2014/main" id="{A89BB93E-2026-496E-9C07-E2A59C2095BC}"/>
+                <a16:creationId xmlns:a16="http://schemas.microsoft.com/office/drawing/2014/main" id="{C0DCEB37-A4F4-445A-8C5B-8AE8D97F8CEB}"/>
               </a:ext>
             </a:extLst>
           </p:cNvPr>
@@ -16289,7 +16289,7 @@
           <p:cNvPr id="30" name="">
             <a:extLst xmlns:a="http://schemas.openxmlformats.org/drawingml/2006/main">
               <a:ext uri="{FF2B5EF4-FFF2-40B4-BE49-F238E27FC236}">
-                <a16:creationId xmlns:a16="http://schemas.microsoft.com/office/drawing/2014/main" id="{961DD89A-158C-4603-B2DB-F29DBE9B7C80}"/>
+                <a16:creationId xmlns:a16="http://schemas.microsoft.com/office/drawing/2014/main" id="{7239A87F-62CC-4503-84CA-C37F84AADB55}"/>
               </a:ext>
             </a:extLst>
           </p:cNvPr>
@@ -16452,7 +16452,7 @@
           <p:cNvPr id="2" name="">
             <a:extLst xmlns:a="http://schemas.openxmlformats.org/drawingml/2006/main">
               <a:ext uri="{FF2B5EF4-FFF2-40B4-BE49-F238E27FC236}">
-                <a16:creationId xmlns:a16="http://schemas.microsoft.com/office/drawing/2014/main" id="{A81F1295-1925-4BC0-9F69-AA72A35EE065}"/>
+                <a16:creationId xmlns:a16="http://schemas.microsoft.com/office/drawing/2014/main" id="{8B2EC1C8-8418-471F-9CBD-8C39F2351AEE}"/>
               </a:ext>
             </a:extLst>
           </p:cNvPr>
@@ -16615,7 +16615,7 @@
           <p:cNvPr id="3" name="">
             <a:extLst xmlns:a="http://schemas.openxmlformats.org/drawingml/2006/main">
               <a:ext uri="{FF2B5EF4-FFF2-40B4-BE49-F238E27FC236}">
-                <a16:creationId xmlns:a16="http://schemas.microsoft.com/office/drawing/2014/main" id="{E2E73530-0F0A-49D5-8D53-ABE2269A5E85}"/>
+                <a16:creationId xmlns:a16="http://schemas.microsoft.com/office/drawing/2014/main" id="{6FEE4B2A-AB32-4DFB-BAA3-363943A75620}"/>
               </a:ext>
             </a:extLst>
           </p:cNvPr>
@@ -16778,7 +16778,7 @@
           <p:cNvPr id="4" name="">
             <a:extLst xmlns:a="http://schemas.openxmlformats.org/drawingml/2006/main">
               <a:ext uri="{FF2B5EF4-FFF2-40B4-BE49-F238E27FC236}">
-                <a16:creationId xmlns:a16="http://schemas.microsoft.com/office/drawing/2014/main" id="{D1636372-B96E-4383-BB8F-E04C65B1822C}"/>
+                <a16:creationId xmlns:a16="http://schemas.microsoft.com/office/drawing/2014/main" id="{43182F24-B05C-49E6-8051-A3CF2BC161F8}"/>
               </a:ext>
             </a:extLst>
           </p:cNvPr>
@@ -16813,7 +16813,7 @@
           <p:cNvPr id="5" name="">
             <a:extLst xmlns:a="http://schemas.openxmlformats.org/drawingml/2006/main">
               <a:ext uri="{FF2B5EF4-FFF2-40B4-BE49-F238E27FC236}">
-                <a16:creationId xmlns:a16="http://schemas.microsoft.com/office/drawing/2014/main" id="{733CB7FA-20E7-4BD2-A72C-576A562D4EDE}"/>
+                <a16:creationId xmlns:a16="http://schemas.microsoft.com/office/drawing/2014/main" id="{E1461C86-D288-49A3-9981-39697F63CC83}"/>
               </a:ext>
             </a:extLst>
           </p:cNvPr>
@@ -16976,7 +16976,7 @@
           <p:cNvPr id="6" name="">
             <a:extLst xmlns:a="http://schemas.openxmlformats.org/drawingml/2006/main">
               <a:ext uri="{FF2B5EF4-FFF2-40B4-BE49-F238E27FC236}">
-                <a16:creationId xmlns:a16="http://schemas.microsoft.com/office/drawing/2014/main" id="{AB4E0AEE-9392-42F6-AA1F-8C84E75F24CB}"/>
+                <a16:creationId xmlns:a16="http://schemas.microsoft.com/office/drawing/2014/main" id="{C7A8CC2C-D27C-4E50-9001-2B2EF0051D7A}"/>
               </a:ext>
             </a:extLst>
           </p:cNvPr>
@@ -17139,7 +17139,7 @@
           <p:cNvPr id="7" name="">
             <a:extLst xmlns:a="http://schemas.openxmlformats.org/drawingml/2006/main">
               <a:ext uri="{FF2B5EF4-FFF2-40B4-BE49-F238E27FC236}">
-                <a16:creationId xmlns:a16="http://schemas.microsoft.com/office/drawing/2014/main" id="{C848C9F6-A3C8-4B64-ABB1-30B27F8A75C3}"/>
+                <a16:creationId xmlns:a16="http://schemas.microsoft.com/office/drawing/2014/main" id="{370D686F-A10E-44A8-8CA1-5E6BC931B8A2}"/>
               </a:ext>
             </a:extLst>
           </p:cNvPr>
@@ -17174,7 +17174,7 @@
           <p:cNvPr id="8" name="">
             <a:extLst xmlns:a="http://schemas.openxmlformats.org/drawingml/2006/main">
               <a:ext uri="{FF2B5EF4-FFF2-40B4-BE49-F238E27FC236}">
-                <a16:creationId xmlns:a16="http://schemas.microsoft.com/office/drawing/2014/main" id="{166E4BE1-DFA3-4559-A540-578FB10E2B4B}"/>
+                <a16:creationId xmlns:a16="http://schemas.microsoft.com/office/drawing/2014/main" id="{F581CFD6-91CC-4503-8776-C086D81E8A4E}"/>
               </a:ext>
             </a:extLst>
           </p:cNvPr>
@@ -17337,7 +17337,7 @@
           <p:cNvPr id="9" name="">
             <a:extLst xmlns:a="http://schemas.openxmlformats.org/drawingml/2006/main">
               <a:ext uri="{FF2B5EF4-FFF2-40B4-BE49-F238E27FC236}">
-                <a16:creationId xmlns:a16="http://schemas.microsoft.com/office/drawing/2014/main" id="{B1481F75-497F-42D3-B80C-3C4D089EE1E1}"/>
+                <a16:creationId xmlns:a16="http://schemas.microsoft.com/office/drawing/2014/main" id="{7E72C391-88F0-4BC5-9AF6-3D945F80327B}"/>
               </a:ext>
             </a:extLst>
           </p:cNvPr>
@@ -17500,7 +17500,7 @@
           <p:cNvPr id="10" name="">
             <a:extLst xmlns:a="http://schemas.openxmlformats.org/drawingml/2006/main">
               <a:ext uri="{FF2B5EF4-FFF2-40B4-BE49-F238E27FC236}">
-                <a16:creationId xmlns:a16="http://schemas.microsoft.com/office/drawing/2014/main" id="{1F2540AC-4F9D-443C-BBC8-6759FB9F01F7}"/>
+                <a16:creationId xmlns:a16="http://schemas.microsoft.com/office/drawing/2014/main" id="{508FE8F9-EB2D-4A0F-95A6-6A59DC6F7985}"/>
               </a:ext>
             </a:extLst>
           </p:cNvPr>
@@ -17535,7 +17535,7 @@
           <p:cNvPr id="11" name="">
             <a:extLst xmlns:a="http://schemas.openxmlformats.org/drawingml/2006/main">
               <a:ext uri="{FF2B5EF4-FFF2-40B4-BE49-F238E27FC236}">
-                <a16:creationId xmlns:a16="http://schemas.microsoft.com/office/drawing/2014/main" id="{3F10A41D-3B56-4399-BE20-E34A2ED1A852}"/>
+                <a16:creationId xmlns:a16="http://schemas.microsoft.com/office/drawing/2014/main" id="{7A1EBEFF-80FD-4582-8033-86C7E15F8D1D}"/>
               </a:ext>
             </a:extLst>
           </p:cNvPr>
@@ -17698,7 +17698,7 @@
           <p:cNvPr id="12" name="">
             <a:extLst xmlns:a="http://schemas.openxmlformats.org/drawingml/2006/main">
               <a:ext uri="{FF2B5EF4-FFF2-40B4-BE49-F238E27FC236}">
-                <a16:creationId xmlns:a16="http://schemas.microsoft.com/office/drawing/2014/main" id="{1AD4727D-DAA1-4183-BB2E-5C639CD54762}"/>
+                <a16:creationId xmlns:a16="http://schemas.microsoft.com/office/drawing/2014/main" id="{A38A1D91-A463-4503-95B7-A79C1DC60288}"/>
               </a:ext>
             </a:extLst>
           </p:cNvPr>
@@ -17861,7 +17861,7 @@
           <p:cNvPr id="13" name="">
             <a:extLst xmlns:a="http://schemas.openxmlformats.org/drawingml/2006/main">
               <a:ext uri="{FF2B5EF4-FFF2-40B4-BE49-F238E27FC236}">
-                <a16:creationId xmlns:a16="http://schemas.microsoft.com/office/drawing/2014/main" id="{C60AD785-BEB7-47EB-AC1F-3E7A7406056A}"/>
+                <a16:creationId xmlns:a16="http://schemas.microsoft.com/office/drawing/2014/main" id="{BAACA875-3083-49A7-A294-5B5D4E779184}"/>
               </a:ext>
             </a:extLst>
           </p:cNvPr>
@@ -17896,7 +17896,7 @@
           <p:cNvPr id="14" name="">
             <a:extLst xmlns:a="http://schemas.openxmlformats.org/drawingml/2006/main">
               <a:ext uri="{FF2B5EF4-FFF2-40B4-BE49-F238E27FC236}">
-                <a16:creationId xmlns:a16="http://schemas.microsoft.com/office/drawing/2014/main" id="{646672F0-B55E-4610-9FA4-7B619F220A51}"/>
+                <a16:creationId xmlns:a16="http://schemas.microsoft.com/office/drawing/2014/main" id="{4C6DA6E7-5C88-41E0-95FF-8D8904A987E3}"/>
               </a:ext>
             </a:extLst>
           </p:cNvPr>
@@ -18059,7 +18059,7 @@
           <p:cNvPr id="15" name="">
             <a:extLst xmlns:a="http://schemas.openxmlformats.org/drawingml/2006/main">
               <a:ext uri="{FF2B5EF4-FFF2-40B4-BE49-F238E27FC236}">
-                <a16:creationId xmlns:a16="http://schemas.microsoft.com/office/drawing/2014/main" id="{C59B9035-E156-4272-8D17-862EC8AB9436}"/>
+                <a16:creationId xmlns:a16="http://schemas.microsoft.com/office/drawing/2014/main" id="{E6C6F260-6259-4CC9-9D54-C88ECF2E9146}"/>
               </a:ext>
             </a:extLst>
           </p:cNvPr>
@@ -18222,7 +18222,7 @@
           <p:cNvPr id="19" name="">
             <a:extLst xmlns:a="http://schemas.openxmlformats.org/drawingml/2006/main">
               <a:ext uri="{FF2B5EF4-FFF2-40B4-BE49-F238E27FC236}">
-                <a16:creationId xmlns:a16="http://schemas.microsoft.com/office/drawing/2014/main" id="{D3C7EC57-9251-4AEC-A706-AE56FF7CB5E9}"/>
+                <a16:creationId xmlns:a16="http://schemas.microsoft.com/office/drawing/2014/main" id="{D1DE0952-4912-4725-AD92-4D7EE2FDA9BD}"/>
               </a:ext>
             </a:extLst>
           </p:cNvPr>
@@ -18385,7 +18385,7 @@
           <p:cNvPr id="20" name="">
             <a:extLst xmlns:a="http://schemas.openxmlformats.org/drawingml/2006/main">
               <a:ext uri="{FF2B5EF4-FFF2-40B4-BE49-F238E27FC236}">
-                <a16:creationId xmlns:a16="http://schemas.microsoft.com/office/drawing/2014/main" id="{D6903191-8D15-46AE-B986-624EF6E385D4}"/>
+                <a16:creationId xmlns:a16="http://schemas.microsoft.com/office/drawing/2014/main" id="{C152BAB5-B523-4666-808A-84B0C77B9D75}"/>
               </a:ext>
             </a:extLst>
           </p:cNvPr>
@@ -18418,7 +18418,7 @@
           <p:cNvPr id="21" name="">
             <a:extLst xmlns:a="http://schemas.openxmlformats.org/drawingml/2006/main">
               <a:ext uri="{FF2B5EF4-FFF2-40B4-BE49-F238E27FC236}">
-                <a16:creationId xmlns:a16="http://schemas.microsoft.com/office/drawing/2014/main" id="{E9420E32-602B-462E-812D-64752FC7D17E}"/>
+                <a16:creationId xmlns:a16="http://schemas.microsoft.com/office/drawing/2014/main" id="{34BEB5F4-C09B-4426-BFA2-E3D20814CB67}"/>
               </a:ext>
             </a:extLst>
           </p:cNvPr>
@@ -18581,7 +18581,7 @@
           <p:cNvPr id="22" name="">
             <a:extLst xmlns:a="http://schemas.openxmlformats.org/drawingml/2006/main">
               <a:ext uri="{FF2B5EF4-FFF2-40B4-BE49-F238E27FC236}">
-                <a16:creationId xmlns:a16="http://schemas.microsoft.com/office/drawing/2014/main" id="{2D28E60F-F3AD-4932-A3DE-38F6E32CB16D}"/>
+                <a16:creationId xmlns:a16="http://schemas.microsoft.com/office/drawing/2014/main" id="{C1C5A528-2B93-4B3A-B88F-0718D45791E1}"/>
               </a:ext>
             </a:extLst>
           </p:cNvPr>
@@ -18614,7 +18614,7 @@
           <p:cNvPr id="23" name="">
             <a:extLst xmlns:a="http://schemas.openxmlformats.org/drawingml/2006/main">
               <a:ext uri="{FF2B5EF4-FFF2-40B4-BE49-F238E27FC236}">
-                <a16:creationId xmlns:a16="http://schemas.microsoft.com/office/drawing/2014/main" id="{25846A8B-309C-4B2E-9716-AD6AACDCA467}"/>
+                <a16:creationId xmlns:a16="http://schemas.microsoft.com/office/drawing/2014/main" id="{FE5CDE7B-3361-421C-9322-4C73767B385E}"/>
               </a:ext>
             </a:extLst>
           </p:cNvPr>
@@ -18777,7 +18777,7 @@
           <p:cNvPr id="24" name="">
             <a:extLst xmlns:a="http://schemas.openxmlformats.org/drawingml/2006/main">
               <a:ext uri="{FF2B5EF4-FFF2-40B4-BE49-F238E27FC236}">
-                <a16:creationId xmlns:a16="http://schemas.microsoft.com/office/drawing/2014/main" id="{5B852869-D5F5-4457-A79F-82B781994C61}"/>
+                <a16:creationId xmlns:a16="http://schemas.microsoft.com/office/drawing/2014/main" id="{68A1F89E-CC7A-4E90-8758-43BC5CD4FCEC}"/>
               </a:ext>
             </a:extLst>
           </p:cNvPr>
@@ -18810,7 +18810,7 @@
           <p:cNvPr id="25" name="">
             <a:extLst xmlns:a="http://schemas.openxmlformats.org/drawingml/2006/main">
               <a:ext uri="{FF2B5EF4-FFF2-40B4-BE49-F238E27FC236}">
-                <a16:creationId xmlns:a16="http://schemas.microsoft.com/office/drawing/2014/main" id="{353AC8F8-E26C-4F52-A9D4-6213984E60DA}"/>
+                <a16:creationId xmlns:a16="http://schemas.microsoft.com/office/drawing/2014/main" id="{91A46E30-EE7E-440C-8510-D21056826A09}"/>
               </a:ext>
             </a:extLst>
           </p:cNvPr>
@@ -18973,7 +18973,7 @@
           <p:cNvPr id="26" name="">
             <a:extLst xmlns:a="http://schemas.openxmlformats.org/drawingml/2006/main">
               <a:ext uri="{FF2B5EF4-FFF2-40B4-BE49-F238E27FC236}">
-                <a16:creationId xmlns:a16="http://schemas.microsoft.com/office/drawing/2014/main" id="{C2497A10-8BA9-4C96-BD59-0FD58B4D8C48}"/>
+                <a16:creationId xmlns:a16="http://schemas.microsoft.com/office/drawing/2014/main" id="{C2B09889-D3E6-4F8C-AABE-76850E3CB3D6}"/>
               </a:ext>
             </a:extLst>
           </p:cNvPr>
@@ -19006,7 +19006,7 @@
           <p:cNvPr id="27" name="">
             <a:extLst xmlns:a="http://schemas.openxmlformats.org/drawingml/2006/main">
               <a:ext uri="{FF2B5EF4-FFF2-40B4-BE49-F238E27FC236}">
-                <a16:creationId xmlns:a16="http://schemas.microsoft.com/office/drawing/2014/main" id="{F4D35191-7029-44D8-895A-D606465C831F}"/>
+                <a16:creationId xmlns:a16="http://schemas.microsoft.com/office/drawing/2014/main" id="{1EEAB9A4-3DE9-4191-8AD2-62FDE440472B}"/>
               </a:ext>
             </a:extLst>
           </p:cNvPr>
@@ -19250,7 +19250,7 @@
           <p:cNvPr id="28" name="">
             <a:extLst xmlns:a="http://schemas.openxmlformats.org/drawingml/2006/main">
               <a:ext uri="{FF2B5EF4-FFF2-40B4-BE49-F238E27FC236}">
-                <a16:creationId xmlns:a16="http://schemas.microsoft.com/office/drawing/2014/main" id="{B2F4602F-5453-4D71-9BA1-75AA1E853424}"/>
+                <a16:creationId xmlns:a16="http://schemas.microsoft.com/office/drawing/2014/main" id="{76FC8104-2033-4885-A8FD-8D672A5267CC}"/>
               </a:ext>
             </a:extLst>
           </p:cNvPr>
@@ -19413,7 +19413,7 @@
           <p:cNvPr id="29" name="">
             <a:extLst xmlns:a="http://schemas.openxmlformats.org/drawingml/2006/main">
               <a:ext uri="{FF2B5EF4-FFF2-40B4-BE49-F238E27FC236}">
-                <a16:creationId xmlns:a16="http://schemas.microsoft.com/office/drawing/2014/main" id="{4E1BFE66-2972-4535-BADF-689F139F754E}"/>
+                <a16:creationId xmlns:a16="http://schemas.microsoft.com/office/drawing/2014/main" id="{7B958802-5C77-4DFC-BE1E-F46DA7C2CC48}"/>
               </a:ext>
             </a:extLst>
           </p:cNvPr>
@@ -19574,7 +19574,7 @@
     </p:spTree>
     <p:extLst>
       <p:ext uri="{BB962C8B-B14F-4D97-AF65-F5344CB8AC3E}">
-        <p14:creationId xmlns:p14="http://schemas.microsoft.com/office/powerpoint/2010/main" val="1573933910"/>
+        <p14:creationId xmlns:p14="http://schemas.microsoft.com/office/powerpoint/2010/main" val="445541404"/>
       </p:ext>
     </p:extLst>
   </p:cSld>
@@ -19605,7 +19605,7 @@
           <p:cNvPr id="27" name="">
             <a:extLst xmlns:a="http://schemas.openxmlformats.org/drawingml/2006/main">
               <a:ext uri="{FF2B5EF4-FFF2-40B4-BE49-F238E27FC236}">
-                <a16:creationId xmlns:a16="http://schemas.microsoft.com/office/drawing/2014/main" id="{361F8FB5-B2B0-4E56-8F2F-C0074FFA74FB}"/>
+                <a16:creationId xmlns:a16="http://schemas.microsoft.com/office/drawing/2014/main" id="{52C708E4-F01F-4BCE-92B8-E26175E9FE3C}"/>
               </a:ext>
             </a:extLst>
           </p:cNvPr>
@@ -19640,7 +19640,7 @@
           <p:cNvPr id="26" name="">
             <a:extLst xmlns:a="http://schemas.openxmlformats.org/drawingml/2006/main">
               <a:ext uri="{FF2B5EF4-FFF2-40B4-BE49-F238E27FC236}">
-                <a16:creationId xmlns:a16="http://schemas.microsoft.com/office/drawing/2014/main" id="{9EA4CAEC-3F12-492F-B4B7-8F47D8F170D4}"/>
+                <a16:creationId xmlns:a16="http://schemas.microsoft.com/office/drawing/2014/main" id="{1ABC1C91-26B6-4759-9C1D-CF0C1AC692E6}"/>
               </a:ext>
             </a:extLst>
           </p:cNvPr>
@@ -19675,7 +19675,7 @@
           <p:cNvPr id="25" name="">
             <a:extLst xmlns:a="http://schemas.openxmlformats.org/drawingml/2006/main">
               <a:ext uri="{FF2B5EF4-FFF2-40B4-BE49-F238E27FC236}">
-                <a16:creationId xmlns:a16="http://schemas.microsoft.com/office/drawing/2014/main" id="{BB272B5E-E94D-4BBC-B622-87C329F7A614}"/>
+                <a16:creationId xmlns:a16="http://schemas.microsoft.com/office/drawing/2014/main" id="{6F8D4A19-CA44-4A7F-8043-0809FC00075F}"/>
               </a:ext>
             </a:extLst>
           </p:cNvPr>
@@ -19707,7 +19707,7 @@
           <p:cNvPr id="24" name="">
             <a:extLst xmlns:a="http://schemas.openxmlformats.org/drawingml/2006/main">
               <a:ext uri="{FF2B5EF4-FFF2-40B4-BE49-F238E27FC236}">
-                <a16:creationId xmlns:a16="http://schemas.microsoft.com/office/drawing/2014/main" id="{B5A86875-6939-4924-9D91-2C66ACBDE217}"/>
+                <a16:creationId xmlns:a16="http://schemas.microsoft.com/office/drawing/2014/main" id="{E20875C5-8F2A-46E0-A485-48120BA90DD6}"/>
               </a:ext>
             </a:extLst>
           </p:cNvPr>
@@ -19739,7 +19739,7 @@
           <p:cNvPr id="23" name="">
             <a:extLst xmlns:a="http://schemas.openxmlformats.org/drawingml/2006/main">
               <a:ext uri="{FF2B5EF4-FFF2-40B4-BE49-F238E27FC236}">
-                <a16:creationId xmlns:a16="http://schemas.microsoft.com/office/drawing/2014/main" id="{8F10362C-28DC-474E-BDDB-3EBECF4DB14B}"/>
+                <a16:creationId xmlns:a16="http://schemas.microsoft.com/office/drawing/2014/main" id="{9934B723-7BD5-4BC0-8833-3D3D3502D4E0}"/>
               </a:ext>
             </a:extLst>
           </p:cNvPr>
@@ -19771,7 +19771,7 @@
           <p:cNvPr id="22" name="">
             <a:extLst xmlns:a="http://schemas.openxmlformats.org/drawingml/2006/main">
               <a:ext uri="{FF2B5EF4-FFF2-40B4-BE49-F238E27FC236}">
-                <a16:creationId xmlns:a16="http://schemas.microsoft.com/office/drawing/2014/main" id="{A57DE650-6DFD-4007-90D2-1E66F40D36CA}"/>
+                <a16:creationId xmlns:a16="http://schemas.microsoft.com/office/drawing/2014/main" id="{13F7EAAF-BAB8-4ECB-BA3A-C4967CCD3388}"/>
               </a:ext>
             </a:extLst>
           </p:cNvPr>
@@ -19803,7 +19803,7 @@
           <p:cNvPr id="36" name="">
             <a:extLst xmlns:a="http://schemas.openxmlformats.org/drawingml/2006/main">
               <a:ext uri="{FF2B5EF4-FFF2-40B4-BE49-F238E27FC236}">
-                <a16:creationId xmlns:a16="http://schemas.microsoft.com/office/drawing/2014/main" id="{B8A7B0F6-D857-47D9-8AD0-E156B36B93B5}"/>
+                <a16:creationId xmlns:a16="http://schemas.microsoft.com/office/drawing/2014/main" id="{B6CC149A-3B00-44AD-848E-68D8267545C8}"/>
               </a:ext>
             </a:extLst>
           </p:cNvPr>
@@ -19966,7 +19966,7 @@
           <p:cNvPr id="2" name="">
             <a:extLst xmlns:a="http://schemas.openxmlformats.org/drawingml/2006/main">
               <a:ext uri="{FF2B5EF4-FFF2-40B4-BE49-F238E27FC236}">
-                <a16:creationId xmlns:a16="http://schemas.microsoft.com/office/drawing/2014/main" id="{631000CF-D190-4937-A886-D58ED2B0482A}"/>
+                <a16:creationId xmlns:a16="http://schemas.microsoft.com/office/drawing/2014/main" id="{32D45AC0-DC88-43E4-954A-BD69A72FD1FA}"/>
               </a:ext>
             </a:extLst>
           </p:cNvPr>
@@ -20129,7 +20129,7 @@
           <p:cNvPr id="3" name="">
             <a:extLst xmlns:a="http://schemas.openxmlformats.org/drawingml/2006/main">
               <a:ext uri="{FF2B5EF4-FFF2-40B4-BE49-F238E27FC236}">
-                <a16:creationId xmlns:a16="http://schemas.microsoft.com/office/drawing/2014/main" id="{4AAD75CF-00B0-4295-933C-3DFF1572D340}"/>
+                <a16:creationId xmlns:a16="http://schemas.microsoft.com/office/drawing/2014/main" id="{5E9E963A-B2C2-47EE-8EC3-8B782AFF3C37}"/>
               </a:ext>
             </a:extLst>
           </p:cNvPr>
@@ -20292,7 +20292,7 @@
           <p:cNvPr id="4" name="">
             <a:extLst xmlns:a="http://schemas.openxmlformats.org/drawingml/2006/main">
               <a:ext uri="{FF2B5EF4-FFF2-40B4-BE49-F238E27FC236}">
-                <a16:creationId xmlns:a16="http://schemas.microsoft.com/office/drawing/2014/main" id="{0CCB76E5-54BF-4BD9-9AFA-EEBAE8E70DE7}"/>
+                <a16:creationId xmlns:a16="http://schemas.microsoft.com/office/drawing/2014/main" id="{C99A34F8-4750-4F30-8024-3ACC0169C890}"/>
               </a:ext>
             </a:extLst>
           </p:cNvPr>
@@ -20327,7 +20327,7 @@
           <p:cNvPr id="5" name="">
             <a:extLst xmlns:a="http://schemas.openxmlformats.org/drawingml/2006/main">
               <a:ext uri="{FF2B5EF4-FFF2-40B4-BE49-F238E27FC236}">
-                <a16:creationId xmlns:a16="http://schemas.microsoft.com/office/drawing/2014/main" id="{52890F1D-ADA9-4ACA-A2D7-EEAB4FB60EEA}"/>
+                <a16:creationId xmlns:a16="http://schemas.microsoft.com/office/drawing/2014/main" id="{8273628F-A56D-45BA-A9D6-3083E638F286}"/>
               </a:ext>
             </a:extLst>
           </p:cNvPr>
@@ -20490,7 +20490,7 @@
           <p:cNvPr id="6" name="">
             <a:extLst xmlns:a="http://schemas.openxmlformats.org/drawingml/2006/main">
               <a:ext uri="{FF2B5EF4-FFF2-40B4-BE49-F238E27FC236}">
-                <a16:creationId xmlns:a16="http://schemas.microsoft.com/office/drawing/2014/main" id="{81075E3A-D236-4527-B80E-568FE77A79F8}"/>
+                <a16:creationId xmlns:a16="http://schemas.microsoft.com/office/drawing/2014/main" id="{16C7C4C3-81B5-4751-9BD7-AC91030A731B}"/>
               </a:ext>
             </a:extLst>
           </p:cNvPr>
@@ -20653,7 +20653,7 @@
           <p:cNvPr id="7" name="">
             <a:extLst xmlns:a="http://schemas.openxmlformats.org/drawingml/2006/main">
               <a:ext uri="{FF2B5EF4-FFF2-40B4-BE49-F238E27FC236}">
-                <a16:creationId xmlns:a16="http://schemas.microsoft.com/office/drawing/2014/main" id="{E2D677CE-50BD-49E5-A3F7-14C2F756AE76}"/>
+                <a16:creationId xmlns:a16="http://schemas.microsoft.com/office/drawing/2014/main" id="{939DF0E4-7A00-4659-8F80-4ECBF88BC66E}"/>
               </a:ext>
             </a:extLst>
           </p:cNvPr>
@@ -20688,7 +20688,7 @@
           <p:cNvPr id="8" name="">
             <a:extLst xmlns:a="http://schemas.openxmlformats.org/drawingml/2006/main">
               <a:ext uri="{FF2B5EF4-FFF2-40B4-BE49-F238E27FC236}">
-                <a16:creationId xmlns:a16="http://schemas.microsoft.com/office/drawing/2014/main" id="{8E17E2AE-2595-4754-9B6B-C33F7A64E193}"/>
+                <a16:creationId xmlns:a16="http://schemas.microsoft.com/office/drawing/2014/main" id="{ED1B62B4-2D02-4ECF-9187-13BAEAEBDFA1}"/>
               </a:ext>
             </a:extLst>
           </p:cNvPr>
@@ -20851,7 +20851,7 @@
           <p:cNvPr id="9" name="">
             <a:extLst xmlns:a="http://schemas.openxmlformats.org/drawingml/2006/main">
               <a:ext uri="{FF2B5EF4-FFF2-40B4-BE49-F238E27FC236}">
-                <a16:creationId xmlns:a16="http://schemas.microsoft.com/office/drawing/2014/main" id="{F381A2AA-6C84-4C79-8BD4-E12953C80133}"/>
+                <a16:creationId xmlns:a16="http://schemas.microsoft.com/office/drawing/2014/main" id="{7ED2CAF9-6418-4059-B9CF-3FF9871FE705}"/>
               </a:ext>
             </a:extLst>
           </p:cNvPr>
@@ -21014,7 +21014,7 @@
           <p:cNvPr id="10" name="">
             <a:extLst xmlns:a="http://schemas.openxmlformats.org/drawingml/2006/main">
               <a:ext uri="{FF2B5EF4-FFF2-40B4-BE49-F238E27FC236}">
-                <a16:creationId xmlns:a16="http://schemas.microsoft.com/office/drawing/2014/main" id="{80B0E432-74B0-4F3B-AC06-FA0B025A3273}"/>
+                <a16:creationId xmlns:a16="http://schemas.microsoft.com/office/drawing/2014/main" id="{FE86C041-5489-4041-BE59-050638CF33EC}"/>
               </a:ext>
             </a:extLst>
           </p:cNvPr>
@@ -21049,7 +21049,7 @@
           <p:cNvPr id="11" name="">
             <a:extLst xmlns:a="http://schemas.openxmlformats.org/drawingml/2006/main">
               <a:ext uri="{FF2B5EF4-FFF2-40B4-BE49-F238E27FC236}">
-                <a16:creationId xmlns:a16="http://schemas.microsoft.com/office/drawing/2014/main" id="{88E7F7F2-A321-4DE6-B06F-0518286B2113}"/>
+                <a16:creationId xmlns:a16="http://schemas.microsoft.com/office/drawing/2014/main" id="{D488EA42-2B03-44D0-A508-86CE385E354D}"/>
               </a:ext>
             </a:extLst>
           </p:cNvPr>
@@ -21212,7 +21212,7 @@
           <p:cNvPr id="12" name="">
             <a:extLst xmlns:a="http://schemas.openxmlformats.org/drawingml/2006/main">
               <a:ext uri="{FF2B5EF4-FFF2-40B4-BE49-F238E27FC236}">
-                <a16:creationId xmlns:a16="http://schemas.microsoft.com/office/drawing/2014/main" id="{2B4D6553-6CC9-47F6-991D-82FA0ED259A6}"/>
+                <a16:creationId xmlns:a16="http://schemas.microsoft.com/office/drawing/2014/main" id="{FE36D44F-A6CF-48CC-BF61-46FE4DDB8D80}"/>
               </a:ext>
             </a:extLst>
           </p:cNvPr>
@@ -21375,7 +21375,7 @@
           <p:cNvPr id="13" name="">
             <a:extLst xmlns:a="http://schemas.openxmlformats.org/drawingml/2006/main">
               <a:ext uri="{FF2B5EF4-FFF2-40B4-BE49-F238E27FC236}">
-                <a16:creationId xmlns:a16="http://schemas.microsoft.com/office/drawing/2014/main" id="{F30D9DB6-DA6B-41AA-8D82-AB736A764F03}"/>
+                <a16:creationId xmlns:a16="http://schemas.microsoft.com/office/drawing/2014/main" id="{26AB2E9D-DB21-4493-BCA3-987F8D8E0E34}"/>
               </a:ext>
             </a:extLst>
           </p:cNvPr>
@@ -21410,7 +21410,7 @@
           <p:cNvPr id="14" name="">
             <a:extLst xmlns:a="http://schemas.openxmlformats.org/drawingml/2006/main">
               <a:ext uri="{FF2B5EF4-FFF2-40B4-BE49-F238E27FC236}">
-                <a16:creationId xmlns:a16="http://schemas.microsoft.com/office/drawing/2014/main" id="{640A326B-5C2C-4E3B-BBB1-B5AB8A1DA197}"/>
+                <a16:creationId xmlns:a16="http://schemas.microsoft.com/office/drawing/2014/main" id="{DB0DE6FA-DB16-4D90-B456-7C3BE3419AAE}"/>
               </a:ext>
             </a:extLst>
           </p:cNvPr>
@@ -21573,7 +21573,7 @@
           <p:cNvPr id="15" name="">
             <a:extLst xmlns:a="http://schemas.openxmlformats.org/drawingml/2006/main">
               <a:ext uri="{FF2B5EF4-FFF2-40B4-BE49-F238E27FC236}">
-                <a16:creationId xmlns:a16="http://schemas.microsoft.com/office/drawing/2014/main" id="{AA493C23-3AA2-40CA-9A72-C6F1A76C569D}"/>
+                <a16:creationId xmlns:a16="http://schemas.microsoft.com/office/drawing/2014/main" id="{22EB7106-3A6F-4FE9-81EA-A9D15016F5F0}"/>
               </a:ext>
             </a:extLst>
           </p:cNvPr>
@@ -21736,7 +21736,7 @@
           <p:cNvPr id="16" name="">
             <a:extLst xmlns:a="http://schemas.openxmlformats.org/drawingml/2006/main">
               <a:ext uri="{FF2B5EF4-FFF2-40B4-BE49-F238E27FC236}">
-                <a16:creationId xmlns:a16="http://schemas.microsoft.com/office/drawing/2014/main" id="{7F11E809-10C7-4EB1-937C-D926AEE28413}"/>
+                <a16:creationId xmlns:a16="http://schemas.microsoft.com/office/drawing/2014/main" id="{6DE11E5F-2E92-4778-A3CB-CE25BF2C7707}"/>
               </a:ext>
             </a:extLst>
           </p:cNvPr>
@@ -21771,7 +21771,7 @@
           <p:cNvPr id="17" name="">
             <a:extLst xmlns:a="http://schemas.openxmlformats.org/drawingml/2006/main">
               <a:ext uri="{FF2B5EF4-FFF2-40B4-BE49-F238E27FC236}">
-                <a16:creationId xmlns:a16="http://schemas.microsoft.com/office/drawing/2014/main" id="{59EDFD2A-3177-4691-A5D6-8A5E030A92CE}"/>
+                <a16:creationId xmlns:a16="http://schemas.microsoft.com/office/drawing/2014/main" id="{708157BC-E489-469D-A1BC-25C5ED40ADB7}"/>
               </a:ext>
             </a:extLst>
           </p:cNvPr>
@@ -21934,7 +21934,7 @@
           <p:cNvPr id="18" name="">
             <a:extLst xmlns:a="http://schemas.openxmlformats.org/drawingml/2006/main">
               <a:ext uri="{FF2B5EF4-FFF2-40B4-BE49-F238E27FC236}">
-                <a16:creationId xmlns:a16="http://schemas.microsoft.com/office/drawing/2014/main" id="{E406C292-AB36-480B-8C35-26B998E73F2C}"/>
+                <a16:creationId xmlns:a16="http://schemas.microsoft.com/office/drawing/2014/main" id="{CBBF207B-E611-415B-8CFC-36F7EF8A993A}"/>
               </a:ext>
             </a:extLst>
           </p:cNvPr>
@@ -22097,7 +22097,7 @@
           <p:cNvPr id="19" name="">
             <a:extLst xmlns:a="http://schemas.openxmlformats.org/drawingml/2006/main">
               <a:ext uri="{FF2B5EF4-FFF2-40B4-BE49-F238E27FC236}">
-                <a16:creationId xmlns:a16="http://schemas.microsoft.com/office/drawing/2014/main" id="{F920E089-D3E8-4939-B818-C66F2814BB25}"/>
+                <a16:creationId xmlns:a16="http://schemas.microsoft.com/office/drawing/2014/main" id="{8BBEC0AA-EB08-470F-936B-6DC85B2C86C6}"/>
               </a:ext>
             </a:extLst>
           </p:cNvPr>
@@ -22132,7 +22132,7 @@
           <p:cNvPr id="20" name="">
             <a:extLst xmlns:a="http://schemas.openxmlformats.org/drawingml/2006/main">
               <a:ext uri="{FF2B5EF4-FFF2-40B4-BE49-F238E27FC236}">
-                <a16:creationId xmlns:a16="http://schemas.microsoft.com/office/drawing/2014/main" id="{9A3E7AC6-5ED4-4AC9-9506-B3507CEC5B2F}"/>
+                <a16:creationId xmlns:a16="http://schemas.microsoft.com/office/drawing/2014/main" id="{F3BDAD7F-4CFC-4DE7-BEA5-800804AE95A1}"/>
               </a:ext>
             </a:extLst>
           </p:cNvPr>
@@ -22295,7 +22295,7 @@
           <p:cNvPr id="21" name="">
             <a:extLst xmlns:a="http://schemas.openxmlformats.org/drawingml/2006/main">
               <a:ext uri="{FF2B5EF4-FFF2-40B4-BE49-F238E27FC236}">
-                <a16:creationId xmlns:a16="http://schemas.microsoft.com/office/drawing/2014/main" id="{E4B98BFC-0735-4204-A34A-D55D54E85558}"/>
+                <a16:creationId xmlns:a16="http://schemas.microsoft.com/office/drawing/2014/main" id="{8748F709-F338-4771-9DB3-CEF85292DDF2}"/>
               </a:ext>
             </a:extLst>
           </p:cNvPr>
@@ -22458,7 +22458,7 @@
           <p:cNvPr id="28" name="">
             <a:extLst xmlns:a="http://schemas.openxmlformats.org/drawingml/2006/main">
               <a:ext uri="{FF2B5EF4-FFF2-40B4-BE49-F238E27FC236}">
-                <a16:creationId xmlns:a16="http://schemas.microsoft.com/office/drawing/2014/main" id="{0364A0EB-811D-4E87-8FAA-0C0E44503280}"/>
+                <a16:creationId xmlns:a16="http://schemas.microsoft.com/office/drawing/2014/main" id="{3AB75B92-8403-4945-A790-F859BFCC7962}"/>
               </a:ext>
             </a:extLst>
           </p:cNvPr>
@@ -22491,7 +22491,7 @@
           <p:cNvPr id="29" name="">
             <a:extLst xmlns:a="http://schemas.openxmlformats.org/drawingml/2006/main">
               <a:ext uri="{FF2B5EF4-FFF2-40B4-BE49-F238E27FC236}">
-                <a16:creationId xmlns:a16="http://schemas.microsoft.com/office/drawing/2014/main" id="{F8A917E2-CBEC-483E-B3B8-BEAA174B0392}"/>
+                <a16:creationId xmlns:a16="http://schemas.microsoft.com/office/drawing/2014/main" id="{80D53784-FE2B-4BF3-9BF8-533A9E346C4C}"/>
               </a:ext>
             </a:extLst>
           </p:cNvPr>
@@ -22654,7 +22654,7 @@
           <p:cNvPr id="30" name="">
             <a:extLst xmlns:a="http://schemas.openxmlformats.org/drawingml/2006/main">
               <a:ext uri="{FF2B5EF4-FFF2-40B4-BE49-F238E27FC236}">
-                <a16:creationId xmlns:a16="http://schemas.microsoft.com/office/drawing/2014/main" id="{83C3A284-0E95-425D-978E-31CBAEDB2BE8}"/>
+                <a16:creationId xmlns:a16="http://schemas.microsoft.com/office/drawing/2014/main" id="{A68650CC-438E-424C-BECA-E7C5855AAD2B}"/>
               </a:ext>
             </a:extLst>
           </p:cNvPr>
@@ -22687,7 +22687,7 @@
           <p:cNvPr id="31" name="">
             <a:extLst xmlns:a="http://schemas.openxmlformats.org/drawingml/2006/main">
               <a:ext uri="{FF2B5EF4-FFF2-40B4-BE49-F238E27FC236}">
-                <a16:creationId xmlns:a16="http://schemas.microsoft.com/office/drawing/2014/main" id="{B2C42B32-B6AD-4BD4-8CA4-029B68A66D09}"/>
+                <a16:creationId xmlns:a16="http://schemas.microsoft.com/office/drawing/2014/main" id="{50DCDA14-BEA5-415B-BFB5-029F3BEA2A0A}"/>
               </a:ext>
             </a:extLst>
           </p:cNvPr>
@@ -22850,7 +22850,7 @@
           <p:cNvPr id="32" name="">
             <a:extLst xmlns:a="http://schemas.openxmlformats.org/drawingml/2006/main">
               <a:ext uri="{FF2B5EF4-FFF2-40B4-BE49-F238E27FC236}">
-                <a16:creationId xmlns:a16="http://schemas.microsoft.com/office/drawing/2014/main" id="{3462633F-B0C4-400D-94C7-FBCFCB9723DB}"/>
+                <a16:creationId xmlns:a16="http://schemas.microsoft.com/office/drawing/2014/main" id="{D87AFCB9-DE9E-4CA9-9C0E-6D688D2C7133}"/>
               </a:ext>
             </a:extLst>
           </p:cNvPr>
@@ -23013,7 +23013,7 @@
           <p:cNvPr id="33" name="">
             <a:extLst xmlns:a="http://schemas.openxmlformats.org/drawingml/2006/main">
               <a:ext uri="{FF2B5EF4-FFF2-40B4-BE49-F238E27FC236}">
-                <a16:creationId xmlns:a16="http://schemas.microsoft.com/office/drawing/2014/main" id="{A4841EBA-D7AB-449C-BF81-E3C228D91254}"/>
+                <a16:creationId xmlns:a16="http://schemas.microsoft.com/office/drawing/2014/main" id="{8869B955-B250-4AC0-9EC8-50D6A2E94C6E}"/>
               </a:ext>
             </a:extLst>
           </p:cNvPr>
@@ -23176,7 +23176,7 @@
           <p:cNvPr id="34" name="">
             <a:extLst xmlns:a="http://schemas.openxmlformats.org/drawingml/2006/main">
               <a:ext uri="{FF2B5EF4-FFF2-40B4-BE49-F238E27FC236}">
-                <a16:creationId xmlns:a16="http://schemas.microsoft.com/office/drawing/2014/main" id="{BBB9C2E5-4B46-4003-AD47-3F50D5B5B494}"/>
+                <a16:creationId xmlns:a16="http://schemas.microsoft.com/office/drawing/2014/main" id="{37869D86-EE01-4CB3-857B-8F2F385DA9ED}"/>
               </a:ext>
             </a:extLst>
           </p:cNvPr>
@@ -23339,7 +23339,7 @@
           <p:cNvPr id="35" name="">
             <a:extLst xmlns:a="http://schemas.openxmlformats.org/drawingml/2006/main">
               <a:ext uri="{FF2B5EF4-FFF2-40B4-BE49-F238E27FC236}">
-                <a16:creationId xmlns:a16="http://schemas.microsoft.com/office/drawing/2014/main" id="{FD5CDD3A-F61D-4C74-AA86-6CB2FDA66BB6}"/>
+                <a16:creationId xmlns:a16="http://schemas.microsoft.com/office/drawing/2014/main" id="{1F93A05F-62AE-4296-B286-DF3B7E4FA895}"/>
               </a:ext>
             </a:extLst>
           </p:cNvPr>
@@ -23500,7 +23500,7 @@
     </p:spTree>
     <p:extLst>
       <p:ext uri="{BB962C8B-B14F-4D97-AF65-F5344CB8AC3E}">
-        <p14:creationId xmlns:p14="http://schemas.microsoft.com/office/powerpoint/2010/main" val="1797549290"/>
+        <p14:creationId xmlns:p14="http://schemas.microsoft.com/office/powerpoint/2010/main" val="1375729944"/>
       </p:ext>
     </p:extLst>
   </p:cSld>
@@ -23531,7 +23531,7 @@
           <p:cNvPr id="21" name="">
             <a:extLst xmlns:a="http://schemas.openxmlformats.org/drawingml/2006/main">
               <a:ext uri="{FF2B5EF4-FFF2-40B4-BE49-F238E27FC236}">
-                <a16:creationId xmlns:a16="http://schemas.microsoft.com/office/drawing/2014/main" id="{BADB9F69-E3A4-4017-A047-ECEDA00E52FF}"/>
+                <a16:creationId xmlns:a16="http://schemas.microsoft.com/office/drawing/2014/main" id="{215C8358-08D0-43C0-88A0-AECA2192201A}"/>
               </a:ext>
             </a:extLst>
           </p:cNvPr>
@@ -23694,7 +23694,7 @@
           <p:cNvPr id="2" name="">
             <a:extLst xmlns:a="http://schemas.openxmlformats.org/drawingml/2006/main">
               <a:ext uri="{FF2B5EF4-FFF2-40B4-BE49-F238E27FC236}">
-                <a16:creationId xmlns:a16="http://schemas.microsoft.com/office/drawing/2014/main" id="{48FBD188-5568-40D9-9A63-5B20CA9A6789}"/>
+                <a16:creationId xmlns:a16="http://schemas.microsoft.com/office/drawing/2014/main" id="{6C49F297-7F9D-49B1-B3D0-7DB455CBD7C3}"/>
               </a:ext>
             </a:extLst>
           </p:cNvPr>
@@ -23857,7 +23857,7 @@
           <p:cNvPr id="3" name="">
             <a:extLst xmlns:a="http://schemas.openxmlformats.org/drawingml/2006/main">
               <a:ext uri="{FF2B5EF4-FFF2-40B4-BE49-F238E27FC236}">
-                <a16:creationId xmlns:a16="http://schemas.microsoft.com/office/drawing/2014/main" id="{0379A948-272B-4A45-8BB6-FB1D58B3293A}"/>
+                <a16:creationId xmlns:a16="http://schemas.microsoft.com/office/drawing/2014/main" id="{05106D66-EF75-4EC0-99AE-EF93CE153729}"/>
               </a:ext>
             </a:extLst>
           </p:cNvPr>
@@ -24020,7 +24020,7 @@
           <p:cNvPr id="4" name="">
             <a:extLst xmlns:a="http://schemas.openxmlformats.org/drawingml/2006/main">
               <a:ext uri="{FF2B5EF4-FFF2-40B4-BE49-F238E27FC236}">
-                <a16:creationId xmlns:a16="http://schemas.microsoft.com/office/drawing/2014/main" id="{2378BCCB-7EA6-4667-97CB-C4DD17F131D8}"/>
+                <a16:creationId xmlns:a16="http://schemas.microsoft.com/office/drawing/2014/main" id="{382005B8-2785-44B1-977D-211F83A72BAF}"/>
               </a:ext>
             </a:extLst>
           </p:cNvPr>
@@ -24053,7 +24053,7 @@
           <p:cNvPr id="5" name="">
             <a:extLst xmlns:a="http://schemas.openxmlformats.org/drawingml/2006/main">
               <a:ext uri="{FF2B5EF4-FFF2-40B4-BE49-F238E27FC236}">
-                <a16:creationId xmlns:a16="http://schemas.microsoft.com/office/drawing/2014/main" id="{4EB3DFB3-ECAD-4B2F-9180-DD7060A068C0}"/>
+                <a16:creationId xmlns:a16="http://schemas.microsoft.com/office/drawing/2014/main" id="{50BD340B-8AFF-4A9D-8BE6-67899BDF66E9}"/>
               </a:ext>
             </a:extLst>
           </p:cNvPr>
@@ -24063,7 +24063,7 @@
           <p:nvPr/>
         </p:nvPicPr>
         <p:blipFill>
-          <a:blip xmlns:r="http://schemas.openxmlformats.org/officeDocument/2006/relationships" xmlns:a="http://schemas.openxmlformats.org/drawingml/2006/main" r:embed="R40e8ab8c993040ca"/>
+          <a:blip xmlns:r="http://schemas.openxmlformats.org/officeDocument/2006/relationships" xmlns:a="http://schemas.openxmlformats.org/drawingml/2006/main" r:embed="Ra8677164b4ef4c1b"/>
           <a:srcRect xmlns:a="http://schemas.openxmlformats.org/drawingml/2006/main" l="0" t="0" r="0" b="12000"/>
           <a:stretch xmlns:a="http://schemas.openxmlformats.org/drawingml/2006/main"/>
         </p:blipFill>
@@ -24084,7 +24084,7 @@
           <p:cNvPr id="6" name="">
             <a:extLst xmlns:a="http://schemas.openxmlformats.org/drawingml/2006/main">
               <a:ext uri="{FF2B5EF4-FFF2-40B4-BE49-F238E27FC236}">
-                <a16:creationId xmlns:a16="http://schemas.microsoft.com/office/drawing/2014/main" id="{DCAA9C07-EC30-4BA3-B10B-8CAA4D082509}"/>
+                <a16:creationId xmlns:a16="http://schemas.microsoft.com/office/drawing/2014/main" id="{6E1711FF-9E0B-48B2-A9E7-8540184A4D26}"/>
               </a:ext>
             </a:extLst>
           </p:cNvPr>
@@ -24117,7 +24117,7 @@
           <p:cNvPr id="7" name="">
             <a:extLst xmlns:a="http://schemas.openxmlformats.org/drawingml/2006/main">
               <a:ext uri="{FF2B5EF4-FFF2-40B4-BE49-F238E27FC236}">
-                <a16:creationId xmlns:a16="http://schemas.microsoft.com/office/drawing/2014/main" id="{98F2EC79-88AC-4AB9-8D54-636A66C1AF26}"/>
+                <a16:creationId xmlns:a16="http://schemas.microsoft.com/office/drawing/2014/main" id="{5E45B8F5-2F3C-46D1-8AE6-6E5136F7F99B}"/>
               </a:ext>
             </a:extLst>
           </p:cNvPr>
@@ -24280,7 +24280,7 @@
           <p:cNvPr id="8" name="">
             <a:extLst xmlns:a="http://schemas.openxmlformats.org/drawingml/2006/main">
               <a:ext uri="{FF2B5EF4-FFF2-40B4-BE49-F238E27FC236}">
-                <a16:creationId xmlns:a16="http://schemas.microsoft.com/office/drawing/2014/main" id="{E189C4ED-2D3D-4A5E-90E8-75862390D05F}"/>
+                <a16:creationId xmlns:a16="http://schemas.microsoft.com/office/drawing/2014/main" id="{3B26A1D8-BB81-4766-BAF6-8A2A3E6A5C67}"/>
               </a:ext>
             </a:extLst>
           </p:cNvPr>
@@ -24443,7 +24443,7 @@
           <p:cNvPr id="9" name="">
             <a:extLst xmlns:a="http://schemas.openxmlformats.org/drawingml/2006/main">
               <a:ext uri="{FF2B5EF4-FFF2-40B4-BE49-F238E27FC236}">
-                <a16:creationId xmlns:a16="http://schemas.microsoft.com/office/drawing/2014/main" id="{AB73EE6C-DB2D-43C8-98D3-D7FE12009B17}"/>
+                <a16:creationId xmlns:a16="http://schemas.microsoft.com/office/drawing/2014/main" id="{BA362704-6FAE-4E0B-9647-F5E33B13E002}"/>
               </a:ext>
             </a:extLst>
           </p:cNvPr>
@@ -24606,7 +24606,7 @@
           <p:cNvPr id="10" name="">
             <a:extLst xmlns:a="http://schemas.openxmlformats.org/drawingml/2006/main">
               <a:ext uri="{FF2B5EF4-FFF2-40B4-BE49-F238E27FC236}">
-                <a16:creationId xmlns:a16="http://schemas.microsoft.com/office/drawing/2014/main" id="{12140E1D-FDA4-4D1E-B6D1-61646DC2DC3F}"/>
+                <a16:creationId xmlns:a16="http://schemas.microsoft.com/office/drawing/2014/main" id="{8A4B4ED4-2F5E-4804-B88F-86D3071C4E13}"/>
               </a:ext>
             </a:extLst>
           </p:cNvPr>
@@ -24769,7 +24769,7 @@
           <p:cNvPr id="11" name="">
             <a:extLst xmlns:a="http://schemas.openxmlformats.org/drawingml/2006/main">
               <a:ext uri="{FF2B5EF4-FFF2-40B4-BE49-F238E27FC236}">
-                <a16:creationId xmlns:a16="http://schemas.microsoft.com/office/drawing/2014/main" id="{1E1C68B4-DD79-4A0A-832E-1B4BFFB5E7C9}"/>
+                <a16:creationId xmlns:a16="http://schemas.microsoft.com/office/drawing/2014/main" id="{6AB8C3E6-D4AF-4852-AD44-5144CD7F10E9}"/>
               </a:ext>
             </a:extLst>
           </p:cNvPr>
@@ -24932,7 +24932,7 @@
           <p:cNvPr id="12" name="">
             <a:extLst xmlns:a="http://schemas.openxmlformats.org/drawingml/2006/main">
               <a:ext uri="{FF2B5EF4-FFF2-40B4-BE49-F238E27FC236}">
-                <a16:creationId xmlns:a16="http://schemas.microsoft.com/office/drawing/2014/main" id="{DED19E53-AEDC-47F1-8841-5742051E658E}"/>
+                <a16:creationId xmlns:a16="http://schemas.microsoft.com/office/drawing/2014/main" id="{B5E6762F-BE4D-4B2D-A283-326C5C279E72}"/>
               </a:ext>
             </a:extLst>
           </p:cNvPr>
@@ -25095,7 +25095,7 @@
           <p:cNvPr id="13" name="">
             <a:extLst xmlns:a="http://schemas.openxmlformats.org/drawingml/2006/main">
               <a:ext uri="{FF2B5EF4-FFF2-40B4-BE49-F238E27FC236}">
-                <a16:creationId xmlns:a16="http://schemas.microsoft.com/office/drawing/2014/main" id="{711414C1-DAF1-498D-9579-9C8E395CFDAB}"/>
+                <a16:creationId xmlns:a16="http://schemas.microsoft.com/office/drawing/2014/main" id="{32F89B47-B305-4671-A00A-98AB60807F8E}"/>
               </a:ext>
             </a:extLst>
           </p:cNvPr>
@@ -25258,7 +25258,7 @@
           <p:cNvPr id="14" name="">
             <a:extLst xmlns:a="http://schemas.openxmlformats.org/drawingml/2006/main">
               <a:ext uri="{FF2B5EF4-FFF2-40B4-BE49-F238E27FC236}">
-                <a16:creationId xmlns:a16="http://schemas.microsoft.com/office/drawing/2014/main" id="{E85842EB-2D34-48C0-B5EB-A9BA0A929801}"/>
+                <a16:creationId xmlns:a16="http://schemas.microsoft.com/office/drawing/2014/main" id="{F88B8FAB-2DC1-486C-B9A5-99C9CC006968}"/>
               </a:ext>
             </a:extLst>
           </p:cNvPr>
@@ -25421,7 +25421,7 @@
           <p:cNvPr id="15" name="">
             <a:extLst xmlns:a="http://schemas.openxmlformats.org/drawingml/2006/main">
               <a:ext uri="{FF2B5EF4-FFF2-40B4-BE49-F238E27FC236}">
-                <a16:creationId xmlns:a16="http://schemas.microsoft.com/office/drawing/2014/main" id="{9ACA650C-1254-4F3B-8F13-555BBCA782D3}"/>
+                <a16:creationId xmlns:a16="http://schemas.microsoft.com/office/drawing/2014/main" id="{9181BE74-D98D-4465-91F9-55E51AAE3B33}"/>
               </a:ext>
             </a:extLst>
           </p:cNvPr>
@@ -25584,7 +25584,7 @@
           <p:cNvPr id="16" name="">
             <a:extLst xmlns:a="http://schemas.openxmlformats.org/drawingml/2006/main">
               <a:ext uri="{FF2B5EF4-FFF2-40B4-BE49-F238E27FC236}">
-                <a16:creationId xmlns:a16="http://schemas.microsoft.com/office/drawing/2014/main" id="{2AD36ECA-41E2-447B-BF7A-4F50FCC5FA60}"/>
+                <a16:creationId xmlns:a16="http://schemas.microsoft.com/office/drawing/2014/main" id="{51ECD3B2-205A-4853-A975-012D40786A71}"/>
               </a:ext>
             </a:extLst>
           </p:cNvPr>
@@ -25747,7 +25747,7 @@
           <p:cNvPr id="17" name="">
             <a:extLst xmlns:a="http://schemas.openxmlformats.org/drawingml/2006/main">
               <a:ext uri="{FF2B5EF4-FFF2-40B4-BE49-F238E27FC236}">
-                <a16:creationId xmlns:a16="http://schemas.microsoft.com/office/drawing/2014/main" id="{A816A15A-F6FC-4290-BDF8-5DB47B3ECD2E}"/>
+                <a16:creationId xmlns:a16="http://schemas.microsoft.com/office/drawing/2014/main" id="{94721CC6-59B4-4932-A3BD-C0D08022C01E}"/>
               </a:ext>
             </a:extLst>
           </p:cNvPr>
@@ -25782,7 +25782,7 @@
           <p:cNvPr id="18" name="">
             <a:extLst xmlns:a="http://schemas.openxmlformats.org/drawingml/2006/main">
               <a:ext uri="{FF2B5EF4-FFF2-40B4-BE49-F238E27FC236}">
-                <a16:creationId xmlns:a16="http://schemas.microsoft.com/office/drawing/2014/main" id="{A214EF0E-19DA-4806-A76F-23622BC4494C}"/>
+                <a16:creationId xmlns:a16="http://schemas.microsoft.com/office/drawing/2014/main" id="{0ED1F06B-783D-4209-AC53-FCEDA14DC2DD}"/>
               </a:ext>
             </a:extLst>
           </p:cNvPr>
@@ -25945,7 +25945,7 @@
           <p:cNvPr id="19" name="">
             <a:extLst xmlns:a="http://schemas.openxmlformats.org/drawingml/2006/main">
               <a:ext uri="{FF2B5EF4-FFF2-40B4-BE49-F238E27FC236}">
-                <a16:creationId xmlns:a16="http://schemas.microsoft.com/office/drawing/2014/main" id="{6836A53C-D400-46E0-97CC-882CCCA6785F}"/>
+                <a16:creationId xmlns:a16="http://schemas.microsoft.com/office/drawing/2014/main" id="{F14B1FC3-68EF-4065-97AD-E6C4B43447D4}"/>
               </a:ext>
             </a:extLst>
           </p:cNvPr>
@@ -26108,7 +26108,7 @@
           <p:cNvPr id="20" name="">
             <a:extLst xmlns:a="http://schemas.openxmlformats.org/drawingml/2006/main">
               <a:ext uri="{FF2B5EF4-FFF2-40B4-BE49-F238E27FC236}">
-                <a16:creationId xmlns:a16="http://schemas.microsoft.com/office/drawing/2014/main" id="{485E54D9-5695-4465-A0DE-E34168FD0E83}"/>
+                <a16:creationId xmlns:a16="http://schemas.microsoft.com/office/drawing/2014/main" id="{A889E153-0349-4656-B3B9-BCD58C0FCE2C}"/>
               </a:ext>
             </a:extLst>
           </p:cNvPr>
@@ -26269,7 +26269,7 @@
     </p:spTree>
     <p:extLst>
       <p:ext uri="{BB962C8B-B14F-4D97-AF65-F5344CB8AC3E}">
-        <p14:creationId xmlns:p14="http://schemas.microsoft.com/office/powerpoint/2010/main" val="1670856873"/>
+        <p14:creationId xmlns:p14="http://schemas.microsoft.com/office/powerpoint/2010/main" val="434831781"/>
       </p:ext>
     </p:extLst>
   </p:cSld>
@@ -26300,7 +26300,7 @@
           <p:cNvPr id="28" name="">
             <a:extLst xmlns:a="http://schemas.openxmlformats.org/drawingml/2006/main">
               <a:ext uri="{FF2B5EF4-FFF2-40B4-BE49-F238E27FC236}">
-                <a16:creationId xmlns:a16="http://schemas.microsoft.com/office/drawing/2014/main" id="{673BBE7D-5B44-4073-95D3-1004512B4F88}"/>
+                <a16:creationId xmlns:a16="http://schemas.microsoft.com/office/drawing/2014/main" id="{728F1AF3-F437-46FC-B42F-F506BE50CCCF}"/>
               </a:ext>
             </a:extLst>
           </p:cNvPr>
@@ -26463,7 +26463,7 @@
           <p:cNvPr id="2" name="">
             <a:extLst xmlns:a="http://schemas.openxmlformats.org/drawingml/2006/main">
               <a:ext uri="{FF2B5EF4-FFF2-40B4-BE49-F238E27FC236}">
-                <a16:creationId xmlns:a16="http://schemas.microsoft.com/office/drawing/2014/main" id="{DB603A2E-85AA-40C2-88B6-9154CCFEF501}"/>
+                <a16:creationId xmlns:a16="http://schemas.microsoft.com/office/drawing/2014/main" id="{E18E08A7-22FB-4217-AF5A-F51D09713C1E}"/>
               </a:ext>
             </a:extLst>
           </p:cNvPr>
@@ -26626,7 +26626,7 @@
           <p:cNvPr id="3" name="">
             <a:extLst xmlns:a="http://schemas.openxmlformats.org/drawingml/2006/main">
               <a:ext uri="{FF2B5EF4-FFF2-40B4-BE49-F238E27FC236}">
-                <a16:creationId xmlns:a16="http://schemas.microsoft.com/office/drawing/2014/main" id="{0947A8B9-4DC5-4087-8918-4027CD9AA6E3}"/>
+                <a16:creationId xmlns:a16="http://schemas.microsoft.com/office/drawing/2014/main" id="{82F9C2AB-8D87-446B-AFFC-92136E0EC0C2}"/>
               </a:ext>
             </a:extLst>
           </p:cNvPr>
@@ -26789,7 +26789,7 @@
           <p:cNvPr id="4" name="">
             <a:extLst xmlns:a="http://schemas.openxmlformats.org/drawingml/2006/main">
               <a:ext uri="{FF2B5EF4-FFF2-40B4-BE49-F238E27FC236}">
-                <a16:creationId xmlns:a16="http://schemas.microsoft.com/office/drawing/2014/main" id="{5EC5478E-7584-4FA5-84E6-33BC7299796E}"/>
+                <a16:creationId xmlns:a16="http://schemas.microsoft.com/office/drawing/2014/main" id="{D9DBB39C-BBCA-4F62-87DE-96BC84A0A1C9}"/>
               </a:ext>
             </a:extLst>
           </p:cNvPr>
@@ -26952,7 +26952,7 @@
           <p:cNvPr id="5" name="">
             <a:extLst xmlns:a="http://schemas.openxmlformats.org/drawingml/2006/main">
               <a:ext uri="{FF2B5EF4-FFF2-40B4-BE49-F238E27FC236}">
-                <a16:creationId xmlns:a16="http://schemas.microsoft.com/office/drawing/2014/main" id="{03B4200A-AC84-4F4E-8AA7-97E0608754A1}"/>
+                <a16:creationId xmlns:a16="http://schemas.microsoft.com/office/drawing/2014/main" id="{5A271CC9-EC03-400D-A03C-9DAA4800CD80}"/>
               </a:ext>
             </a:extLst>
           </p:cNvPr>
@@ -27115,7 +27115,7 @@
           <p:cNvPr id="6" name="">
             <a:extLst xmlns:a="http://schemas.openxmlformats.org/drawingml/2006/main">
               <a:ext uri="{FF2B5EF4-FFF2-40B4-BE49-F238E27FC236}">
-                <a16:creationId xmlns:a16="http://schemas.microsoft.com/office/drawing/2014/main" id="{E924D8B7-AF7E-46DE-83F6-E4C0EEACEAC0}"/>
+                <a16:creationId xmlns:a16="http://schemas.microsoft.com/office/drawing/2014/main" id="{E7EC0AF9-AB99-4062-846C-AEDCC46A331D}"/>
               </a:ext>
             </a:extLst>
           </p:cNvPr>
@@ -27278,7 +27278,7 @@
           <p:cNvPr id="7" name="">
             <a:extLst xmlns:a="http://schemas.openxmlformats.org/drawingml/2006/main">
               <a:ext uri="{FF2B5EF4-FFF2-40B4-BE49-F238E27FC236}">
-                <a16:creationId xmlns:a16="http://schemas.microsoft.com/office/drawing/2014/main" id="{5BD5B702-7E81-4904-9DFC-C4A8832B0F1E}"/>
+                <a16:creationId xmlns:a16="http://schemas.microsoft.com/office/drawing/2014/main" id="{76D82137-6E26-4B7F-9897-9EE3FC2985D2}"/>
               </a:ext>
             </a:extLst>
           </p:cNvPr>
@@ -27441,7 +27441,7 @@
           <p:cNvPr id="8" name="">
             <a:extLst xmlns:a="http://schemas.openxmlformats.org/drawingml/2006/main">
               <a:ext uri="{FF2B5EF4-FFF2-40B4-BE49-F238E27FC236}">
-                <a16:creationId xmlns:a16="http://schemas.microsoft.com/office/drawing/2014/main" id="{731A9840-D630-4BAA-B498-5C6D2A5293F8}"/>
+                <a16:creationId xmlns:a16="http://schemas.microsoft.com/office/drawing/2014/main" id="{E208DEB6-BFD3-48BB-B86E-87305A0BBD15}"/>
               </a:ext>
             </a:extLst>
           </p:cNvPr>
@@ -27604,7 +27604,7 @@
           <p:cNvPr id="9" name="">
             <a:extLst xmlns:a="http://schemas.openxmlformats.org/drawingml/2006/main">
               <a:ext uri="{FF2B5EF4-FFF2-40B4-BE49-F238E27FC236}">
-                <a16:creationId xmlns:a16="http://schemas.microsoft.com/office/drawing/2014/main" id="{6960D5D6-118F-49A2-B4CA-09D83D52F3B8}"/>
+                <a16:creationId xmlns:a16="http://schemas.microsoft.com/office/drawing/2014/main" id="{7886C6AC-9551-4B60-90D6-428BBB40F11A}"/>
               </a:ext>
             </a:extLst>
           </p:cNvPr>
@@ -27767,7 +27767,7 @@
           <p:cNvPr id="10" name="">
             <a:extLst xmlns:a="http://schemas.openxmlformats.org/drawingml/2006/main">
               <a:ext uri="{FF2B5EF4-FFF2-40B4-BE49-F238E27FC236}">
-                <a16:creationId xmlns:a16="http://schemas.microsoft.com/office/drawing/2014/main" id="{7BE1C340-9D1D-48DA-94D1-0204C676F8CD}"/>
+                <a16:creationId xmlns:a16="http://schemas.microsoft.com/office/drawing/2014/main" id="{28B28DD5-6B3C-4E1B-9C08-852B9672E6E7}"/>
               </a:ext>
             </a:extLst>
           </p:cNvPr>
@@ -27930,7 +27930,7 @@
           <p:cNvPr id="11" name="">
             <a:extLst xmlns:a="http://schemas.openxmlformats.org/drawingml/2006/main">
               <a:ext uri="{FF2B5EF4-FFF2-40B4-BE49-F238E27FC236}">
-                <a16:creationId xmlns:a16="http://schemas.microsoft.com/office/drawing/2014/main" id="{ADC4F3AB-0E8E-41CB-881F-54F7AEFEB61A}"/>
+                <a16:creationId xmlns:a16="http://schemas.microsoft.com/office/drawing/2014/main" id="{B9946DA0-4959-4452-AEA0-53148F7D3BC4}"/>
               </a:ext>
             </a:extLst>
           </p:cNvPr>
@@ -28093,7 +28093,7 @@
           <p:cNvPr id="12" name="">
             <a:extLst xmlns:a="http://schemas.openxmlformats.org/drawingml/2006/main">
               <a:ext uri="{FF2B5EF4-FFF2-40B4-BE49-F238E27FC236}">
-                <a16:creationId xmlns:a16="http://schemas.microsoft.com/office/drawing/2014/main" id="{CA32F365-DB6F-43B9-AFE0-457DC04C921F}"/>
+                <a16:creationId xmlns:a16="http://schemas.microsoft.com/office/drawing/2014/main" id="{AD900690-8DB4-4C74-84CB-17208B96DFB5}"/>
               </a:ext>
             </a:extLst>
           </p:cNvPr>
@@ -28256,7 +28256,7 @@
           <p:cNvPr id="13" name="">
             <a:extLst xmlns:a="http://schemas.openxmlformats.org/drawingml/2006/main">
               <a:ext uri="{FF2B5EF4-FFF2-40B4-BE49-F238E27FC236}">
-                <a16:creationId xmlns:a16="http://schemas.microsoft.com/office/drawing/2014/main" id="{72558CC9-FA3E-41DB-AB35-3ECAF4E2261C}"/>
+                <a16:creationId xmlns:a16="http://schemas.microsoft.com/office/drawing/2014/main" id="{7830DC82-E331-44A0-93CA-37D1F8F8AC26}"/>
               </a:ext>
             </a:extLst>
           </p:cNvPr>
@@ -28289,7 +28289,7 @@
           <p:cNvPr id="14" name="">
             <a:extLst xmlns:a="http://schemas.openxmlformats.org/drawingml/2006/main">
               <a:ext uri="{FF2B5EF4-FFF2-40B4-BE49-F238E27FC236}">
-                <a16:creationId xmlns:a16="http://schemas.microsoft.com/office/drawing/2014/main" id="{09C28642-0BB2-434F-B43F-3542F68453D7}"/>
+                <a16:creationId xmlns:a16="http://schemas.microsoft.com/office/drawing/2014/main" id="{E843D8F2-DC6E-4562-BD01-14C9959AEEE8}"/>
               </a:ext>
             </a:extLst>
           </p:cNvPr>
@@ -28452,7 +28452,7 @@
           <p:cNvPr id="15" name="">
             <a:extLst xmlns:a="http://schemas.openxmlformats.org/drawingml/2006/main">
               <a:ext uri="{FF2B5EF4-FFF2-40B4-BE49-F238E27FC236}">
-                <a16:creationId xmlns:a16="http://schemas.microsoft.com/office/drawing/2014/main" id="{1C1B4E46-0AB9-4C4E-B2DE-B0713BD2FF97}"/>
+                <a16:creationId xmlns:a16="http://schemas.microsoft.com/office/drawing/2014/main" id="{BBB3904B-CC34-4706-8CCC-3CA75FFC9661}"/>
               </a:ext>
             </a:extLst>
           </p:cNvPr>
@@ -28485,7 +28485,7 @@
           <p:cNvPr id="16" name="">
             <a:extLst xmlns:a="http://schemas.openxmlformats.org/drawingml/2006/main">
               <a:ext uri="{FF2B5EF4-FFF2-40B4-BE49-F238E27FC236}">
-                <a16:creationId xmlns:a16="http://schemas.microsoft.com/office/drawing/2014/main" id="{33030177-4646-437D-85F5-BB7F6891662D}"/>
+                <a16:creationId xmlns:a16="http://schemas.microsoft.com/office/drawing/2014/main" id="{46D83772-6ADE-4850-AEA8-899563E84A2E}"/>
               </a:ext>
             </a:extLst>
           </p:cNvPr>
@@ -28648,7 +28648,7 @@
           <p:cNvPr id="17" name="">
             <a:extLst xmlns:a="http://schemas.openxmlformats.org/drawingml/2006/main">
               <a:ext uri="{FF2B5EF4-FFF2-40B4-BE49-F238E27FC236}">
-                <a16:creationId xmlns:a16="http://schemas.microsoft.com/office/drawing/2014/main" id="{3D19CC86-2F74-41ED-8D63-A024617B88DA}"/>
+                <a16:creationId xmlns:a16="http://schemas.microsoft.com/office/drawing/2014/main" id="{AB899DD2-AF43-4225-B2E0-00F2D9FD7BDF}"/>
               </a:ext>
             </a:extLst>
           </p:cNvPr>
@@ -28681,7 +28681,7 @@
           <p:cNvPr id="18" name="">
             <a:extLst xmlns:a="http://schemas.openxmlformats.org/drawingml/2006/main">
               <a:ext uri="{FF2B5EF4-FFF2-40B4-BE49-F238E27FC236}">
-                <a16:creationId xmlns:a16="http://schemas.microsoft.com/office/drawing/2014/main" id="{17B3A77C-766C-4325-B5ED-499760546427}"/>
+                <a16:creationId xmlns:a16="http://schemas.microsoft.com/office/drawing/2014/main" id="{7AE57D50-24F6-43AE-B0E7-68B2EB0D646E}"/>
               </a:ext>
             </a:extLst>
           </p:cNvPr>
@@ -28844,7 +28844,7 @@
           <p:cNvPr id="19" name="">
             <a:extLst xmlns:a="http://schemas.openxmlformats.org/drawingml/2006/main">
               <a:ext uri="{FF2B5EF4-FFF2-40B4-BE49-F238E27FC236}">
-                <a16:creationId xmlns:a16="http://schemas.microsoft.com/office/drawing/2014/main" id="{029086C5-C8B8-4D47-AA11-39DED53AF632}"/>
+                <a16:creationId xmlns:a16="http://schemas.microsoft.com/office/drawing/2014/main" id="{F67A6B12-6BD8-4E21-90C3-11D9732908C4}"/>
               </a:ext>
             </a:extLst>
           </p:cNvPr>
@@ -29007,7 +29007,7 @@
           <p:cNvPr id="20" name="">
             <a:extLst xmlns:a="http://schemas.openxmlformats.org/drawingml/2006/main">
               <a:ext uri="{FF2B5EF4-FFF2-40B4-BE49-F238E27FC236}">
-                <a16:creationId xmlns:a16="http://schemas.microsoft.com/office/drawing/2014/main" id="{B738747C-AB42-4FFF-BD77-14E5BCE4FC95}"/>
+                <a16:creationId xmlns:a16="http://schemas.microsoft.com/office/drawing/2014/main" id="{FD56C8BF-C728-4F0B-9702-4D0CDAF32B57}"/>
               </a:ext>
             </a:extLst>
           </p:cNvPr>
@@ -29040,7 +29040,7 @@
           <p:cNvPr id="21" name="">
             <a:extLst xmlns:a="http://schemas.openxmlformats.org/drawingml/2006/main">
               <a:ext uri="{FF2B5EF4-FFF2-40B4-BE49-F238E27FC236}">
-                <a16:creationId xmlns:a16="http://schemas.microsoft.com/office/drawing/2014/main" id="{CAE346F1-B070-4FD1-B735-F075C277882D}"/>
+                <a16:creationId xmlns:a16="http://schemas.microsoft.com/office/drawing/2014/main" id="{9D85EC39-DBBF-42CD-B833-2B14C21A0EB7}"/>
               </a:ext>
             </a:extLst>
           </p:cNvPr>
@@ -29203,7 +29203,7 @@
           <p:cNvPr id="22" name="">
             <a:extLst xmlns:a="http://schemas.openxmlformats.org/drawingml/2006/main">
               <a:ext uri="{FF2B5EF4-FFF2-40B4-BE49-F238E27FC236}">
-                <a16:creationId xmlns:a16="http://schemas.microsoft.com/office/drawing/2014/main" id="{31D64F46-3372-4D75-A636-4F66A651F6F8}"/>
+                <a16:creationId xmlns:a16="http://schemas.microsoft.com/office/drawing/2014/main" id="{7BC8C75C-F87E-4B89-992A-4FD62A19D3D5}"/>
               </a:ext>
             </a:extLst>
           </p:cNvPr>
@@ -29236,7 +29236,7 @@
           <p:cNvPr id="23" name="">
             <a:extLst xmlns:a="http://schemas.openxmlformats.org/drawingml/2006/main">
               <a:ext uri="{FF2B5EF4-FFF2-40B4-BE49-F238E27FC236}">
-                <a16:creationId xmlns:a16="http://schemas.microsoft.com/office/drawing/2014/main" id="{5A5F4F50-4562-470D-AFB5-B7E691D9733B}"/>
+                <a16:creationId xmlns:a16="http://schemas.microsoft.com/office/drawing/2014/main" id="{10B39041-17FF-4CFC-870F-7682D16C5639}"/>
               </a:ext>
             </a:extLst>
           </p:cNvPr>
@@ -29399,7 +29399,7 @@
           <p:cNvPr id="24" name="">
             <a:extLst xmlns:a="http://schemas.openxmlformats.org/drawingml/2006/main">
               <a:ext uri="{FF2B5EF4-FFF2-40B4-BE49-F238E27FC236}">
-                <a16:creationId xmlns:a16="http://schemas.microsoft.com/office/drawing/2014/main" id="{1063931A-CC5D-42FC-84BE-C40CBED54DA0}"/>
+                <a16:creationId xmlns:a16="http://schemas.microsoft.com/office/drawing/2014/main" id="{76E29B50-6C8A-4A2C-AB47-E605163E9CA3}"/>
               </a:ext>
             </a:extLst>
           </p:cNvPr>
@@ -29432,7 +29432,7 @@
           <p:cNvPr id="25" name="">
             <a:extLst xmlns:a="http://schemas.openxmlformats.org/drawingml/2006/main">
               <a:ext uri="{FF2B5EF4-FFF2-40B4-BE49-F238E27FC236}">
-                <a16:creationId xmlns:a16="http://schemas.microsoft.com/office/drawing/2014/main" id="{7A22DCDF-C13C-44D5-AC6A-3B86C3D9F361}"/>
+                <a16:creationId xmlns:a16="http://schemas.microsoft.com/office/drawing/2014/main" id="{9CE76231-53BD-4C3C-8378-0FDECF7062A8}"/>
               </a:ext>
             </a:extLst>
           </p:cNvPr>
@@ -29595,7 +29595,7 @@
           <p:cNvPr id="26" name="">
             <a:extLst xmlns:a="http://schemas.openxmlformats.org/drawingml/2006/main">
               <a:ext uri="{FF2B5EF4-FFF2-40B4-BE49-F238E27FC236}">
-                <a16:creationId xmlns:a16="http://schemas.microsoft.com/office/drawing/2014/main" id="{BD6D9504-47C6-4AB8-8451-49C595F5D2D0}"/>
+                <a16:creationId xmlns:a16="http://schemas.microsoft.com/office/drawing/2014/main" id="{9F4E2C38-62B5-4478-96EA-290EFB998A81}"/>
               </a:ext>
             </a:extLst>
           </p:cNvPr>
@@ -29758,7 +29758,7 @@
           <p:cNvPr id="27" name="">
             <a:extLst xmlns:a="http://schemas.openxmlformats.org/drawingml/2006/main">
               <a:ext uri="{FF2B5EF4-FFF2-40B4-BE49-F238E27FC236}">
-                <a16:creationId xmlns:a16="http://schemas.microsoft.com/office/drawing/2014/main" id="{128E6E5E-934B-47F9-8337-6427078C4DB7}"/>
+                <a16:creationId xmlns:a16="http://schemas.microsoft.com/office/drawing/2014/main" id="{0E3A6034-42AD-48F2-8278-7AFDFF774084}"/>
               </a:ext>
             </a:extLst>
           </p:cNvPr>
@@ -29919,7 +29919,7 @@
     </p:spTree>
     <p:extLst>
       <p:ext uri="{BB962C8B-B14F-4D97-AF65-F5344CB8AC3E}">
-        <p14:creationId xmlns:p14="http://schemas.microsoft.com/office/powerpoint/2010/main" val="549891152"/>
+        <p14:creationId xmlns:p14="http://schemas.microsoft.com/office/powerpoint/2010/main" val="1321173260"/>
       </p:ext>
     </p:extLst>
   </p:cSld>

</xml_diff>

<commit_message>
Polish proposal deck and add presentation script
</commit_message>
<xml_diff>
--- a/docs/Smart_Grocery_Agents_Project_Proposal.pptx
+++ b/docs/Smart_Grocery_Agents_Project_Proposal.pptx
@@ -2,20 +2,20 @@
 <file path=ppt/presentation.xml><?xml version="1.0" encoding="utf-8"?>
 <p:presentation xmlns:p="http://schemas.openxmlformats.org/presentationml/2006/main">
   <p:sldMasterIdLst>
-    <p:sldMasterId xmlns:r="http://schemas.openxmlformats.org/officeDocument/2006/relationships" id="2147483648" r:id="R1390041177074e36"/>
+    <p:sldMasterId xmlns:r="http://schemas.openxmlformats.org/officeDocument/2006/relationships" id="2147483648" r:id="R8987650c44e04c93"/>
   </p:sldMasterIdLst>
   <p:notesMasterIdLst>
-    <p:notesMasterId xmlns:r="http://schemas.openxmlformats.org/officeDocument/2006/relationships" r:id="Rdfde71b491514b24"/>
+    <p:notesMasterId xmlns:r="http://schemas.openxmlformats.org/officeDocument/2006/relationships" r:id="R4243ff7c0d824372"/>
   </p:notesMasterIdLst>
   <p:sldIdLst>
-    <p:sldId xmlns:r="http://schemas.openxmlformats.org/officeDocument/2006/relationships" id="256" r:id="R460552b6351c4427"/>
-    <p:sldId xmlns:r="http://schemas.openxmlformats.org/officeDocument/2006/relationships" id="257" r:id="R0d1a5d2677724e96"/>
-    <p:sldId xmlns:r="http://schemas.openxmlformats.org/officeDocument/2006/relationships" id="258" r:id="Rfed75943664044d2"/>
-    <p:sldId xmlns:r="http://schemas.openxmlformats.org/officeDocument/2006/relationships" id="259" r:id="R7eeb18bf5afd4de8"/>
-    <p:sldId xmlns:r="http://schemas.openxmlformats.org/officeDocument/2006/relationships" id="260" r:id="R01867d17bebe4a6d"/>
-    <p:sldId xmlns:r="http://schemas.openxmlformats.org/officeDocument/2006/relationships" id="261" r:id="Rc6cf3d4e42134e6e"/>
-    <p:sldId xmlns:r="http://schemas.openxmlformats.org/officeDocument/2006/relationships" id="262" r:id="R00b27dbfd3944f73"/>
-    <p:sldId xmlns:r="http://schemas.openxmlformats.org/officeDocument/2006/relationships" id="263" r:id="Rd09531c8cfa84146"/>
+    <p:sldId xmlns:r="http://schemas.openxmlformats.org/officeDocument/2006/relationships" id="256" r:id="R3c1e6b4be46147f3"/>
+    <p:sldId xmlns:r="http://schemas.openxmlformats.org/officeDocument/2006/relationships" id="257" r:id="R75d7f7936db24633"/>
+    <p:sldId xmlns:r="http://schemas.openxmlformats.org/officeDocument/2006/relationships" id="258" r:id="Rf2a8d823cb0d4e9d"/>
+    <p:sldId xmlns:r="http://schemas.openxmlformats.org/officeDocument/2006/relationships" id="259" r:id="R3bbdc68e9a4a43b8"/>
+    <p:sldId xmlns:r="http://schemas.openxmlformats.org/officeDocument/2006/relationships" id="260" r:id="R5ec6fd642860487b"/>
+    <p:sldId xmlns:r="http://schemas.openxmlformats.org/officeDocument/2006/relationships" id="261" r:id="Rb02d43a8bc5443f3"/>
+    <p:sldId xmlns:r="http://schemas.openxmlformats.org/officeDocument/2006/relationships" id="262" r:id="R68dbbf6be95e44fa"/>
+    <p:sldId xmlns:r="http://schemas.openxmlformats.org/officeDocument/2006/relationships" id="263" r:id="R257d3c7c40204e7c"/>
   </p:sldIdLst>
   <p:sldSz cx="12192000" cy="6858000"/>
   <p:notesSz cx="6858000" cy="9144000"/>
@@ -447,11 +447,7 @@
         <p:txBody>
           <a:bodyPr xmlns:a="http://schemas.openxmlformats.org/drawingml/2006/main"/>
           <a:lstStyle xmlns:a="http://schemas.openxmlformats.org/drawingml/2006/main"/>
-          <a:p xmlns:a="http://schemas.openxmlformats.org/drawingml/2006/main">
-            <a:r>
-              <a:t>Спикер: Анастасия, 35–40 секунд. Представиться и назвать команду. Коротко: мы собрали работающий MVP, который из пользовательских ограничений формирует меню, считает корзину и проверяет результат.</a:t>
-            </a:r>
-          </a:p>
+          <a:p xmlns:a="http://schemas.openxmlformats.org/drawingml/2006/main"/>
         </p:txBody>
       </p:sp>
       <p:sp>
@@ -517,11 +513,7 @@
         <p:txBody>
           <a:bodyPr xmlns:a="http://schemas.openxmlformats.org/drawingml/2006/main"/>
           <a:lstStyle xmlns:a="http://schemas.openxmlformats.org/drawingml/2006/main"/>
-          <a:p xmlns:a="http://schemas.openxmlformats.org/drawingml/2006/main">
-            <a:r>
-              <a:t>Спикер: Анастасия, около 55 секунд. Фильтры умеют найти подходящие рецепты, но не составляют связный план и не используют содержательный feedback. Поэтому LLM выбирает и пересматривает меню. Стоимость, единицы, бюджет и итоговая валидность остаются в Python. Это ключевой ответ на вопрос «зачем здесь LLM».</a:t>
-            </a:r>
-          </a:p>
+          <a:p xmlns:a="http://schemas.openxmlformats.org/drawingml/2006/main"/>
         </p:txBody>
       </p:sp>
       <p:sp>
@@ -589,7 +581,7 @@
           <a:lstStyle xmlns:a="http://schemas.openxmlformats.org/drawingml/2006/main"/>
           <a:p xmlns:a="http://schemas.openxmlformats.org/drawingml/2006/main">
             <a:r>
-              <a:t>Спикер: Максим, около 65 секунд. Данные подготовлены заранее: 150 рецептов, 503 нормализованных ингредиента и 503 демонстрационные цены. Поиск применяет жёсткие ограничения по диете и времени и передаёт планировщику только допустимые ID. Сразу назвать ограничение: CU — условные единицы, а часть исходных количеств обозначена как pcs. Источник данных: https://www.kaggle.com/datasets/shuyangli94/food-com-recipes-and-user-interactions</a:t>
+              <a:t>Источник данных: https://www.kaggle.com/datasets/shuyangli94/food-com-recipes-and-user-interactions</a:t>
             </a:r>
           </a:p>
         </p:txBody>
@@ -657,11 +649,7 @@
         <p:txBody>
           <a:bodyPr xmlns:a="http://schemas.openxmlformats.org/drawingml/2006/main"/>
           <a:lstStyle xmlns:a="http://schemas.openxmlformats.org/drawingml/2006/main"/>
-          <a:p xmlns:a="http://schemas.openxmlformats.org/drawingml/2006/main">
-            <a:r>
-              <a:t>Спикер: Рита, около 65 секунд. Планировщик получает только ID кандидатов и возвращает строгий JSON. Pydantic проверяет схему и отклоняет неизвестные рецепты. При плохом JSON есть одна повторная попытка, при недоступном API — безопасный fallback из кандидатов. Важно: planner не считает стоимость и не определяет valid.</a:t>
-            </a:r>
-          </a:p>
+          <a:p xmlns:a="http://schemas.openxmlformats.org/drawingml/2006/main"/>
         </p:txBody>
       </p:sp>
       <p:sp>
@@ -727,11 +715,7 @@
         <p:txBody>
           <a:bodyPr xmlns:a="http://schemas.openxmlformats.org/drawingml/2006/main"/>
           <a:lstStyle xmlns:a="http://schemas.openxmlformats.org/drawingml/2006/main"/>
-          <a:p xmlns:a="http://schemas.openxmlformats.org/drawingml/2006/main">
-            <a:r>
-              <a:t>Спикер: Александра, около 70 секунд. Calculator масштабирует ингредиенты на число людей, суммирует их, вычитает pantry и применяет цену. Validator проверяет бюджет, диету, неизвестные цены и единицы. Critic получает уже вычисленные нарушения и объясняет, как исправить выбор. Он не может изменить total_cost, корзину или valid. Неизвестная цена не маскируется нулём: total_cost становится null.</a:t>
-            </a:r>
-          </a:p>
+          <a:p xmlns:a="http://schemas.openxmlformats.org/drawingml/2006/main"/>
         </p:txBody>
       </p:sp>
       <p:sp>
@@ -797,11 +781,7 @@
         <p:txBody>
           <a:bodyPr xmlns:a="http://schemas.openxmlformats.org/drawingml/2006/main"/>
           <a:lstStyle xmlns:a="http://schemas.openxmlformats.org/drawingml/2006/main"/>
-          <a:p xmlns:a="http://schemas.openxmlformats.org/drawingml/2006/main">
-            <a:r>
-              <a:t>Спикер: Анастасия, около 65 секунд. Пройти слева направо: запрос, поиск, planner, Python validator, интерфейс. Если есть нарушения, critic формирует feedback и planner делает одну повторную попытку. LangGraph для такого короткого цикла не даёт практической пользы. Он станет уместен при нескольких ветвях, долгих процессах или сохранении состояния между сессиями.</a:t>
-            </a:r>
-          </a:p>
+          <a:p xmlns:a="http://schemas.openxmlformats.org/drawingml/2006/main"/>
         </p:txBody>
       </p:sp>
       <p:sp>
@@ -867,11 +847,7 @@
         <p:txBody>
           <a:bodyPr xmlns:a="http://schemas.openxmlformats.org/drawingml/2006/main"/>
           <a:lstStyle xmlns:a="http://schemas.openxmlformats.org/drawingml/2006/main"/>
-          <a:p xmlns:a="http://schemas.openxmlformats.org/drawingml/2006/main">
-            <a:r>
-              <a:t>Демо, около 3 минут. Анастасия задаёт параметры и запускает. Максим кратко показывает каталог и найденных кандидатов. Рита показывает 6 выбранных блюд и поясняет planner. Александра показывает корзину, стоимость и Python-проверку. Затем поставить бюджет 0 CU, снова запустить и раскрыть историю попыток: violation over_budget, реальный ответ critic и feedback для второй попытки. Не показывать .env, AI Studio и API-ключ.</a:t>
-            </a:r>
-          </a:p>
+          <a:p xmlns:a="http://schemas.openxmlformats.org/drawingml/2006/main"/>
         </p:txBody>
       </p:sp>
       <p:sp>
@@ -939,7 +915,7 @@
           <a:lstStyle xmlns:a="http://schemas.openxmlformats.org/drawingml/2006/main"/>
           <a:p xmlns:a="http://schemas.openxmlformats.org/drawingml/2006/main">
             <a:r>
-              <a:t>Спикер: Анастасия, 45–50 секунд. MVP проверен 91 тестом, Docker healthcheck проходит, live Gemini проверен, репозиторий публичный. Ограничения данных названы открыто. К final defense подключим реальные цены, формальную оценку качества меню и деплой с наблюдаемостью. Источники: https://github.com/asastyy/smart-grocery-agents и https://github.com/AlgazinovAleksandr/LLM-Agents-Course/blob/main/GROUP_PROJECT.md</a:t>
+              <a:t>Источники: https://github.com/asastyy/smart-grocery-agents и https://github.com/AlgazinovAleksandr/LLM-Agents-Course/blob/main/GROUP_PROJECT.md</a:t>
             </a:r>
           </a:p>
         </p:txBody>
@@ -986,7 +962,7 @@
           <p:cNvPr id="3" name="Title">
             <a:extLst xmlns:a="http://schemas.openxmlformats.org/drawingml/2006/main">
               <a:ext uri="{FF2B5EF4-FFF2-40B4-BE49-F238E27FC236}">
-                <a16:creationId xmlns:a16="http://schemas.microsoft.com/office/drawing/2014/main" id="{55D0161F-200C-4AE1-BAC8-3703C5B4AE51}"/>
+                <a16:creationId xmlns:a16="http://schemas.microsoft.com/office/drawing/2014/main" id="{46B0ABD7-5E9B-4E50-BCCE-BB5368B19D0F}"/>
               </a:ext>
             </a:extLst>
           </p:cNvPr>
@@ -1215,7 +1191,7 @@
           <p:cNvPr id="2" name="Subtitle">
             <a:extLst xmlns:a="http://schemas.openxmlformats.org/drawingml/2006/main">
               <a:ext uri="{FF2B5EF4-FFF2-40B4-BE49-F238E27FC236}">
-                <a16:creationId xmlns:a16="http://schemas.microsoft.com/office/drawing/2014/main" id="{BDE7BD8D-805B-408A-BF87-CA7E4CD88D8E}"/>
+                <a16:creationId xmlns:a16="http://schemas.microsoft.com/office/drawing/2014/main" id="{2536D732-B797-411D-9AE7-F2D5B811A3A0}"/>
               </a:ext>
             </a:extLst>
           </p:cNvPr>
@@ -1461,7 +1437,7 @@
           <p:cNvPr id="2" name="Section title">
             <a:extLst xmlns:a="http://schemas.openxmlformats.org/drawingml/2006/main">
               <a:ext uri="{FF2B5EF4-FFF2-40B4-BE49-F238E27FC236}">
-                <a16:creationId xmlns:a16="http://schemas.microsoft.com/office/drawing/2014/main" id="{A9D86529-160F-4259-A314-E450924D5BA6}"/>
+                <a16:creationId xmlns:a16="http://schemas.microsoft.com/office/drawing/2014/main" id="{0A632760-F1B6-4EFB-9064-CFE5A5F4A6B1}"/>
               </a:ext>
             </a:extLst>
           </p:cNvPr>
@@ -1707,7 +1683,7 @@
           <p:cNvPr id="3" name="Title">
             <a:extLst xmlns:a="http://schemas.openxmlformats.org/drawingml/2006/main">
               <a:ext uri="{FF2B5EF4-FFF2-40B4-BE49-F238E27FC236}">
-                <a16:creationId xmlns:a16="http://schemas.microsoft.com/office/drawing/2014/main" id="{97A9C4D1-983F-46EB-9BD3-81CAD3663814}"/>
+                <a16:creationId xmlns:a16="http://schemas.microsoft.com/office/drawing/2014/main" id="{B528CAF6-1D1F-40E3-ACC4-8C4DE2B3820B}"/>
               </a:ext>
             </a:extLst>
           </p:cNvPr>
@@ -1936,7 +1912,7 @@
           <p:cNvPr id="2" name="Body">
             <a:extLst xmlns:a="http://schemas.openxmlformats.org/drawingml/2006/main">
               <a:ext uri="{FF2B5EF4-FFF2-40B4-BE49-F238E27FC236}">
-                <a16:creationId xmlns:a16="http://schemas.microsoft.com/office/drawing/2014/main" id="{D8DFC3E8-CF35-4E47-A108-A31264B43CF8}"/>
+                <a16:creationId xmlns:a16="http://schemas.microsoft.com/office/drawing/2014/main" id="{026D3904-C6ED-43AB-9353-93CA0C133F88}"/>
               </a:ext>
             </a:extLst>
           </p:cNvPr>
@@ -2182,7 +2158,7 @@
           <p:cNvPr id="4" name="Title">
             <a:extLst xmlns:a="http://schemas.openxmlformats.org/drawingml/2006/main">
               <a:ext uri="{FF2B5EF4-FFF2-40B4-BE49-F238E27FC236}">
-                <a16:creationId xmlns:a16="http://schemas.microsoft.com/office/drawing/2014/main" id="{DB4C4E64-D9E7-4CFB-A394-E57B6C0A8445}"/>
+                <a16:creationId xmlns:a16="http://schemas.microsoft.com/office/drawing/2014/main" id="{A5E98106-0B2A-4AD4-932B-F9EE6A1168DD}"/>
               </a:ext>
             </a:extLst>
           </p:cNvPr>
@@ -2411,7 +2387,7 @@
           <p:cNvPr id="2" name="Left column">
             <a:extLst xmlns:a="http://schemas.openxmlformats.org/drawingml/2006/main">
               <a:ext uri="{FF2B5EF4-FFF2-40B4-BE49-F238E27FC236}">
-                <a16:creationId xmlns:a16="http://schemas.microsoft.com/office/drawing/2014/main" id="{5C278160-954F-4358-BDC7-2F9E5DB4BF72}"/>
+                <a16:creationId xmlns:a16="http://schemas.microsoft.com/office/drawing/2014/main" id="{8604FB17-F50D-4698-8514-D6F8E58054D6}"/>
               </a:ext>
             </a:extLst>
           </p:cNvPr>
@@ -2640,7 +2616,7 @@
           <p:cNvPr id="3" name="Right column">
             <a:extLst xmlns:a="http://schemas.openxmlformats.org/drawingml/2006/main">
               <a:ext uri="{FF2B5EF4-FFF2-40B4-BE49-F238E27FC236}">
-                <a16:creationId xmlns:a16="http://schemas.microsoft.com/office/drawing/2014/main" id="{35B856BF-C02D-4DF2-A62A-17B484F15600}"/>
+                <a16:creationId xmlns:a16="http://schemas.microsoft.com/office/drawing/2014/main" id="{77999B37-4DBC-458B-9AB1-55B53F799983}"/>
               </a:ext>
             </a:extLst>
           </p:cNvPr>
@@ -2886,7 +2862,7 @@
           <p:cNvPr id="3" name="Title">
             <a:extLst xmlns:a="http://schemas.openxmlformats.org/drawingml/2006/main">
               <a:ext uri="{FF2B5EF4-FFF2-40B4-BE49-F238E27FC236}">
-                <a16:creationId xmlns:a16="http://schemas.microsoft.com/office/drawing/2014/main" id="{B3B928E1-FCFB-4063-BD8F-1DE2722BB565}"/>
+                <a16:creationId xmlns:a16="http://schemas.microsoft.com/office/drawing/2014/main" id="{1C570C4A-D4FA-4676-9DFD-A6B15C5C5832}"/>
               </a:ext>
             </a:extLst>
           </p:cNvPr>
@@ -3115,7 +3091,7 @@
           <p:cNvPr id="2" name="Left column">
             <a:extLst xmlns:a="http://schemas.openxmlformats.org/drawingml/2006/main">
               <a:ext uri="{FF2B5EF4-FFF2-40B4-BE49-F238E27FC236}">
-                <a16:creationId xmlns:a16="http://schemas.microsoft.com/office/drawing/2014/main" id="{E3BAFF14-C488-4F9A-B0D0-FE70C15365AF}"/>
+                <a16:creationId xmlns:a16="http://schemas.microsoft.com/office/drawing/2014/main" id="{B97BAFC0-8176-4DA9-A0F1-B55AF2E99F33}"/>
               </a:ext>
             </a:extLst>
           </p:cNvPr>
@@ -3382,12 +3358,12 @@
   </p:cSld>
   <p:clrMap bg1="lt1" tx1="dk1" bg2="lt2" tx2="dk2" accent1="accent1" accent2="accent2" accent3="accent3" accent4="accent4" accent5="accent5" accent6="accent6" hlink="hlink" folHlink="folHlink"/>
   <p:sldLayoutIdLst>
-    <p:sldLayoutId xmlns:r="http://schemas.openxmlformats.org/officeDocument/2006/relationships" id="2147483649" r:id="R915b2d94d6a642a8"/>
-    <p:sldLayoutId xmlns:r="http://schemas.openxmlformats.org/officeDocument/2006/relationships" id="2147483650" r:id="R7eec097a5a4248c1"/>
-    <p:sldLayoutId xmlns:r="http://schemas.openxmlformats.org/officeDocument/2006/relationships" id="2147483651" r:id="Rcddd5a17ea4846e4"/>
-    <p:sldLayoutId xmlns:r="http://schemas.openxmlformats.org/officeDocument/2006/relationships" id="2147483652" r:id="Rb98b80e4c4e143bb"/>
-    <p:sldLayoutId xmlns:r="http://schemas.openxmlformats.org/officeDocument/2006/relationships" id="2147483653" r:id="R66ec7d690b464a26"/>
-    <p:sldLayoutId xmlns:r="http://schemas.openxmlformats.org/officeDocument/2006/relationships" id="2147483654" r:id="R2c6d2f650b104fc0"/>
+    <p:sldLayoutId xmlns:r="http://schemas.openxmlformats.org/officeDocument/2006/relationships" id="2147483649" r:id="R38e4b29eddd94bbf"/>
+    <p:sldLayoutId xmlns:r="http://schemas.openxmlformats.org/officeDocument/2006/relationships" id="2147483650" r:id="Rd9afef0c1dc64718"/>
+    <p:sldLayoutId xmlns:r="http://schemas.openxmlformats.org/officeDocument/2006/relationships" id="2147483651" r:id="Rcd6f97c972e14ff3"/>
+    <p:sldLayoutId xmlns:r="http://schemas.openxmlformats.org/officeDocument/2006/relationships" id="2147483652" r:id="R7803f5b43e9442ea"/>
+    <p:sldLayoutId xmlns:r="http://schemas.openxmlformats.org/officeDocument/2006/relationships" id="2147483653" r:id="Ra518a7c0b7f641fa"/>
+    <p:sldLayoutId xmlns:r="http://schemas.openxmlformats.org/officeDocument/2006/relationships" id="2147483654" r:id="R6cc0d76cc630406e"/>
   </p:sldLayoutIdLst>
   <p:txStyles>
     <p:titleStyle>
@@ -3938,7 +3914,7 @@
           <p:cNvPr id="10" name="">
             <a:extLst xmlns:a="http://schemas.openxmlformats.org/drawingml/2006/main">
               <a:ext uri="{FF2B5EF4-FFF2-40B4-BE49-F238E27FC236}">
-                <a16:creationId xmlns:a16="http://schemas.microsoft.com/office/drawing/2014/main" id="{C1F73863-DC54-4FC3-A38F-285D079F8D6C}"/>
+                <a16:creationId xmlns:a16="http://schemas.microsoft.com/office/drawing/2014/main" id="{A9C62A9F-F492-4870-85AC-B289E7584F68}"/>
               </a:ext>
             </a:extLst>
           </p:cNvPr>
@@ -3969,7 +3945,7 @@
           <p:cNvPr id="2" name="">
             <a:extLst xmlns:a="http://schemas.openxmlformats.org/drawingml/2006/main">
               <a:ext uri="{FF2B5EF4-FFF2-40B4-BE49-F238E27FC236}">
-                <a16:creationId xmlns:a16="http://schemas.microsoft.com/office/drawing/2014/main" id="{DE5F8C79-A4D4-46E0-A7B3-62274801AB62}"/>
+                <a16:creationId xmlns:a16="http://schemas.microsoft.com/office/drawing/2014/main" id="{D89EC2EE-30ED-4149-BD46-A8379447ED69}"/>
               </a:ext>
             </a:extLst>
           </p:cNvPr>
@@ -4002,7 +3978,7 @@
           <p:cNvPr id="3" name="">
             <a:extLst xmlns:a="http://schemas.openxmlformats.org/drawingml/2006/main">
               <a:ext uri="{FF2B5EF4-FFF2-40B4-BE49-F238E27FC236}">
-                <a16:creationId xmlns:a16="http://schemas.microsoft.com/office/drawing/2014/main" id="{D66FCD5B-6128-4525-BAA3-900847119884}"/>
+                <a16:creationId xmlns:a16="http://schemas.microsoft.com/office/drawing/2014/main" id="{AA727620-E672-4824-8E1A-A832CD350FAE}"/>
               </a:ext>
             </a:extLst>
           </p:cNvPr>
@@ -4165,7 +4141,7 @@
           <p:cNvPr id="4" name="">
             <a:extLst xmlns:a="http://schemas.openxmlformats.org/drawingml/2006/main">
               <a:ext uri="{FF2B5EF4-FFF2-40B4-BE49-F238E27FC236}">
-                <a16:creationId xmlns:a16="http://schemas.microsoft.com/office/drawing/2014/main" id="{2A98268B-C236-4AC5-8C1B-4B40074CA3F6}"/>
+                <a16:creationId xmlns:a16="http://schemas.microsoft.com/office/drawing/2014/main" id="{0F4C42F7-A808-4806-A67E-A389F31E77AD}"/>
               </a:ext>
             </a:extLst>
           </p:cNvPr>
@@ -4355,7 +4331,7 @@
           <p:cNvPr id="5" name="">
             <a:extLst xmlns:a="http://schemas.openxmlformats.org/drawingml/2006/main">
               <a:ext uri="{FF2B5EF4-FFF2-40B4-BE49-F238E27FC236}">
-                <a16:creationId xmlns:a16="http://schemas.microsoft.com/office/drawing/2014/main" id="{058ACDC8-40BC-4CE4-8B2E-0B792EC70576}"/>
+                <a16:creationId xmlns:a16="http://schemas.microsoft.com/office/drawing/2014/main" id="{CF179918-4133-44BE-A6EF-C75B02EFA3E4}"/>
               </a:ext>
             </a:extLst>
           </p:cNvPr>
@@ -4545,7 +4521,7 @@
           <p:cNvPr id="6" name="">
             <a:extLst xmlns:a="http://schemas.openxmlformats.org/drawingml/2006/main">
               <a:ext uri="{FF2B5EF4-FFF2-40B4-BE49-F238E27FC236}">
-                <a16:creationId xmlns:a16="http://schemas.microsoft.com/office/drawing/2014/main" id="{6C25384D-3326-4508-9488-B40107AA7F86}"/>
+                <a16:creationId xmlns:a16="http://schemas.microsoft.com/office/drawing/2014/main" id="{304CBECC-E381-4209-9164-417C0807FE13}"/>
               </a:ext>
             </a:extLst>
           </p:cNvPr>
@@ -4708,7 +4684,7 @@
           <p:cNvPr id="7" name="">
             <a:extLst xmlns:a="http://schemas.openxmlformats.org/drawingml/2006/main">
               <a:ext uri="{FF2B5EF4-FFF2-40B4-BE49-F238E27FC236}">
-                <a16:creationId xmlns:a16="http://schemas.microsoft.com/office/drawing/2014/main" id="{B49D7BA4-3D34-4BE9-884A-83F205EC13BC}"/>
+                <a16:creationId xmlns:a16="http://schemas.microsoft.com/office/drawing/2014/main" id="{C1026919-BA5A-4785-BAFB-7E3049F948FB}"/>
               </a:ext>
             </a:extLst>
           </p:cNvPr>
@@ -4952,7 +4928,7 @@
           <p:cNvPr id="8" name="">
             <a:extLst xmlns:a="http://schemas.openxmlformats.org/drawingml/2006/main">
               <a:ext uri="{FF2B5EF4-FFF2-40B4-BE49-F238E27FC236}">
-                <a16:creationId xmlns:a16="http://schemas.microsoft.com/office/drawing/2014/main" id="{0F5278A2-AE49-4224-8F40-AA6ED8AFCE28}"/>
+                <a16:creationId xmlns:a16="http://schemas.microsoft.com/office/drawing/2014/main" id="{DF21799C-4F91-412D-B565-29A895A311D2}"/>
               </a:ext>
             </a:extLst>
           </p:cNvPr>
@@ -4985,7 +4961,7 @@
           <p:cNvPr id="9" name="">
             <a:extLst xmlns:a="http://schemas.openxmlformats.org/drawingml/2006/main">
               <a:ext uri="{FF2B5EF4-FFF2-40B4-BE49-F238E27FC236}">
-                <a16:creationId xmlns:a16="http://schemas.microsoft.com/office/drawing/2014/main" id="{C06979D4-A9E1-4E84-8AAA-158DFD3305B7}"/>
+                <a16:creationId xmlns:a16="http://schemas.microsoft.com/office/drawing/2014/main" id="{3CD5E44F-8A63-43BD-8295-2FA117CEA9DB}"/>
               </a:ext>
             </a:extLst>
           </p:cNvPr>
@@ -4995,7 +4971,7 @@
           <p:nvPr/>
         </p:nvPicPr>
         <p:blipFill>
-          <a:blip xmlns:r="http://schemas.openxmlformats.org/officeDocument/2006/relationships" xmlns:a="http://schemas.openxmlformats.org/drawingml/2006/main" r:embed="R2808d3f4e9574eb9"/>
+          <a:blip xmlns:r="http://schemas.openxmlformats.org/officeDocument/2006/relationships" xmlns:a="http://schemas.openxmlformats.org/drawingml/2006/main" r:embed="Rbcb086c294114fab"/>
           <a:srcRect xmlns:a="http://schemas.openxmlformats.org/drawingml/2006/main" l="0" t="2000" r="0" b="2000"/>
           <a:stretch xmlns:a="http://schemas.openxmlformats.org/drawingml/2006/main"/>
         </p:blipFill>
@@ -5014,7 +4990,7 @@
     </p:spTree>
     <p:extLst>
       <p:ext uri="{BB962C8B-B14F-4D97-AF65-F5344CB8AC3E}">
-        <p14:creationId xmlns:p14="http://schemas.microsoft.com/office/powerpoint/2010/main" val="118121208"/>
+        <p14:creationId xmlns:p14="http://schemas.microsoft.com/office/powerpoint/2010/main" val="433871275"/>
       </p:ext>
     </p:extLst>
   </p:cSld>
@@ -5045,7 +5021,7 @@
           <p:cNvPr id="29" name="">
             <a:extLst xmlns:a="http://schemas.openxmlformats.org/drawingml/2006/main">
               <a:ext uri="{FF2B5EF4-FFF2-40B4-BE49-F238E27FC236}">
-                <a16:creationId xmlns:a16="http://schemas.microsoft.com/office/drawing/2014/main" id="{64C38AA2-C471-4E52-B6A8-CD4F10D0BB31}"/>
+                <a16:creationId xmlns:a16="http://schemas.microsoft.com/office/drawing/2014/main" id="{4BD2A3CB-DE9E-4922-A538-53E8B83512A7}"/>
               </a:ext>
             </a:extLst>
           </p:cNvPr>
@@ -5079,7 +5055,7 @@
           <p:cNvPr id="28" name="">
             <a:extLst xmlns:a="http://schemas.openxmlformats.org/drawingml/2006/main">
               <a:ext uri="{FF2B5EF4-FFF2-40B4-BE49-F238E27FC236}">
-                <a16:creationId xmlns:a16="http://schemas.microsoft.com/office/drawing/2014/main" id="{0DA54567-AC38-448B-90EA-01C885B1F02B}"/>
+                <a16:creationId xmlns:a16="http://schemas.microsoft.com/office/drawing/2014/main" id="{F8A2A26E-F5AF-4068-84CE-F09372EF1FC3}"/>
               </a:ext>
             </a:extLst>
           </p:cNvPr>
@@ -5110,10 +5086,10 @@
       </p:cxnSp>
       <p:sp>
         <p:nvSpPr>
-          <p:cNvPr id="36" name="">
+          <p:cNvPr id="35" name="">
             <a:extLst xmlns:a="http://schemas.openxmlformats.org/drawingml/2006/main">
               <a:ext uri="{FF2B5EF4-FFF2-40B4-BE49-F238E27FC236}">
-                <a16:creationId xmlns:a16="http://schemas.microsoft.com/office/drawing/2014/main" id="{C30E3823-8011-411D-89E6-B01DBDA96448}"/>
+                <a16:creationId xmlns:a16="http://schemas.microsoft.com/office/drawing/2014/main" id="{7CBCA628-7B81-496C-9836-8B23E6B55379}"/>
               </a:ext>
             </a:extLst>
           </p:cNvPr>
@@ -5266,7 +5242,7 @@
                 <a:ea typeface="Arial"/>
                 <a:cs typeface="Arial"/>
               </a:rPr>
-              <a:t>1 · ПРОБЛЕМА И ПОЛЬЗОВАТЕЛЬ</a:t>
+              <a:t>1 · ПРОБЛЕМА И РОЛЬ LLM</a:t>
             </a:r>
           </a:p>
         </p:txBody>
@@ -5276,7 +5252,7 @@
           <p:cNvPr id="2" name="">
             <a:extLst xmlns:a="http://schemas.openxmlformats.org/drawingml/2006/main">
               <a:ext uri="{FF2B5EF4-FFF2-40B4-BE49-F238E27FC236}">
-                <a16:creationId xmlns:a16="http://schemas.microsoft.com/office/drawing/2014/main" id="{63E39FB8-4D4C-472C-9B3D-19958489DA6F}"/>
+                <a16:creationId xmlns:a16="http://schemas.microsoft.com/office/drawing/2014/main" id="{613F7406-8CEB-4162-A590-DECEAC2A37F2}"/>
               </a:ext>
             </a:extLst>
           </p:cNvPr>
@@ -5429,7 +5405,7 @@
                 <a:ea typeface="Arial"/>
                 <a:cs typeface="Arial"/>
               </a:rPr>
-              <a:t>Один запрос — пять ограничений</a:t>
+              <a:t>Меню должно учитывать все ограничения</a:t>
             </a:r>
           </a:p>
         </p:txBody>
@@ -5439,7 +5415,7 @@
           <p:cNvPr id="3" name="">
             <a:extLst xmlns:a="http://schemas.openxmlformats.org/drawingml/2006/main">
               <a:ext uri="{FF2B5EF4-FFF2-40B4-BE49-F238E27FC236}">
-                <a16:creationId xmlns:a16="http://schemas.microsoft.com/office/drawing/2014/main" id="{7CC0E9AB-7923-4588-B080-53B209E3887F}"/>
+                <a16:creationId xmlns:a16="http://schemas.microsoft.com/office/drawing/2014/main" id="{564CD431-7882-4F76-B3E6-D2ABE2B77B85}"/>
               </a:ext>
             </a:extLst>
           </p:cNvPr>
@@ -5592,7 +5568,7 @@
                 <a:ea typeface="Arial"/>
                 <a:cs typeface="Arial"/>
               </a:rPr>
-              <a:t>Человеку трудно вручную совместить их в связное меню на несколько дней.</a:t>
+              <a:t>Запасы, бюджет, питание, время, число дней и людей.</a:t>
             </a:r>
           </a:p>
         </p:txBody>
@@ -5602,7 +5578,7 @@
           <p:cNvPr id="4" name="">
             <a:extLst xmlns:a="http://schemas.openxmlformats.org/drawingml/2006/main">
               <a:ext uri="{FF2B5EF4-FFF2-40B4-BE49-F238E27FC236}">
-                <a16:creationId xmlns:a16="http://schemas.microsoft.com/office/drawing/2014/main" id="{A1EF9567-7A75-4045-AF22-683197E52974}"/>
+                <a16:creationId xmlns:a16="http://schemas.microsoft.com/office/drawing/2014/main" id="{71725FDD-0689-4D4F-A10E-AC98388CC73E}"/>
               </a:ext>
             </a:extLst>
           </p:cNvPr>
@@ -5635,7 +5611,7 @@
           <p:cNvPr id="5" name="">
             <a:extLst xmlns:a="http://schemas.openxmlformats.org/drawingml/2006/main">
               <a:ext uri="{FF2B5EF4-FFF2-40B4-BE49-F238E27FC236}">
-                <a16:creationId xmlns:a16="http://schemas.microsoft.com/office/drawing/2014/main" id="{AAA5FF94-4808-4F06-A8D5-1B31D0684326}"/>
+                <a16:creationId xmlns:a16="http://schemas.microsoft.com/office/drawing/2014/main" id="{73882677-E7FD-4287-B4EE-D52AA0FBF46E}"/>
               </a:ext>
             </a:extLst>
           </p:cNvPr>
@@ -5798,7 +5774,7 @@
           <p:cNvPr id="6" name="">
             <a:extLst xmlns:a="http://schemas.openxmlformats.org/drawingml/2006/main">
               <a:ext uri="{FF2B5EF4-FFF2-40B4-BE49-F238E27FC236}">
-                <a16:creationId xmlns:a16="http://schemas.microsoft.com/office/drawing/2014/main" id="{E3F22DB2-1D88-4116-BBEF-63E0BF2C6E03}"/>
+                <a16:creationId xmlns:a16="http://schemas.microsoft.com/office/drawing/2014/main" id="{C5AC1A3A-9E53-4B72-B618-BC0DA95D0FFB}"/>
               </a:ext>
             </a:extLst>
           </p:cNvPr>
@@ -5961,7 +5937,7 @@
           <p:cNvPr id="7" name="">
             <a:extLst xmlns:a="http://schemas.openxmlformats.org/drawingml/2006/main">
               <a:ext uri="{FF2B5EF4-FFF2-40B4-BE49-F238E27FC236}">
-                <a16:creationId xmlns:a16="http://schemas.microsoft.com/office/drawing/2014/main" id="{529A7A30-60A2-450A-9D39-21FCB73502E7}"/>
+                <a16:creationId xmlns:a16="http://schemas.microsoft.com/office/drawing/2014/main" id="{B2987751-64A3-443D-B996-3721A1E34B87}"/>
               </a:ext>
             </a:extLst>
           </p:cNvPr>
@@ -5994,7 +5970,7 @@
           <p:cNvPr id="8" name="">
             <a:extLst xmlns:a="http://schemas.openxmlformats.org/drawingml/2006/main">
               <a:ext uri="{FF2B5EF4-FFF2-40B4-BE49-F238E27FC236}">
-                <a16:creationId xmlns:a16="http://schemas.microsoft.com/office/drawing/2014/main" id="{A402C0AB-6AD6-4AFA-A83E-C886821E6855}"/>
+                <a16:creationId xmlns:a16="http://schemas.microsoft.com/office/drawing/2014/main" id="{2AB790F1-760A-494E-B9CC-8B7AFC52F4B9}"/>
               </a:ext>
             </a:extLst>
           </p:cNvPr>
@@ -6157,7 +6133,7 @@
           <p:cNvPr id="9" name="">
             <a:extLst xmlns:a="http://schemas.openxmlformats.org/drawingml/2006/main">
               <a:ext uri="{FF2B5EF4-FFF2-40B4-BE49-F238E27FC236}">
-                <a16:creationId xmlns:a16="http://schemas.microsoft.com/office/drawing/2014/main" id="{743D6AE8-071E-4287-9648-D98D5E787922}"/>
+                <a16:creationId xmlns:a16="http://schemas.microsoft.com/office/drawing/2014/main" id="{B03FFFB4-81CA-4B67-BA35-59BD7C387BFA}"/>
               </a:ext>
             </a:extLst>
           </p:cNvPr>
@@ -6320,7 +6296,7 @@
           <p:cNvPr id="10" name="">
             <a:extLst xmlns:a="http://schemas.openxmlformats.org/drawingml/2006/main">
               <a:ext uri="{FF2B5EF4-FFF2-40B4-BE49-F238E27FC236}">
-                <a16:creationId xmlns:a16="http://schemas.microsoft.com/office/drawing/2014/main" id="{6F70B1E1-E4FF-43C9-ADDA-AB9698969B2B}"/>
+                <a16:creationId xmlns:a16="http://schemas.microsoft.com/office/drawing/2014/main" id="{E52964C3-E7D8-46BD-9356-8BE32EC21073}"/>
               </a:ext>
             </a:extLst>
           </p:cNvPr>
@@ -6353,7 +6329,7 @@
           <p:cNvPr id="11" name="">
             <a:extLst xmlns:a="http://schemas.openxmlformats.org/drawingml/2006/main">
               <a:ext uri="{FF2B5EF4-FFF2-40B4-BE49-F238E27FC236}">
-                <a16:creationId xmlns:a16="http://schemas.microsoft.com/office/drawing/2014/main" id="{9C4F5576-DD32-4484-A795-136D4224FBBF}"/>
+                <a16:creationId xmlns:a16="http://schemas.microsoft.com/office/drawing/2014/main" id="{D69E9C03-2DE1-4300-956D-0C80188E7263}"/>
               </a:ext>
             </a:extLst>
           </p:cNvPr>
@@ -6516,7 +6492,7 @@
           <p:cNvPr id="12" name="">
             <a:extLst xmlns:a="http://schemas.openxmlformats.org/drawingml/2006/main">
               <a:ext uri="{FF2B5EF4-FFF2-40B4-BE49-F238E27FC236}">
-                <a16:creationId xmlns:a16="http://schemas.microsoft.com/office/drawing/2014/main" id="{73274D9F-65F0-4C09-ACF4-FAE06ACBE0A8}"/>
+                <a16:creationId xmlns:a16="http://schemas.microsoft.com/office/drawing/2014/main" id="{62BE8CCA-EB56-430B-979C-28EE5C4D8358}"/>
               </a:ext>
             </a:extLst>
           </p:cNvPr>
@@ -6679,7 +6655,7 @@
           <p:cNvPr id="13" name="">
             <a:extLst xmlns:a="http://schemas.openxmlformats.org/drawingml/2006/main">
               <a:ext uri="{FF2B5EF4-FFF2-40B4-BE49-F238E27FC236}">
-                <a16:creationId xmlns:a16="http://schemas.microsoft.com/office/drawing/2014/main" id="{9E76BD70-E82D-48CD-B6A1-F8B678DE4EFF}"/>
+                <a16:creationId xmlns:a16="http://schemas.microsoft.com/office/drawing/2014/main" id="{93C0E4B7-2C0F-4D41-A60D-1048202E1A14}"/>
               </a:ext>
             </a:extLst>
           </p:cNvPr>
@@ -6712,7 +6688,7 @@
           <p:cNvPr id="14" name="">
             <a:extLst xmlns:a="http://schemas.openxmlformats.org/drawingml/2006/main">
               <a:ext uri="{FF2B5EF4-FFF2-40B4-BE49-F238E27FC236}">
-                <a16:creationId xmlns:a16="http://schemas.microsoft.com/office/drawing/2014/main" id="{AE2B42C1-38B5-4811-9249-BDE83119E833}"/>
+                <a16:creationId xmlns:a16="http://schemas.microsoft.com/office/drawing/2014/main" id="{BC881A5A-9AB5-4836-B1D2-6149F00DA627}"/>
               </a:ext>
             </a:extLst>
           </p:cNvPr>
@@ -6875,7 +6851,7 @@
           <p:cNvPr id="15" name="">
             <a:extLst xmlns:a="http://schemas.openxmlformats.org/drawingml/2006/main">
               <a:ext uri="{FF2B5EF4-FFF2-40B4-BE49-F238E27FC236}">
-                <a16:creationId xmlns:a16="http://schemas.microsoft.com/office/drawing/2014/main" id="{957B2752-FBE4-4B9B-90B4-FDAFCA424CF8}"/>
+                <a16:creationId xmlns:a16="http://schemas.microsoft.com/office/drawing/2014/main" id="{136D56AC-BDDA-4DEF-96E4-970AAE3F9954}"/>
               </a:ext>
             </a:extLst>
           </p:cNvPr>
@@ -7038,7 +7014,7 @@
           <p:cNvPr id="16" name="">
             <a:extLst xmlns:a="http://schemas.openxmlformats.org/drawingml/2006/main">
               <a:ext uri="{FF2B5EF4-FFF2-40B4-BE49-F238E27FC236}">
-                <a16:creationId xmlns:a16="http://schemas.microsoft.com/office/drawing/2014/main" id="{07366B94-3621-429A-8284-CFB0036CBFC1}"/>
+                <a16:creationId xmlns:a16="http://schemas.microsoft.com/office/drawing/2014/main" id="{3DE1552C-20EE-443A-8DAD-22219DFA1257}"/>
               </a:ext>
             </a:extLst>
           </p:cNvPr>
@@ -7071,7 +7047,7 @@
           <p:cNvPr id="17" name="">
             <a:extLst xmlns:a="http://schemas.openxmlformats.org/drawingml/2006/main">
               <a:ext uri="{FF2B5EF4-FFF2-40B4-BE49-F238E27FC236}">
-                <a16:creationId xmlns:a16="http://schemas.microsoft.com/office/drawing/2014/main" id="{D226E60B-5210-44CC-960E-380F63BA1FD9}"/>
+                <a16:creationId xmlns:a16="http://schemas.microsoft.com/office/drawing/2014/main" id="{B772D86C-E939-42FC-8033-6AFA46EC7E55}"/>
               </a:ext>
             </a:extLst>
           </p:cNvPr>
@@ -7234,7 +7210,7 @@
           <p:cNvPr id="18" name="">
             <a:extLst xmlns:a="http://schemas.openxmlformats.org/drawingml/2006/main">
               <a:ext uri="{FF2B5EF4-FFF2-40B4-BE49-F238E27FC236}">
-                <a16:creationId xmlns:a16="http://schemas.microsoft.com/office/drawing/2014/main" id="{A08DE946-8F1B-4AC8-AE54-E636B0326E4E}"/>
+                <a16:creationId xmlns:a16="http://schemas.microsoft.com/office/drawing/2014/main" id="{F29AC30C-04BD-4AB5-A179-3443B4CC064D}"/>
               </a:ext>
             </a:extLst>
           </p:cNvPr>
@@ -7397,7 +7373,7 @@
           <p:cNvPr id="19" name="">
             <a:extLst xmlns:a="http://schemas.openxmlformats.org/drawingml/2006/main">
               <a:ext uri="{FF2B5EF4-FFF2-40B4-BE49-F238E27FC236}">
-                <a16:creationId xmlns:a16="http://schemas.microsoft.com/office/drawing/2014/main" id="{9BE1182F-0883-40CC-945E-E9B6F9FC6F2E}"/>
+                <a16:creationId xmlns:a16="http://schemas.microsoft.com/office/drawing/2014/main" id="{3B75D812-3827-4F46-A750-DD504D291902}"/>
               </a:ext>
             </a:extLst>
           </p:cNvPr>
@@ -7432,7 +7408,7 @@
           <p:cNvPr id="20" name="">
             <a:extLst xmlns:a="http://schemas.openxmlformats.org/drawingml/2006/main">
               <a:ext uri="{FF2B5EF4-FFF2-40B4-BE49-F238E27FC236}">
-                <a16:creationId xmlns:a16="http://schemas.microsoft.com/office/drawing/2014/main" id="{9BBF888B-B1D2-45AA-A814-8945F4D6410E}"/>
+                <a16:creationId xmlns:a16="http://schemas.microsoft.com/office/drawing/2014/main" id="{55D58F46-CE21-4549-8B51-9CDB94FE1A0A}"/>
               </a:ext>
             </a:extLst>
           </p:cNvPr>
@@ -7595,7 +7571,7 @@
           <p:cNvPr id="21" name="">
             <a:extLst xmlns:a="http://schemas.openxmlformats.org/drawingml/2006/main">
               <a:ext uri="{FF2B5EF4-FFF2-40B4-BE49-F238E27FC236}">
-                <a16:creationId xmlns:a16="http://schemas.microsoft.com/office/drawing/2014/main" id="{256315EC-E389-4D1D-A821-27ACA7E1D973}"/>
+                <a16:creationId xmlns:a16="http://schemas.microsoft.com/office/drawing/2014/main" id="{2720BDFB-DF22-49BE-A1A3-FBE56125FD24}"/>
               </a:ext>
             </a:extLst>
           </p:cNvPr>
@@ -7758,7 +7734,7 @@
           <p:cNvPr id="22" name="">
             <a:extLst xmlns:a="http://schemas.openxmlformats.org/drawingml/2006/main">
               <a:ext uri="{FF2B5EF4-FFF2-40B4-BE49-F238E27FC236}">
-                <a16:creationId xmlns:a16="http://schemas.microsoft.com/office/drawing/2014/main" id="{2FC70669-769E-444F-86D7-DD165C16CCA3}"/>
+                <a16:creationId xmlns:a16="http://schemas.microsoft.com/office/drawing/2014/main" id="{93E08D1B-60CB-44CD-8522-5A1FB2A02BCA}"/>
               </a:ext>
             </a:extLst>
           </p:cNvPr>
@@ -7793,7 +7769,7 @@
           <p:cNvPr id="23" name="">
             <a:extLst xmlns:a="http://schemas.openxmlformats.org/drawingml/2006/main">
               <a:ext uri="{FF2B5EF4-FFF2-40B4-BE49-F238E27FC236}">
-                <a16:creationId xmlns:a16="http://schemas.microsoft.com/office/drawing/2014/main" id="{DF973FC0-44C5-493B-83EC-59455D7B8956}"/>
+                <a16:creationId xmlns:a16="http://schemas.microsoft.com/office/drawing/2014/main" id="{5CA092C2-FCEE-4C1F-8141-42D6F45269FD}"/>
               </a:ext>
             </a:extLst>
           </p:cNvPr>
@@ -7956,7 +7932,7 @@
           <p:cNvPr id="24" name="">
             <a:extLst xmlns:a="http://schemas.openxmlformats.org/drawingml/2006/main">
               <a:ext uri="{FF2B5EF4-FFF2-40B4-BE49-F238E27FC236}">
-                <a16:creationId xmlns:a16="http://schemas.microsoft.com/office/drawing/2014/main" id="{35DD4E91-FF9A-4C8F-A544-CD391EB16D96}"/>
+                <a16:creationId xmlns:a16="http://schemas.microsoft.com/office/drawing/2014/main" id="{E6EEABC7-B990-4D6D-AD2E-383A636A273E}"/>
               </a:ext>
             </a:extLst>
           </p:cNvPr>
@@ -8119,7 +8095,7 @@
           <p:cNvPr id="25" name="">
             <a:extLst xmlns:a="http://schemas.openxmlformats.org/drawingml/2006/main">
               <a:ext uri="{FF2B5EF4-FFF2-40B4-BE49-F238E27FC236}">
-                <a16:creationId xmlns:a16="http://schemas.microsoft.com/office/drawing/2014/main" id="{ADD886D3-1726-4BAE-8A13-A364B75AF8F0}"/>
+                <a16:creationId xmlns:a16="http://schemas.microsoft.com/office/drawing/2014/main" id="{358CD5D9-23F6-4B6B-A974-6DC98457DBD5}"/>
               </a:ext>
             </a:extLst>
           </p:cNvPr>
@@ -8154,7 +8130,7 @@
           <p:cNvPr id="26" name="">
             <a:extLst xmlns:a="http://schemas.openxmlformats.org/drawingml/2006/main">
               <a:ext uri="{FF2B5EF4-FFF2-40B4-BE49-F238E27FC236}">
-                <a16:creationId xmlns:a16="http://schemas.microsoft.com/office/drawing/2014/main" id="{90035769-E036-4042-B89B-63432102907E}"/>
+                <a16:creationId xmlns:a16="http://schemas.microsoft.com/office/drawing/2014/main" id="{7B33B692-79AE-4713-A942-D1123D6DFCC8}"/>
               </a:ext>
             </a:extLst>
           </p:cNvPr>
@@ -8317,7 +8293,7 @@
           <p:cNvPr id="27" name="">
             <a:extLst xmlns:a="http://schemas.openxmlformats.org/drawingml/2006/main">
               <a:ext uri="{FF2B5EF4-FFF2-40B4-BE49-F238E27FC236}">
-                <a16:creationId xmlns:a16="http://schemas.microsoft.com/office/drawing/2014/main" id="{8283B4AA-5189-4ABC-A1FD-33F89FD26476}"/>
+                <a16:creationId xmlns:a16="http://schemas.microsoft.com/office/drawing/2014/main" id="{8D1700EC-907B-4796-9285-91477045A206}"/>
               </a:ext>
             </a:extLst>
           </p:cNvPr>
@@ -8480,7 +8456,7 @@
           <p:cNvPr id="30" name="">
             <a:extLst xmlns:a="http://schemas.openxmlformats.org/drawingml/2006/main">
               <a:ext uri="{FF2B5EF4-FFF2-40B4-BE49-F238E27FC236}">
-                <a16:creationId xmlns:a16="http://schemas.microsoft.com/office/drawing/2014/main" id="{255B3581-F099-4DF2-A4D2-CE4FF850639E}"/>
+                <a16:creationId xmlns:a16="http://schemas.microsoft.com/office/drawing/2014/main" id="{B1C315DA-44C5-4025-B52A-C1B76AFB3B21}"/>
               </a:ext>
             </a:extLst>
           </p:cNvPr>
@@ -8513,7 +8489,7 @@
           <p:cNvPr id="31" name="">
             <a:extLst xmlns:a="http://schemas.openxmlformats.org/drawingml/2006/main">
               <a:ext uri="{FF2B5EF4-FFF2-40B4-BE49-F238E27FC236}">
-                <a16:creationId xmlns:a16="http://schemas.microsoft.com/office/drawing/2014/main" id="{BA5442CD-0F02-4EC7-85B0-64E3C3424C8F}"/>
+                <a16:creationId xmlns:a16="http://schemas.microsoft.com/office/drawing/2014/main" id="{345F4BEB-BF17-4226-9B63-4CE77C6E785E}"/>
               </a:ext>
             </a:extLst>
           </p:cNvPr>
@@ -8676,7 +8652,7 @@
           <p:cNvPr id="32" name="">
             <a:extLst xmlns:a="http://schemas.openxmlformats.org/drawingml/2006/main">
               <a:ext uri="{FF2B5EF4-FFF2-40B4-BE49-F238E27FC236}">
-                <a16:creationId xmlns:a16="http://schemas.microsoft.com/office/drawing/2014/main" id="{20984D5E-5989-44C7-A842-DE1BE8A6DBEC}"/>
+                <a16:creationId xmlns:a16="http://schemas.microsoft.com/office/drawing/2014/main" id="{49B48C2B-9A08-40D0-AA4C-9B9DEADF72A8}"/>
               </a:ext>
             </a:extLst>
           </p:cNvPr>
@@ -8709,7 +8685,7 @@
           <p:cNvPr id="33" name="">
             <a:extLst xmlns:a="http://schemas.openxmlformats.org/drawingml/2006/main">
               <a:ext uri="{FF2B5EF4-FFF2-40B4-BE49-F238E27FC236}">
-                <a16:creationId xmlns:a16="http://schemas.microsoft.com/office/drawing/2014/main" id="{5E4F5F84-D1A5-4D3B-A2AC-7BBA56AEA519}"/>
+                <a16:creationId xmlns:a16="http://schemas.microsoft.com/office/drawing/2014/main" id="{FAF21AEB-BB3D-498D-925F-7153D11AF2BE}"/>
               </a:ext>
             </a:extLst>
           </p:cNvPr>
@@ -8872,170 +8848,7 @@
           <p:cNvPr id="34" name="">
             <a:extLst xmlns:a="http://schemas.openxmlformats.org/drawingml/2006/main">
               <a:ext uri="{FF2B5EF4-FFF2-40B4-BE49-F238E27FC236}">
-                <a16:creationId xmlns:a16="http://schemas.microsoft.com/office/drawing/2014/main" id="{484EFC64-3898-438C-84E5-04B9A5A1E378}"/>
-              </a:ext>
-            </a:extLst>
-          </p:cNvPr>
-          <p:cNvSpPr>
-            <a:spLocks xmlns:a="http://schemas.openxmlformats.org/drawingml/2006/main" noGrp="1"/>
-          </p:cNvSpPr>
-          <p:nvPr/>
-        </p:nvSpPr>
-        <p:spPr>
-          <a:xfrm xmlns:a="http://schemas.openxmlformats.org/drawingml/2006/main">
-            <a:off x="666750" y="6419850"/>
-            <a:ext cx="4762500" cy="190500"/>
-          </a:xfrm>
-          <a:prstGeom xmlns:a="http://schemas.openxmlformats.org/drawingml/2006/main" prst="rect">
-            <a:avLst/>
-          </a:prstGeom>
-          <a:noFill xmlns:a="http://schemas.openxmlformats.org/drawingml/2006/main"/>
-          <a:ln xmlns:a="http://schemas.openxmlformats.org/drawingml/2006/main" w="0">
-            <a:noFill/>
-            <a:prstDash val="solid"/>
-          </a:ln>
-        </p:spPr>
-        <p:txBody>
-          <a:bodyPr xmlns:a="http://schemas.openxmlformats.org/drawingml/2006/main" wrap="square" lIns="0" tIns="0" rIns="0" bIns="0" anchor="t">
-            <a:normAutofit fontScale="100000"/>
-          </a:bodyPr>
-          <a:lstStyle xmlns:a="http://schemas.openxmlformats.org/drawingml/2006/main">
-            <a:defPPr algn="l">
-              <a:defRPr sz="975" b="0">
-                <a:solidFill>
-                  <a:srgbClr val="6B7280"/>
-                </a:solidFill>
-                <a:latin typeface="Arial"/>
-                <a:ea typeface="Arial"/>
-                <a:cs typeface="Arial"/>
-              </a:defRPr>
-            </a:defPPr>
-            <a:lvl1pPr algn="l">
-              <a:defRPr sz="975" b="0">
-                <a:solidFill>
-                  <a:srgbClr val="6B7280"/>
-                </a:solidFill>
-                <a:latin typeface="Arial"/>
-                <a:ea typeface="Arial"/>
-                <a:cs typeface="Arial"/>
-              </a:defRPr>
-            </a:lvl1pPr>
-            <a:lvl2pPr algn="l">
-              <a:defRPr sz="975" b="0">
-                <a:solidFill>
-                  <a:srgbClr val="6B7280"/>
-                </a:solidFill>
-                <a:latin typeface="Arial"/>
-                <a:ea typeface="Arial"/>
-                <a:cs typeface="Arial"/>
-              </a:defRPr>
-            </a:lvl2pPr>
-            <a:lvl3pPr algn="l">
-              <a:defRPr sz="975" b="0">
-                <a:solidFill>
-                  <a:srgbClr val="6B7280"/>
-                </a:solidFill>
-                <a:latin typeface="Arial"/>
-                <a:ea typeface="Arial"/>
-                <a:cs typeface="Arial"/>
-              </a:defRPr>
-            </a:lvl3pPr>
-            <a:lvl4pPr algn="l">
-              <a:defRPr sz="975" b="0">
-                <a:solidFill>
-                  <a:srgbClr val="6B7280"/>
-                </a:solidFill>
-                <a:latin typeface="Arial"/>
-                <a:ea typeface="Arial"/>
-                <a:cs typeface="Arial"/>
-              </a:defRPr>
-            </a:lvl4pPr>
-            <a:lvl5pPr algn="l">
-              <a:defRPr sz="975" b="0">
-                <a:solidFill>
-                  <a:srgbClr val="6B7280"/>
-                </a:solidFill>
-                <a:latin typeface="Arial"/>
-                <a:ea typeface="Arial"/>
-                <a:cs typeface="Arial"/>
-              </a:defRPr>
-            </a:lvl5pPr>
-            <a:lvl6pPr algn="l">
-              <a:defRPr sz="975" b="0">
-                <a:solidFill>
-                  <a:srgbClr val="6B7280"/>
-                </a:solidFill>
-                <a:latin typeface="Arial"/>
-                <a:ea typeface="Arial"/>
-                <a:cs typeface="Arial"/>
-              </a:defRPr>
-            </a:lvl6pPr>
-            <a:lvl7pPr algn="l">
-              <a:defRPr sz="975" b="0">
-                <a:solidFill>
-                  <a:srgbClr val="6B7280"/>
-                </a:solidFill>
-                <a:latin typeface="Arial"/>
-                <a:ea typeface="Arial"/>
-                <a:cs typeface="Arial"/>
-              </a:defRPr>
-            </a:lvl7pPr>
-            <a:lvl8pPr algn="l">
-              <a:defRPr sz="975" b="0">
-                <a:solidFill>
-                  <a:srgbClr val="6B7280"/>
-                </a:solidFill>
-                <a:latin typeface="Arial"/>
-                <a:ea typeface="Arial"/>
-                <a:cs typeface="Arial"/>
-              </a:defRPr>
-            </a:lvl8pPr>
-            <a:lvl9pPr algn="l">
-              <a:defRPr sz="975" b="0">
-                <a:solidFill>
-                  <a:srgbClr val="6B7280"/>
-                </a:solidFill>
-                <a:latin typeface="Arial"/>
-                <a:ea typeface="Arial"/>
-                <a:cs typeface="Arial"/>
-              </a:defRPr>
-            </a:lvl9pPr>
-          </a:lstStyle>
-          <a:p xmlns:a="http://schemas.openxmlformats.org/drawingml/2006/main">
-            <a:pPr algn="l">
-              <a:lnSpc>
-                <a:spcPct val="105000"/>
-              </a:lnSpc>
-              <a:buNone/>
-              <a:defRPr sz="975" b="0">
-                <a:solidFill>
-                  <a:srgbClr val="6B7280"/>
-                </a:solidFill>
-                <a:latin typeface="Arial"/>
-                <a:ea typeface="Arial"/>
-                <a:cs typeface="Arial"/>
-              </a:defRPr>
-            </a:pPr>
-            <a:r>
-              <a:rPr sz="975" b="0">
-                <a:solidFill>
-                  <a:srgbClr val="6B7280"/>
-                </a:solidFill>
-                <a:latin typeface="Arial"/>
-                <a:ea typeface="Arial"/>
-                <a:cs typeface="Arial"/>
-              </a:rPr>
-              <a:t>Спикер · Анастасия</a:t>
-            </a:r>
-          </a:p>
-        </p:txBody>
-      </p:sp>
-      <p:sp>
-        <p:nvSpPr>
-          <p:cNvPr id="35" name="">
-            <a:extLst xmlns:a="http://schemas.openxmlformats.org/drawingml/2006/main">
-              <a:ext uri="{FF2B5EF4-FFF2-40B4-BE49-F238E27FC236}">
-                <a16:creationId xmlns:a16="http://schemas.microsoft.com/office/drawing/2014/main" id="{55E97283-E387-4B49-8B94-5F13BF8B42D2}"/>
+                <a16:creationId xmlns:a16="http://schemas.microsoft.com/office/drawing/2014/main" id="{E26BAF99-64B6-488E-81A7-FA46EEE93AC9}"/>
               </a:ext>
             </a:extLst>
           </p:cNvPr>
@@ -9196,7 +9009,7 @@
     </p:spTree>
     <p:extLst>
       <p:ext uri="{BB962C8B-B14F-4D97-AF65-F5344CB8AC3E}">
-        <p14:creationId xmlns:p14="http://schemas.microsoft.com/office/powerpoint/2010/main" val="204449391"/>
+        <p14:creationId xmlns:p14="http://schemas.microsoft.com/office/powerpoint/2010/main" val="249156665"/>
       </p:ext>
     </p:extLst>
   </p:cSld>
@@ -9227,7 +9040,7 @@
           <p:cNvPr id="24" name="">
             <a:extLst xmlns:a="http://schemas.openxmlformats.org/drawingml/2006/main">
               <a:ext uri="{FF2B5EF4-FFF2-40B4-BE49-F238E27FC236}">
-                <a16:creationId xmlns:a16="http://schemas.microsoft.com/office/drawing/2014/main" id="{3E3E2732-567C-4770-9913-B8FA6BD0E8D5}"/>
+                <a16:creationId xmlns:a16="http://schemas.microsoft.com/office/drawing/2014/main" id="{06365495-46DA-4607-A0F6-F370B65BBAE7}"/>
               </a:ext>
             </a:extLst>
           </p:cNvPr>
@@ -9259,7 +9072,7 @@
           <p:cNvPr id="23" name="">
             <a:extLst xmlns:a="http://schemas.openxmlformats.org/drawingml/2006/main">
               <a:ext uri="{FF2B5EF4-FFF2-40B4-BE49-F238E27FC236}">
-                <a16:creationId xmlns:a16="http://schemas.microsoft.com/office/drawing/2014/main" id="{DAE5F4A4-7ABC-4709-839F-112715BAA4D8}"/>
+                <a16:creationId xmlns:a16="http://schemas.microsoft.com/office/drawing/2014/main" id="{72D10FAC-4BA6-4367-A377-9F269D471F1F}"/>
               </a:ext>
             </a:extLst>
           </p:cNvPr>
@@ -9291,7 +9104,7 @@
           <p:cNvPr id="22" name="">
             <a:extLst xmlns:a="http://schemas.openxmlformats.org/drawingml/2006/main">
               <a:ext uri="{FF2B5EF4-FFF2-40B4-BE49-F238E27FC236}">
-                <a16:creationId xmlns:a16="http://schemas.microsoft.com/office/drawing/2014/main" id="{D9ADD5FC-627E-4046-8969-F29C00C4DB46}"/>
+                <a16:creationId xmlns:a16="http://schemas.microsoft.com/office/drawing/2014/main" id="{D31C6EC1-B0B7-47ED-A90E-2272DC0C2A16}"/>
               </a:ext>
             </a:extLst>
           </p:cNvPr>
@@ -9320,10 +9133,10 @@
       </p:cxnSp>
       <p:sp>
         <p:nvSpPr>
-          <p:cNvPr id="28" name="">
+          <p:cNvPr id="27" name="">
             <a:extLst xmlns:a="http://schemas.openxmlformats.org/drawingml/2006/main">
               <a:ext uri="{FF2B5EF4-FFF2-40B4-BE49-F238E27FC236}">
-                <a16:creationId xmlns:a16="http://schemas.microsoft.com/office/drawing/2014/main" id="{E0AF72F3-4937-439C-817A-6D6101CEBE60}"/>
+                <a16:creationId xmlns:a16="http://schemas.microsoft.com/office/drawing/2014/main" id="{E9C8555A-F132-46C0-B9F8-EA5035FF59CF}"/>
               </a:ext>
             </a:extLst>
           </p:cNvPr>
@@ -9486,7 +9299,7 @@
           <p:cNvPr id="2" name="">
             <a:extLst xmlns:a="http://schemas.openxmlformats.org/drawingml/2006/main">
               <a:ext uri="{FF2B5EF4-FFF2-40B4-BE49-F238E27FC236}">
-                <a16:creationId xmlns:a16="http://schemas.microsoft.com/office/drawing/2014/main" id="{4578794D-68EA-4EE8-A2B8-A3D9316C2A26}"/>
+                <a16:creationId xmlns:a16="http://schemas.microsoft.com/office/drawing/2014/main" id="{AE848572-531C-4345-B2C7-76E5D21C8D31}"/>
               </a:ext>
             </a:extLst>
           </p:cNvPr>
@@ -9639,7 +9452,7 @@
                 <a:ea typeface="Arial"/>
                 <a:cs typeface="Arial"/>
               </a:rPr>
-              <a:t>Сначала сужаем пространство выбора</a:t>
+              <a:t>Поиск отбирает допустимые рецепты</a:t>
             </a:r>
           </a:p>
         </p:txBody>
@@ -9649,7 +9462,7 @@
           <p:cNvPr id="3" name="">
             <a:extLst xmlns:a="http://schemas.openxmlformats.org/drawingml/2006/main">
               <a:ext uri="{FF2B5EF4-FFF2-40B4-BE49-F238E27FC236}">
-                <a16:creationId xmlns:a16="http://schemas.microsoft.com/office/drawing/2014/main" id="{D851BF6C-73FC-4295-8B7D-523A823B08DE}"/>
+                <a16:creationId xmlns:a16="http://schemas.microsoft.com/office/drawing/2014/main" id="{39821277-1625-4DCD-9EE5-D470633E2A79}"/>
               </a:ext>
             </a:extLst>
           </p:cNvPr>
@@ -9802,7 +9615,7 @@
                 <a:ea typeface="Arial"/>
                 <a:cs typeface="Arial"/>
               </a:rPr>
-              <a:t>Модель получает только проверенный набор кандидатов, а не весь каталог.</a:t>
+              <a:t>Модель получает готовый список кандидатов вместо всего каталога.</a:t>
             </a:r>
           </a:p>
         </p:txBody>
@@ -9812,7 +9625,7 @@
           <p:cNvPr id="4" name="">
             <a:extLst xmlns:a="http://schemas.openxmlformats.org/drawingml/2006/main">
               <a:ext uri="{FF2B5EF4-FFF2-40B4-BE49-F238E27FC236}">
-                <a16:creationId xmlns:a16="http://schemas.microsoft.com/office/drawing/2014/main" id="{98ADF1F7-7C00-4A1A-B035-8A518E79CB42}"/>
+                <a16:creationId xmlns:a16="http://schemas.microsoft.com/office/drawing/2014/main" id="{7D394837-013D-4589-A872-CA60376F2C91}"/>
               </a:ext>
             </a:extLst>
           </p:cNvPr>
@@ -9975,7 +9788,7 @@
           <p:cNvPr id="5" name="">
             <a:extLst xmlns:a="http://schemas.openxmlformats.org/drawingml/2006/main">
               <a:ext uri="{FF2B5EF4-FFF2-40B4-BE49-F238E27FC236}">
-                <a16:creationId xmlns:a16="http://schemas.microsoft.com/office/drawing/2014/main" id="{C40E5CAD-7C0F-480E-9F4A-DA14446B509A}"/>
+                <a16:creationId xmlns:a16="http://schemas.microsoft.com/office/drawing/2014/main" id="{F34E5474-3AA7-45CB-896A-053CA409A3AF}"/>
               </a:ext>
             </a:extLst>
           </p:cNvPr>
@@ -10138,7 +9951,7 @@
           <p:cNvPr id="6" name="">
             <a:extLst xmlns:a="http://schemas.openxmlformats.org/drawingml/2006/main">
               <a:ext uri="{FF2B5EF4-FFF2-40B4-BE49-F238E27FC236}">
-                <a16:creationId xmlns:a16="http://schemas.microsoft.com/office/drawing/2014/main" id="{772F2EC5-D8C3-48F7-981B-49B8BA0A2078}"/>
+                <a16:creationId xmlns:a16="http://schemas.microsoft.com/office/drawing/2014/main" id="{F775B99B-C350-4EA2-BCA9-F6DF53D63C6A}"/>
               </a:ext>
             </a:extLst>
           </p:cNvPr>
@@ -10301,7 +10114,7 @@
           <p:cNvPr id="7" name="">
             <a:extLst xmlns:a="http://schemas.openxmlformats.org/drawingml/2006/main">
               <a:ext uri="{FF2B5EF4-FFF2-40B4-BE49-F238E27FC236}">
-                <a16:creationId xmlns:a16="http://schemas.microsoft.com/office/drawing/2014/main" id="{2B2C2532-AA3A-4CB0-B6A8-41AC6FD79108}"/>
+                <a16:creationId xmlns:a16="http://schemas.microsoft.com/office/drawing/2014/main" id="{811D472F-AC40-4523-A0D7-7977CC1B9D94}"/>
               </a:ext>
             </a:extLst>
           </p:cNvPr>
@@ -10464,7 +10277,7 @@
           <p:cNvPr id="8" name="">
             <a:extLst xmlns:a="http://schemas.openxmlformats.org/drawingml/2006/main">
               <a:ext uri="{FF2B5EF4-FFF2-40B4-BE49-F238E27FC236}">
-                <a16:creationId xmlns:a16="http://schemas.microsoft.com/office/drawing/2014/main" id="{44B94821-B92A-402B-9439-1798C143B998}"/>
+                <a16:creationId xmlns:a16="http://schemas.microsoft.com/office/drawing/2014/main" id="{41869628-9DF8-4497-9F71-7EED10AE2F8A}"/>
               </a:ext>
             </a:extLst>
           </p:cNvPr>
@@ -10627,7 +10440,7 @@
           <p:cNvPr id="9" name="">
             <a:extLst xmlns:a="http://schemas.openxmlformats.org/drawingml/2006/main">
               <a:ext uri="{FF2B5EF4-FFF2-40B4-BE49-F238E27FC236}">
-                <a16:creationId xmlns:a16="http://schemas.microsoft.com/office/drawing/2014/main" id="{86E4F560-CBDA-4D57-AD00-7A3D8B62DDE1}"/>
+                <a16:creationId xmlns:a16="http://schemas.microsoft.com/office/drawing/2014/main" id="{7656EF8D-FBEC-4074-955C-FFCC1DC01FB0}"/>
               </a:ext>
             </a:extLst>
           </p:cNvPr>
@@ -10790,7 +10603,7 @@
           <p:cNvPr id="10" name="">
             <a:extLst xmlns:a="http://schemas.openxmlformats.org/drawingml/2006/main">
               <a:ext uri="{FF2B5EF4-FFF2-40B4-BE49-F238E27FC236}">
-                <a16:creationId xmlns:a16="http://schemas.microsoft.com/office/drawing/2014/main" id="{D0C3C103-60AF-4F98-9EA9-53A092269C88}"/>
+                <a16:creationId xmlns:a16="http://schemas.microsoft.com/office/drawing/2014/main" id="{CD4E5FE3-AD21-4887-88C0-C1C3434AAF47}"/>
               </a:ext>
             </a:extLst>
           </p:cNvPr>
@@ -10825,7 +10638,7 @@
           <p:cNvPr id="11" name="">
             <a:extLst xmlns:a="http://schemas.openxmlformats.org/drawingml/2006/main">
               <a:ext uri="{FF2B5EF4-FFF2-40B4-BE49-F238E27FC236}">
-                <a16:creationId xmlns:a16="http://schemas.microsoft.com/office/drawing/2014/main" id="{801F214E-37AE-4E48-9BE9-76C87482EA58}"/>
+                <a16:creationId xmlns:a16="http://schemas.microsoft.com/office/drawing/2014/main" id="{369423CC-36E8-47A4-9A4B-9C68487A418E}"/>
               </a:ext>
             </a:extLst>
           </p:cNvPr>
@@ -10988,7 +10801,7 @@
           <p:cNvPr id="12" name="">
             <a:extLst xmlns:a="http://schemas.openxmlformats.org/drawingml/2006/main">
               <a:ext uri="{FF2B5EF4-FFF2-40B4-BE49-F238E27FC236}">
-                <a16:creationId xmlns:a16="http://schemas.microsoft.com/office/drawing/2014/main" id="{7A29B443-AA3F-4E18-BB47-D7EE1BC5B4C3}"/>
+                <a16:creationId xmlns:a16="http://schemas.microsoft.com/office/drawing/2014/main" id="{D14727E3-84D7-434A-863F-7DA8C1EC984B}"/>
               </a:ext>
             </a:extLst>
           </p:cNvPr>
@@ -11151,7 +10964,7 @@
           <p:cNvPr id="13" name="">
             <a:extLst xmlns:a="http://schemas.openxmlformats.org/drawingml/2006/main">
               <a:ext uri="{FF2B5EF4-FFF2-40B4-BE49-F238E27FC236}">
-                <a16:creationId xmlns:a16="http://schemas.microsoft.com/office/drawing/2014/main" id="{9908A3C0-D7D4-45D2-BFF1-28D0A25BFC03}"/>
+                <a16:creationId xmlns:a16="http://schemas.microsoft.com/office/drawing/2014/main" id="{086C13CC-5501-4B73-AE61-C3AEE823E298}"/>
               </a:ext>
             </a:extLst>
           </p:cNvPr>
@@ -11186,7 +10999,7 @@
           <p:cNvPr id="14" name="">
             <a:extLst xmlns:a="http://schemas.openxmlformats.org/drawingml/2006/main">
               <a:ext uri="{FF2B5EF4-FFF2-40B4-BE49-F238E27FC236}">
-                <a16:creationId xmlns:a16="http://schemas.microsoft.com/office/drawing/2014/main" id="{431F72E1-BBED-41B9-9F1E-10910D64E461}"/>
+                <a16:creationId xmlns:a16="http://schemas.microsoft.com/office/drawing/2014/main" id="{210D2CBA-D8B2-4F1E-A377-6D6180E6962A}"/>
               </a:ext>
             </a:extLst>
           </p:cNvPr>
@@ -11349,7 +11162,7 @@
           <p:cNvPr id="15" name="">
             <a:extLst xmlns:a="http://schemas.openxmlformats.org/drawingml/2006/main">
               <a:ext uri="{FF2B5EF4-FFF2-40B4-BE49-F238E27FC236}">
-                <a16:creationId xmlns:a16="http://schemas.microsoft.com/office/drawing/2014/main" id="{9F543161-F69C-4AE6-A903-EDBEE4A23381}"/>
+                <a16:creationId xmlns:a16="http://schemas.microsoft.com/office/drawing/2014/main" id="{12F81B37-A994-4D48-BE4B-76E86251070E}"/>
               </a:ext>
             </a:extLst>
           </p:cNvPr>
@@ -11512,7 +11325,7 @@
           <p:cNvPr id="16" name="">
             <a:extLst xmlns:a="http://schemas.openxmlformats.org/drawingml/2006/main">
               <a:ext uri="{FF2B5EF4-FFF2-40B4-BE49-F238E27FC236}">
-                <a16:creationId xmlns:a16="http://schemas.microsoft.com/office/drawing/2014/main" id="{11742661-F734-41B6-A11E-AF89E75AA9C9}"/>
+                <a16:creationId xmlns:a16="http://schemas.microsoft.com/office/drawing/2014/main" id="{53DEE789-8CFE-43A4-ACE0-E47D03E43D98}"/>
               </a:ext>
             </a:extLst>
           </p:cNvPr>
@@ -11547,7 +11360,7 @@
           <p:cNvPr id="17" name="">
             <a:extLst xmlns:a="http://schemas.openxmlformats.org/drawingml/2006/main">
               <a:ext uri="{FF2B5EF4-FFF2-40B4-BE49-F238E27FC236}">
-                <a16:creationId xmlns:a16="http://schemas.microsoft.com/office/drawing/2014/main" id="{84D6C7E8-6C1A-472F-ABC4-6AB88486CDDB}"/>
+                <a16:creationId xmlns:a16="http://schemas.microsoft.com/office/drawing/2014/main" id="{4320E412-23E5-4A03-A425-76AA1236D10F}"/>
               </a:ext>
             </a:extLst>
           </p:cNvPr>
@@ -11710,7 +11523,7 @@
           <p:cNvPr id="18" name="">
             <a:extLst xmlns:a="http://schemas.openxmlformats.org/drawingml/2006/main">
               <a:ext uri="{FF2B5EF4-FFF2-40B4-BE49-F238E27FC236}">
-                <a16:creationId xmlns:a16="http://schemas.microsoft.com/office/drawing/2014/main" id="{BDD4041E-8675-4B60-9502-B1478D80D3B6}"/>
+                <a16:creationId xmlns:a16="http://schemas.microsoft.com/office/drawing/2014/main" id="{FC0BAE67-5A12-427B-A100-AF2C3E814C3E}"/>
               </a:ext>
             </a:extLst>
           </p:cNvPr>
@@ -11873,7 +11686,7 @@
           <p:cNvPr id="19" name="">
             <a:extLst xmlns:a="http://schemas.openxmlformats.org/drawingml/2006/main">
               <a:ext uri="{FF2B5EF4-FFF2-40B4-BE49-F238E27FC236}">
-                <a16:creationId xmlns:a16="http://schemas.microsoft.com/office/drawing/2014/main" id="{8420F111-85D9-4AEB-AD2C-E85C80DFBF75}"/>
+                <a16:creationId xmlns:a16="http://schemas.microsoft.com/office/drawing/2014/main" id="{136B1AB4-31DA-4A32-8292-1A32969EE9FE}"/>
               </a:ext>
             </a:extLst>
           </p:cNvPr>
@@ -11908,7 +11721,7 @@
           <p:cNvPr id="20" name="">
             <a:extLst xmlns:a="http://schemas.openxmlformats.org/drawingml/2006/main">
               <a:ext uri="{FF2B5EF4-FFF2-40B4-BE49-F238E27FC236}">
-                <a16:creationId xmlns:a16="http://schemas.microsoft.com/office/drawing/2014/main" id="{2522A159-1C2D-4F86-94D0-02E818D2577E}"/>
+                <a16:creationId xmlns:a16="http://schemas.microsoft.com/office/drawing/2014/main" id="{ECFE64DB-47D6-438B-BECC-5621386243A6}"/>
               </a:ext>
             </a:extLst>
           </p:cNvPr>
@@ -12071,7 +11884,7 @@
           <p:cNvPr id="21" name="">
             <a:extLst xmlns:a="http://schemas.openxmlformats.org/drawingml/2006/main">
               <a:ext uri="{FF2B5EF4-FFF2-40B4-BE49-F238E27FC236}">
-                <a16:creationId xmlns:a16="http://schemas.microsoft.com/office/drawing/2014/main" id="{B946DBF9-0579-43D6-9C9C-8DD9E42B031F}"/>
+                <a16:creationId xmlns:a16="http://schemas.microsoft.com/office/drawing/2014/main" id="{7F42B765-DA04-41C6-BBB5-D5B8572D8C14}"/>
               </a:ext>
             </a:extLst>
           </p:cNvPr>
@@ -12234,7 +12047,7 @@
           <p:cNvPr id="25" name="">
             <a:extLst xmlns:a="http://schemas.openxmlformats.org/drawingml/2006/main">
               <a:ext uri="{FF2B5EF4-FFF2-40B4-BE49-F238E27FC236}">
-                <a16:creationId xmlns:a16="http://schemas.microsoft.com/office/drawing/2014/main" id="{010C1F4B-4BD5-41C7-A83D-9286546CF333}"/>
+                <a16:creationId xmlns:a16="http://schemas.microsoft.com/office/drawing/2014/main" id="{C4378FEB-21B0-44C2-8170-60A1D80A97EB}"/>
               </a:ext>
             </a:extLst>
           </p:cNvPr>
@@ -12397,170 +12210,7 @@
           <p:cNvPr id="26" name="">
             <a:extLst xmlns:a="http://schemas.openxmlformats.org/drawingml/2006/main">
               <a:ext uri="{FF2B5EF4-FFF2-40B4-BE49-F238E27FC236}">
-                <a16:creationId xmlns:a16="http://schemas.microsoft.com/office/drawing/2014/main" id="{700A504B-AAA7-40B2-9A0D-C796F15164F3}"/>
-              </a:ext>
-            </a:extLst>
-          </p:cNvPr>
-          <p:cNvSpPr>
-            <a:spLocks xmlns:a="http://schemas.openxmlformats.org/drawingml/2006/main" noGrp="1"/>
-          </p:cNvSpPr>
-          <p:nvPr/>
-        </p:nvSpPr>
-        <p:spPr>
-          <a:xfrm xmlns:a="http://schemas.openxmlformats.org/drawingml/2006/main">
-            <a:off x="666750" y="6419850"/>
-            <a:ext cx="4762500" cy="190500"/>
-          </a:xfrm>
-          <a:prstGeom xmlns:a="http://schemas.openxmlformats.org/drawingml/2006/main" prst="rect">
-            <a:avLst/>
-          </a:prstGeom>
-          <a:noFill xmlns:a="http://schemas.openxmlformats.org/drawingml/2006/main"/>
-          <a:ln xmlns:a="http://schemas.openxmlformats.org/drawingml/2006/main" w="0">
-            <a:noFill/>
-            <a:prstDash val="solid"/>
-          </a:ln>
-        </p:spPr>
-        <p:txBody>
-          <a:bodyPr xmlns:a="http://schemas.openxmlformats.org/drawingml/2006/main" wrap="square" lIns="0" tIns="0" rIns="0" bIns="0" anchor="t">
-            <a:normAutofit fontScale="100000"/>
-          </a:bodyPr>
-          <a:lstStyle xmlns:a="http://schemas.openxmlformats.org/drawingml/2006/main">
-            <a:defPPr algn="l">
-              <a:defRPr sz="975" b="0">
-                <a:solidFill>
-                  <a:srgbClr val="6B7280"/>
-                </a:solidFill>
-                <a:latin typeface="Arial"/>
-                <a:ea typeface="Arial"/>
-                <a:cs typeface="Arial"/>
-              </a:defRPr>
-            </a:defPPr>
-            <a:lvl1pPr algn="l">
-              <a:defRPr sz="975" b="0">
-                <a:solidFill>
-                  <a:srgbClr val="6B7280"/>
-                </a:solidFill>
-                <a:latin typeface="Arial"/>
-                <a:ea typeface="Arial"/>
-                <a:cs typeface="Arial"/>
-              </a:defRPr>
-            </a:lvl1pPr>
-            <a:lvl2pPr algn="l">
-              <a:defRPr sz="975" b="0">
-                <a:solidFill>
-                  <a:srgbClr val="6B7280"/>
-                </a:solidFill>
-                <a:latin typeface="Arial"/>
-                <a:ea typeface="Arial"/>
-                <a:cs typeface="Arial"/>
-              </a:defRPr>
-            </a:lvl2pPr>
-            <a:lvl3pPr algn="l">
-              <a:defRPr sz="975" b="0">
-                <a:solidFill>
-                  <a:srgbClr val="6B7280"/>
-                </a:solidFill>
-                <a:latin typeface="Arial"/>
-                <a:ea typeface="Arial"/>
-                <a:cs typeface="Arial"/>
-              </a:defRPr>
-            </a:lvl3pPr>
-            <a:lvl4pPr algn="l">
-              <a:defRPr sz="975" b="0">
-                <a:solidFill>
-                  <a:srgbClr val="6B7280"/>
-                </a:solidFill>
-                <a:latin typeface="Arial"/>
-                <a:ea typeface="Arial"/>
-                <a:cs typeface="Arial"/>
-              </a:defRPr>
-            </a:lvl4pPr>
-            <a:lvl5pPr algn="l">
-              <a:defRPr sz="975" b="0">
-                <a:solidFill>
-                  <a:srgbClr val="6B7280"/>
-                </a:solidFill>
-                <a:latin typeface="Arial"/>
-                <a:ea typeface="Arial"/>
-                <a:cs typeface="Arial"/>
-              </a:defRPr>
-            </a:lvl5pPr>
-            <a:lvl6pPr algn="l">
-              <a:defRPr sz="975" b="0">
-                <a:solidFill>
-                  <a:srgbClr val="6B7280"/>
-                </a:solidFill>
-                <a:latin typeface="Arial"/>
-                <a:ea typeface="Arial"/>
-                <a:cs typeface="Arial"/>
-              </a:defRPr>
-            </a:lvl6pPr>
-            <a:lvl7pPr algn="l">
-              <a:defRPr sz="975" b="0">
-                <a:solidFill>
-                  <a:srgbClr val="6B7280"/>
-                </a:solidFill>
-                <a:latin typeface="Arial"/>
-                <a:ea typeface="Arial"/>
-                <a:cs typeface="Arial"/>
-              </a:defRPr>
-            </a:lvl7pPr>
-            <a:lvl8pPr algn="l">
-              <a:defRPr sz="975" b="0">
-                <a:solidFill>
-                  <a:srgbClr val="6B7280"/>
-                </a:solidFill>
-                <a:latin typeface="Arial"/>
-                <a:ea typeface="Arial"/>
-                <a:cs typeface="Arial"/>
-              </a:defRPr>
-            </a:lvl8pPr>
-            <a:lvl9pPr algn="l">
-              <a:defRPr sz="975" b="0">
-                <a:solidFill>
-                  <a:srgbClr val="6B7280"/>
-                </a:solidFill>
-                <a:latin typeface="Arial"/>
-                <a:ea typeface="Arial"/>
-                <a:cs typeface="Arial"/>
-              </a:defRPr>
-            </a:lvl9pPr>
-          </a:lstStyle>
-          <a:p xmlns:a="http://schemas.openxmlformats.org/drawingml/2006/main">
-            <a:pPr algn="l">
-              <a:lnSpc>
-                <a:spcPct val="105000"/>
-              </a:lnSpc>
-              <a:buNone/>
-              <a:defRPr sz="975" b="0">
-                <a:solidFill>
-                  <a:srgbClr val="6B7280"/>
-                </a:solidFill>
-                <a:latin typeface="Arial"/>
-                <a:ea typeface="Arial"/>
-                <a:cs typeface="Arial"/>
-              </a:defRPr>
-            </a:pPr>
-            <a:r>
-              <a:rPr sz="975" b="0">
-                <a:solidFill>
-                  <a:srgbClr val="6B7280"/>
-                </a:solidFill>
-                <a:latin typeface="Arial"/>
-                <a:ea typeface="Arial"/>
-                <a:cs typeface="Arial"/>
-              </a:rPr>
-              <a:t>Спикер · Максим</a:t>
-            </a:r>
-          </a:p>
-        </p:txBody>
-      </p:sp>
-      <p:sp>
-        <p:nvSpPr>
-          <p:cNvPr id="27" name="">
-            <a:extLst xmlns:a="http://schemas.openxmlformats.org/drawingml/2006/main">
-              <a:ext uri="{FF2B5EF4-FFF2-40B4-BE49-F238E27FC236}">
-                <a16:creationId xmlns:a16="http://schemas.microsoft.com/office/drawing/2014/main" id="{0C7FFF05-9358-43C5-9F1E-38E49B8D2B03}"/>
+                <a16:creationId xmlns:a16="http://schemas.microsoft.com/office/drawing/2014/main" id="{ED674FF0-DC12-4437-A406-D12D7AE08736}"/>
               </a:ext>
             </a:extLst>
           </p:cNvPr>
@@ -12721,7 +12371,7 @@
     </p:spTree>
     <p:extLst>
       <p:ext uri="{BB962C8B-B14F-4D97-AF65-F5344CB8AC3E}">
-        <p14:creationId xmlns:p14="http://schemas.microsoft.com/office/powerpoint/2010/main" val="1399814575"/>
+        <p14:creationId xmlns:p14="http://schemas.microsoft.com/office/powerpoint/2010/main" val="1808205560"/>
       </p:ext>
     </p:extLst>
   </p:cSld>
@@ -12752,7 +12402,7 @@
           <p:cNvPr id="18" name="">
             <a:extLst xmlns:a="http://schemas.openxmlformats.org/drawingml/2006/main">
               <a:ext uri="{FF2B5EF4-FFF2-40B4-BE49-F238E27FC236}">
-                <a16:creationId xmlns:a16="http://schemas.microsoft.com/office/drawing/2014/main" id="{3040E921-63DF-4CCE-A332-2AACB67364D9}"/>
+                <a16:creationId xmlns:a16="http://schemas.microsoft.com/office/drawing/2014/main" id="{2B69817E-15A9-4205-9A24-626B50C54136}"/>
               </a:ext>
             </a:extLst>
           </p:cNvPr>
@@ -12784,7 +12434,7 @@
           <p:cNvPr id="17" name="">
             <a:extLst xmlns:a="http://schemas.openxmlformats.org/drawingml/2006/main">
               <a:ext uri="{FF2B5EF4-FFF2-40B4-BE49-F238E27FC236}">
-                <a16:creationId xmlns:a16="http://schemas.microsoft.com/office/drawing/2014/main" id="{208AAE9A-3292-4D4D-9D14-DCA69154E206}"/>
+                <a16:creationId xmlns:a16="http://schemas.microsoft.com/office/drawing/2014/main" id="{352AC17B-7C50-4813-AA1D-A69F98FB4F16}"/>
               </a:ext>
             </a:extLst>
           </p:cNvPr>
@@ -12816,7 +12466,7 @@
           <p:cNvPr id="16" name="">
             <a:extLst xmlns:a="http://schemas.openxmlformats.org/drawingml/2006/main">
               <a:ext uri="{FF2B5EF4-FFF2-40B4-BE49-F238E27FC236}">
-                <a16:creationId xmlns:a16="http://schemas.microsoft.com/office/drawing/2014/main" id="{E0F5920B-44F5-4C5B-8234-70BA3008A39F}"/>
+                <a16:creationId xmlns:a16="http://schemas.microsoft.com/office/drawing/2014/main" id="{C17B4622-2818-47E8-BFDB-59D9E458C477}"/>
               </a:ext>
             </a:extLst>
           </p:cNvPr>
@@ -12845,10 +12495,10 @@
       </p:cxnSp>
       <p:sp>
         <p:nvSpPr>
-          <p:cNvPr id="30" name="">
+          <p:cNvPr id="29" name="">
             <a:extLst xmlns:a="http://schemas.openxmlformats.org/drawingml/2006/main">
               <a:ext uri="{FF2B5EF4-FFF2-40B4-BE49-F238E27FC236}">
-                <a16:creationId xmlns:a16="http://schemas.microsoft.com/office/drawing/2014/main" id="{13637341-713D-46CA-9BF4-D4308AACBEA9}"/>
+                <a16:creationId xmlns:a16="http://schemas.microsoft.com/office/drawing/2014/main" id="{667F1CC0-2CAD-4D4F-B127-250C9BF9233E}"/>
               </a:ext>
             </a:extLst>
           </p:cNvPr>
@@ -13001,7 +12651,7 @@
                 <a:ea typeface="Arial"/>
                 <a:cs typeface="Arial"/>
               </a:rPr>
-              <a:t>3 · ПЛАНИРОВЩИК МЕНЮ</a:t>
+              <a:t>3 · ПЛАНИРОВЩИК GEMINI</a:t>
             </a:r>
           </a:p>
         </p:txBody>
@@ -13011,7 +12661,7 @@
           <p:cNvPr id="2" name="">
             <a:extLst xmlns:a="http://schemas.openxmlformats.org/drawingml/2006/main">
               <a:ext uri="{FF2B5EF4-FFF2-40B4-BE49-F238E27FC236}">
-                <a16:creationId xmlns:a16="http://schemas.microsoft.com/office/drawing/2014/main" id="{47A8DEC1-DEA2-4773-9A60-EE518E64C600}"/>
+                <a16:creationId xmlns:a16="http://schemas.microsoft.com/office/drawing/2014/main" id="{3A7BB83F-7F2E-4C35-8E81-7CF428FAA10F}"/>
               </a:ext>
             </a:extLst>
           </p:cNvPr>
@@ -13164,7 +12814,7 @@
                 <a:ea typeface="Arial"/>
                 <a:cs typeface="Arial"/>
               </a:rPr>
-              <a:t>Модель выбирает, но не считает</a:t>
+              <a:t>Gemini составляет меню из кандидатов</a:t>
             </a:r>
           </a:p>
         </p:txBody>
@@ -13174,7 +12824,7 @@
           <p:cNvPr id="3" name="">
             <a:extLst xmlns:a="http://schemas.openxmlformats.org/drawingml/2006/main">
               <a:ext uri="{FF2B5EF4-FFF2-40B4-BE49-F238E27FC236}">
-                <a16:creationId xmlns:a16="http://schemas.microsoft.com/office/drawing/2014/main" id="{2D345704-3032-47DB-A4AD-95BF424CA5FD}"/>
+                <a16:creationId xmlns:a16="http://schemas.microsoft.com/office/drawing/2014/main" id="{B0D8C2F1-1E3A-4FE5-832A-4FA91BC47677}"/>
               </a:ext>
             </a:extLst>
           </p:cNvPr>
@@ -13327,7 +12977,7 @@
                 <a:ea typeface="Arial"/>
                 <a:cs typeface="Arial"/>
               </a:rPr>
-              <a:t>Строгий контракт ограничивает модель списком допустимых рецептов.</a:t>
+              <a:t>Ответ проходит проверку схемы и допустимых ID.</a:t>
             </a:r>
           </a:p>
         </p:txBody>
@@ -13337,7 +12987,7 @@
           <p:cNvPr id="4" name="">
             <a:extLst xmlns:a="http://schemas.openxmlformats.org/drawingml/2006/main">
               <a:ext uri="{FF2B5EF4-FFF2-40B4-BE49-F238E27FC236}">
-                <a16:creationId xmlns:a16="http://schemas.microsoft.com/office/drawing/2014/main" id="{577C1B75-6C3A-49D5-858C-9489989D42BE}"/>
+                <a16:creationId xmlns:a16="http://schemas.microsoft.com/office/drawing/2014/main" id="{9DE15D01-18F1-4843-B15C-EEA33327338F}"/>
               </a:ext>
             </a:extLst>
           </p:cNvPr>
@@ -13372,7 +13022,7 @@
           <p:cNvPr id="5" name="">
             <a:extLst xmlns:a="http://schemas.openxmlformats.org/drawingml/2006/main">
               <a:ext uri="{FF2B5EF4-FFF2-40B4-BE49-F238E27FC236}">
-                <a16:creationId xmlns:a16="http://schemas.microsoft.com/office/drawing/2014/main" id="{3578251D-04B8-4960-A6F4-8A8E417EA5D4}"/>
+                <a16:creationId xmlns:a16="http://schemas.microsoft.com/office/drawing/2014/main" id="{87D46D6F-E7A5-4285-A7B8-63CA2DBD9184}"/>
               </a:ext>
             </a:extLst>
           </p:cNvPr>
@@ -13535,7 +13185,7 @@
           <p:cNvPr id="6" name="">
             <a:extLst xmlns:a="http://schemas.openxmlformats.org/drawingml/2006/main">
               <a:ext uri="{FF2B5EF4-FFF2-40B4-BE49-F238E27FC236}">
-                <a16:creationId xmlns:a16="http://schemas.microsoft.com/office/drawing/2014/main" id="{BF154404-FD0C-4AEB-8C09-FD03A1C4340D}"/>
+                <a16:creationId xmlns:a16="http://schemas.microsoft.com/office/drawing/2014/main" id="{DA142F93-3B86-4202-8C7E-509097232A0F}"/>
               </a:ext>
             </a:extLst>
           </p:cNvPr>
@@ -13698,7 +13348,7 @@
           <p:cNvPr id="7" name="">
             <a:extLst xmlns:a="http://schemas.openxmlformats.org/drawingml/2006/main">
               <a:ext uri="{FF2B5EF4-FFF2-40B4-BE49-F238E27FC236}">
-                <a16:creationId xmlns:a16="http://schemas.microsoft.com/office/drawing/2014/main" id="{305B6439-36AB-48EE-8B54-5C753E95DC14}"/>
+                <a16:creationId xmlns:a16="http://schemas.microsoft.com/office/drawing/2014/main" id="{C0C68ADE-8BD2-447B-AB15-8B843B9D4972}"/>
               </a:ext>
             </a:extLst>
           </p:cNvPr>
@@ -13733,7 +13383,7 @@
           <p:cNvPr id="8" name="">
             <a:extLst xmlns:a="http://schemas.openxmlformats.org/drawingml/2006/main">
               <a:ext uri="{FF2B5EF4-FFF2-40B4-BE49-F238E27FC236}">
-                <a16:creationId xmlns:a16="http://schemas.microsoft.com/office/drawing/2014/main" id="{56956BA3-7812-43D3-B460-45AC9C21F2A2}"/>
+                <a16:creationId xmlns:a16="http://schemas.microsoft.com/office/drawing/2014/main" id="{21CACCE9-60B2-4FFC-AF14-079F6D65845E}"/>
               </a:ext>
             </a:extLst>
           </p:cNvPr>
@@ -13896,7 +13546,7 @@
           <p:cNvPr id="9" name="">
             <a:extLst xmlns:a="http://schemas.openxmlformats.org/drawingml/2006/main">
               <a:ext uri="{FF2B5EF4-FFF2-40B4-BE49-F238E27FC236}">
-                <a16:creationId xmlns:a16="http://schemas.microsoft.com/office/drawing/2014/main" id="{EDBE7E27-1A3D-40C5-8BCE-D2FF3AA214A3}"/>
+                <a16:creationId xmlns:a16="http://schemas.microsoft.com/office/drawing/2014/main" id="{5829183D-CF69-4C0B-8DE7-0ADF2FFF9B49}"/>
               </a:ext>
             </a:extLst>
           </p:cNvPr>
@@ -14059,7 +13709,7 @@
           <p:cNvPr id="10" name="">
             <a:extLst xmlns:a="http://schemas.openxmlformats.org/drawingml/2006/main">
               <a:ext uri="{FF2B5EF4-FFF2-40B4-BE49-F238E27FC236}">
-                <a16:creationId xmlns:a16="http://schemas.microsoft.com/office/drawing/2014/main" id="{60E036C0-08BB-4AB9-9CE3-918FF597BD79}"/>
+                <a16:creationId xmlns:a16="http://schemas.microsoft.com/office/drawing/2014/main" id="{39AA636B-C0D8-4F7C-9C37-5401DA775067}"/>
               </a:ext>
             </a:extLst>
           </p:cNvPr>
@@ -14094,7 +13744,7 @@
           <p:cNvPr id="11" name="">
             <a:extLst xmlns:a="http://schemas.openxmlformats.org/drawingml/2006/main">
               <a:ext uri="{FF2B5EF4-FFF2-40B4-BE49-F238E27FC236}">
-                <a16:creationId xmlns:a16="http://schemas.microsoft.com/office/drawing/2014/main" id="{971B795E-D40A-49A3-89BA-4D7261B10509}"/>
+                <a16:creationId xmlns:a16="http://schemas.microsoft.com/office/drawing/2014/main" id="{9FF81C5F-5736-4F67-A3F7-01BDCECAA703}"/>
               </a:ext>
             </a:extLst>
           </p:cNvPr>
@@ -14257,7 +13907,7 @@
           <p:cNvPr id="12" name="">
             <a:extLst xmlns:a="http://schemas.openxmlformats.org/drawingml/2006/main">
               <a:ext uri="{FF2B5EF4-FFF2-40B4-BE49-F238E27FC236}">
-                <a16:creationId xmlns:a16="http://schemas.microsoft.com/office/drawing/2014/main" id="{F0270832-AA7D-4173-B30A-8C1DE6C2BFA6}"/>
+                <a16:creationId xmlns:a16="http://schemas.microsoft.com/office/drawing/2014/main" id="{87C7A0EC-A6EC-4638-BA06-5B014A139EC3}"/>
               </a:ext>
             </a:extLst>
           </p:cNvPr>
@@ -14420,7 +14070,7 @@
           <p:cNvPr id="13" name="">
             <a:extLst xmlns:a="http://schemas.openxmlformats.org/drawingml/2006/main">
               <a:ext uri="{FF2B5EF4-FFF2-40B4-BE49-F238E27FC236}">
-                <a16:creationId xmlns:a16="http://schemas.microsoft.com/office/drawing/2014/main" id="{822B5469-00E0-4EEB-BCA9-2C82A74D3E06}"/>
+                <a16:creationId xmlns:a16="http://schemas.microsoft.com/office/drawing/2014/main" id="{916737A5-EB80-4346-8431-B173BC0D9E7D}"/>
               </a:ext>
             </a:extLst>
           </p:cNvPr>
@@ -14455,7 +14105,7 @@
           <p:cNvPr id="14" name="">
             <a:extLst xmlns:a="http://schemas.openxmlformats.org/drawingml/2006/main">
               <a:ext uri="{FF2B5EF4-FFF2-40B4-BE49-F238E27FC236}">
-                <a16:creationId xmlns:a16="http://schemas.microsoft.com/office/drawing/2014/main" id="{4537FC12-702D-4876-9634-B969853268C6}"/>
+                <a16:creationId xmlns:a16="http://schemas.microsoft.com/office/drawing/2014/main" id="{11E58077-26A2-4F0F-A48B-83546E3A92F7}"/>
               </a:ext>
             </a:extLst>
           </p:cNvPr>
@@ -14618,7 +14268,7 @@
           <p:cNvPr id="15" name="">
             <a:extLst xmlns:a="http://schemas.openxmlformats.org/drawingml/2006/main">
               <a:ext uri="{FF2B5EF4-FFF2-40B4-BE49-F238E27FC236}">
-                <a16:creationId xmlns:a16="http://schemas.microsoft.com/office/drawing/2014/main" id="{D7679E8B-6756-48C5-A1FD-C8B2496FA288}"/>
+                <a16:creationId xmlns:a16="http://schemas.microsoft.com/office/drawing/2014/main" id="{4280EEC2-8F0F-4838-9D9C-E38D25511104}"/>
               </a:ext>
             </a:extLst>
           </p:cNvPr>
@@ -14781,7 +14431,7 @@
           <p:cNvPr id="19" name="">
             <a:extLst xmlns:a="http://schemas.openxmlformats.org/drawingml/2006/main">
               <a:ext uri="{FF2B5EF4-FFF2-40B4-BE49-F238E27FC236}">
-                <a16:creationId xmlns:a16="http://schemas.microsoft.com/office/drawing/2014/main" id="{4A5B5502-30FC-4F8E-8F98-67F6DEE91D6E}"/>
+                <a16:creationId xmlns:a16="http://schemas.microsoft.com/office/drawing/2014/main" id="{B591831D-E6C2-44A9-AC3F-4C3AD7363E55}"/>
               </a:ext>
             </a:extLst>
           </p:cNvPr>
@@ -14816,7 +14466,7 @@
           <p:cNvPr id="20" name="">
             <a:extLst xmlns:a="http://schemas.openxmlformats.org/drawingml/2006/main">
               <a:ext uri="{FF2B5EF4-FFF2-40B4-BE49-F238E27FC236}">
-                <a16:creationId xmlns:a16="http://schemas.microsoft.com/office/drawing/2014/main" id="{9B79DE2C-7C25-4DF8-9DDF-39E010C21708}"/>
+                <a16:creationId xmlns:a16="http://schemas.microsoft.com/office/drawing/2014/main" id="{8E8DE836-7997-4D51-A3AC-3ABB7B55363D}"/>
               </a:ext>
             </a:extLst>
           </p:cNvPr>
@@ -15087,7 +14737,7 @@
           <p:cNvPr id="21" name="">
             <a:extLst xmlns:a="http://schemas.openxmlformats.org/drawingml/2006/main">
               <a:ext uri="{FF2B5EF4-FFF2-40B4-BE49-F238E27FC236}">
-                <a16:creationId xmlns:a16="http://schemas.microsoft.com/office/drawing/2014/main" id="{56ADE043-A8A1-414D-AA60-974033CB3C97}"/>
+                <a16:creationId xmlns:a16="http://schemas.microsoft.com/office/drawing/2014/main" id="{1F27A358-7CFB-4AB9-9333-7C8B117BA6EF}"/>
               </a:ext>
             </a:extLst>
           </p:cNvPr>
@@ -15240,7 +14890,7 @@
                 <a:ea typeface="Arial"/>
                 <a:cs typeface="Arial"/>
               </a:rPr>
-              <a:t>Три защиты от ошибок модели</a:t>
+              <a:t>Контроль ответа модели</a:t>
             </a:r>
           </a:p>
         </p:txBody>
@@ -15250,7 +14900,7 @@
           <p:cNvPr id="22" name="">
             <a:extLst xmlns:a="http://schemas.openxmlformats.org/drawingml/2006/main">
               <a:ext uri="{FF2B5EF4-FFF2-40B4-BE49-F238E27FC236}">
-                <a16:creationId xmlns:a16="http://schemas.microsoft.com/office/drawing/2014/main" id="{F76450F0-3AF3-4A38-A166-A0300A7ED24D}"/>
+                <a16:creationId xmlns:a16="http://schemas.microsoft.com/office/drawing/2014/main" id="{FC0337B6-7842-4049-A8D7-6A6AEBE53811}"/>
               </a:ext>
             </a:extLst>
           </p:cNvPr>
@@ -15283,7 +14933,7 @@
           <p:cNvPr id="23" name="">
             <a:extLst xmlns:a="http://schemas.openxmlformats.org/drawingml/2006/main">
               <a:ext uri="{FF2B5EF4-FFF2-40B4-BE49-F238E27FC236}">
-                <a16:creationId xmlns:a16="http://schemas.microsoft.com/office/drawing/2014/main" id="{14A9F078-A6E4-4A66-A720-3D81D381179C}"/>
+                <a16:creationId xmlns:a16="http://schemas.microsoft.com/office/drawing/2014/main" id="{EEC07845-E4F2-4E67-B477-81110C8C18CA}"/>
               </a:ext>
             </a:extLst>
           </p:cNvPr>
@@ -15446,7 +15096,7 @@
           <p:cNvPr id="24" name="">
             <a:extLst xmlns:a="http://schemas.openxmlformats.org/drawingml/2006/main">
               <a:ext uri="{FF2B5EF4-FFF2-40B4-BE49-F238E27FC236}">
-                <a16:creationId xmlns:a16="http://schemas.microsoft.com/office/drawing/2014/main" id="{34047CBA-EED6-4E3F-9EE2-883CC060B474}"/>
+                <a16:creationId xmlns:a16="http://schemas.microsoft.com/office/drawing/2014/main" id="{AA198FE6-CBEC-4508-8EEE-5A23449A6703}"/>
               </a:ext>
             </a:extLst>
           </p:cNvPr>
@@ -15479,7 +15129,7 @@
           <p:cNvPr id="25" name="">
             <a:extLst xmlns:a="http://schemas.openxmlformats.org/drawingml/2006/main">
               <a:ext uri="{FF2B5EF4-FFF2-40B4-BE49-F238E27FC236}">
-                <a16:creationId xmlns:a16="http://schemas.microsoft.com/office/drawing/2014/main" id="{9243E448-2140-4C4C-B68A-1DD1DD66D35D}"/>
+                <a16:creationId xmlns:a16="http://schemas.microsoft.com/office/drawing/2014/main" id="{15EA6C7A-AD18-4350-AE34-4A74877A02D4}"/>
               </a:ext>
             </a:extLst>
           </p:cNvPr>
@@ -15642,7 +15292,7 @@
           <p:cNvPr id="26" name="">
             <a:extLst xmlns:a="http://schemas.openxmlformats.org/drawingml/2006/main">
               <a:ext uri="{FF2B5EF4-FFF2-40B4-BE49-F238E27FC236}">
-                <a16:creationId xmlns:a16="http://schemas.microsoft.com/office/drawing/2014/main" id="{4560F6EC-BC56-40C9-A613-F2C8486F8DC3}"/>
+                <a16:creationId xmlns:a16="http://schemas.microsoft.com/office/drawing/2014/main" id="{6DD03FFC-3D0D-493E-B886-2602356690DE}"/>
               </a:ext>
             </a:extLst>
           </p:cNvPr>
@@ -15675,7 +15325,7 @@
           <p:cNvPr id="27" name="">
             <a:extLst xmlns:a="http://schemas.openxmlformats.org/drawingml/2006/main">
               <a:ext uri="{FF2B5EF4-FFF2-40B4-BE49-F238E27FC236}">
-                <a16:creationId xmlns:a16="http://schemas.microsoft.com/office/drawing/2014/main" id="{2BB2C8FC-398E-48BC-A296-00546C0F780E}"/>
+                <a16:creationId xmlns:a16="http://schemas.microsoft.com/office/drawing/2014/main" id="{497C0092-844C-4F22-BE8D-7546CAD25996}"/>
               </a:ext>
             </a:extLst>
           </p:cNvPr>
@@ -15838,170 +15488,7 @@
           <p:cNvPr id="28" name="">
             <a:extLst xmlns:a="http://schemas.openxmlformats.org/drawingml/2006/main">
               <a:ext uri="{FF2B5EF4-FFF2-40B4-BE49-F238E27FC236}">
-                <a16:creationId xmlns:a16="http://schemas.microsoft.com/office/drawing/2014/main" id="{19E68CF6-FB4F-45B0-9753-FA90501DE5C2}"/>
-              </a:ext>
-            </a:extLst>
-          </p:cNvPr>
-          <p:cNvSpPr>
-            <a:spLocks xmlns:a="http://schemas.openxmlformats.org/drawingml/2006/main" noGrp="1"/>
-          </p:cNvSpPr>
-          <p:nvPr/>
-        </p:nvSpPr>
-        <p:spPr>
-          <a:xfrm xmlns:a="http://schemas.openxmlformats.org/drawingml/2006/main">
-            <a:off x="666750" y="6419850"/>
-            <a:ext cx="4762500" cy="190500"/>
-          </a:xfrm>
-          <a:prstGeom xmlns:a="http://schemas.openxmlformats.org/drawingml/2006/main" prst="rect">
-            <a:avLst/>
-          </a:prstGeom>
-          <a:noFill xmlns:a="http://schemas.openxmlformats.org/drawingml/2006/main"/>
-          <a:ln xmlns:a="http://schemas.openxmlformats.org/drawingml/2006/main" w="0">
-            <a:noFill/>
-            <a:prstDash val="solid"/>
-          </a:ln>
-        </p:spPr>
-        <p:txBody>
-          <a:bodyPr xmlns:a="http://schemas.openxmlformats.org/drawingml/2006/main" wrap="square" lIns="0" tIns="0" rIns="0" bIns="0" anchor="t">
-            <a:normAutofit fontScale="100000"/>
-          </a:bodyPr>
-          <a:lstStyle xmlns:a="http://schemas.openxmlformats.org/drawingml/2006/main">
-            <a:defPPr algn="l">
-              <a:defRPr sz="975" b="0">
-                <a:solidFill>
-                  <a:srgbClr val="6B7280"/>
-                </a:solidFill>
-                <a:latin typeface="Arial"/>
-                <a:ea typeface="Arial"/>
-                <a:cs typeface="Arial"/>
-              </a:defRPr>
-            </a:defPPr>
-            <a:lvl1pPr algn="l">
-              <a:defRPr sz="975" b="0">
-                <a:solidFill>
-                  <a:srgbClr val="6B7280"/>
-                </a:solidFill>
-                <a:latin typeface="Arial"/>
-                <a:ea typeface="Arial"/>
-                <a:cs typeface="Arial"/>
-              </a:defRPr>
-            </a:lvl1pPr>
-            <a:lvl2pPr algn="l">
-              <a:defRPr sz="975" b="0">
-                <a:solidFill>
-                  <a:srgbClr val="6B7280"/>
-                </a:solidFill>
-                <a:latin typeface="Arial"/>
-                <a:ea typeface="Arial"/>
-                <a:cs typeface="Arial"/>
-              </a:defRPr>
-            </a:lvl2pPr>
-            <a:lvl3pPr algn="l">
-              <a:defRPr sz="975" b="0">
-                <a:solidFill>
-                  <a:srgbClr val="6B7280"/>
-                </a:solidFill>
-                <a:latin typeface="Arial"/>
-                <a:ea typeface="Arial"/>
-                <a:cs typeface="Arial"/>
-              </a:defRPr>
-            </a:lvl3pPr>
-            <a:lvl4pPr algn="l">
-              <a:defRPr sz="975" b="0">
-                <a:solidFill>
-                  <a:srgbClr val="6B7280"/>
-                </a:solidFill>
-                <a:latin typeface="Arial"/>
-                <a:ea typeface="Arial"/>
-                <a:cs typeface="Arial"/>
-              </a:defRPr>
-            </a:lvl4pPr>
-            <a:lvl5pPr algn="l">
-              <a:defRPr sz="975" b="0">
-                <a:solidFill>
-                  <a:srgbClr val="6B7280"/>
-                </a:solidFill>
-                <a:latin typeface="Arial"/>
-                <a:ea typeface="Arial"/>
-                <a:cs typeface="Arial"/>
-              </a:defRPr>
-            </a:lvl5pPr>
-            <a:lvl6pPr algn="l">
-              <a:defRPr sz="975" b="0">
-                <a:solidFill>
-                  <a:srgbClr val="6B7280"/>
-                </a:solidFill>
-                <a:latin typeface="Arial"/>
-                <a:ea typeface="Arial"/>
-                <a:cs typeface="Arial"/>
-              </a:defRPr>
-            </a:lvl6pPr>
-            <a:lvl7pPr algn="l">
-              <a:defRPr sz="975" b="0">
-                <a:solidFill>
-                  <a:srgbClr val="6B7280"/>
-                </a:solidFill>
-                <a:latin typeface="Arial"/>
-                <a:ea typeface="Arial"/>
-                <a:cs typeface="Arial"/>
-              </a:defRPr>
-            </a:lvl7pPr>
-            <a:lvl8pPr algn="l">
-              <a:defRPr sz="975" b="0">
-                <a:solidFill>
-                  <a:srgbClr val="6B7280"/>
-                </a:solidFill>
-                <a:latin typeface="Arial"/>
-                <a:ea typeface="Arial"/>
-                <a:cs typeface="Arial"/>
-              </a:defRPr>
-            </a:lvl8pPr>
-            <a:lvl9pPr algn="l">
-              <a:defRPr sz="975" b="0">
-                <a:solidFill>
-                  <a:srgbClr val="6B7280"/>
-                </a:solidFill>
-                <a:latin typeface="Arial"/>
-                <a:ea typeface="Arial"/>
-                <a:cs typeface="Arial"/>
-              </a:defRPr>
-            </a:lvl9pPr>
-          </a:lstStyle>
-          <a:p xmlns:a="http://schemas.openxmlformats.org/drawingml/2006/main">
-            <a:pPr algn="l">
-              <a:lnSpc>
-                <a:spcPct val="105000"/>
-              </a:lnSpc>
-              <a:buNone/>
-              <a:defRPr sz="975" b="0">
-                <a:solidFill>
-                  <a:srgbClr val="6B7280"/>
-                </a:solidFill>
-                <a:latin typeface="Arial"/>
-                <a:ea typeface="Arial"/>
-                <a:cs typeface="Arial"/>
-              </a:defRPr>
-            </a:pPr>
-            <a:r>
-              <a:rPr sz="975" b="0">
-                <a:solidFill>
-                  <a:srgbClr val="6B7280"/>
-                </a:solidFill>
-                <a:latin typeface="Arial"/>
-                <a:ea typeface="Arial"/>
-                <a:cs typeface="Arial"/>
-              </a:rPr>
-              <a:t>Спикер · Рита</a:t>
-            </a:r>
-          </a:p>
-        </p:txBody>
-      </p:sp>
-      <p:sp>
-        <p:nvSpPr>
-          <p:cNvPr id="29" name="">
-            <a:extLst xmlns:a="http://schemas.openxmlformats.org/drawingml/2006/main">
-              <a:ext uri="{FF2B5EF4-FFF2-40B4-BE49-F238E27FC236}">
-                <a16:creationId xmlns:a16="http://schemas.microsoft.com/office/drawing/2014/main" id="{27BC4821-2760-4BC2-89AE-390D379C5C6A}"/>
+                <a16:creationId xmlns:a16="http://schemas.microsoft.com/office/drawing/2014/main" id="{A7BB4FD7-863C-44E9-A44D-915298FA1231}"/>
               </a:ext>
             </a:extLst>
           </p:cNvPr>
@@ -16162,7 +15649,7 @@
     </p:spTree>
     <p:extLst>
       <p:ext uri="{BB962C8B-B14F-4D97-AF65-F5344CB8AC3E}">
-        <p14:creationId xmlns:p14="http://schemas.microsoft.com/office/powerpoint/2010/main" val="1204632368"/>
+        <p14:creationId xmlns:p14="http://schemas.microsoft.com/office/powerpoint/2010/main" val="90526912"/>
       </p:ext>
     </p:extLst>
   </p:cSld>
@@ -16193,7 +15680,7 @@
           <p:cNvPr id="18" name="">
             <a:extLst xmlns:a="http://schemas.openxmlformats.org/drawingml/2006/main">
               <a:ext uri="{FF2B5EF4-FFF2-40B4-BE49-F238E27FC236}">
-                <a16:creationId xmlns:a16="http://schemas.microsoft.com/office/drawing/2014/main" id="{88C395A4-7F50-4254-8389-10EFB0B403BB}"/>
+                <a16:creationId xmlns:a16="http://schemas.microsoft.com/office/drawing/2014/main" id="{9CA9DC4B-956C-46BF-9162-5A48A90518F7}"/>
               </a:ext>
             </a:extLst>
           </p:cNvPr>
@@ -16225,7 +15712,7 @@
           <p:cNvPr id="17" name="">
             <a:extLst xmlns:a="http://schemas.openxmlformats.org/drawingml/2006/main">
               <a:ext uri="{FF2B5EF4-FFF2-40B4-BE49-F238E27FC236}">
-                <a16:creationId xmlns:a16="http://schemas.microsoft.com/office/drawing/2014/main" id="{A3FFF509-E20D-4F88-B71B-E25E06E595D2}"/>
+                <a16:creationId xmlns:a16="http://schemas.microsoft.com/office/drawing/2014/main" id="{66D5F92E-F864-4579-B561-0F090764E962}"/>
               </a:ext>
             </a:extLst>
           </p:cNvPr>
@@ -16257,7 +15744,7 @@
           <p:cNvPr id="16" name="">
             <a:extLst xmlns:a="http://schemas.openxmlformats.org/drawingml/2006/main">
               <a:ext uri="{FF2B5EF4-FFF2-40B4-BE49-F238E27FC236}">
-                <a16:creationId xmlns:a16="http://schemas.microsoft.com/office/drawing/2014/main" id="{C0DCEB37-A4F4-445A-8C5B-8AE8D97F8CEB}"/>
+                <a16:creationId xmlns:a16="http://schemas.microsoft.com/office/drawing/2014/main" id="{94D4E6EE-42AC-4D8B-8F81-09F210FDB1C8}"/>
               </a:ext>
             </a:extLst>
           </p:cNvPr>
@@ -16286,10 +15773,10 @@
       </p:cxnSp>
       <p:sp>
         <p:nvSpPr>
-          <p:cNvPr id="30" name="">
+          <p:cNvPr id="29" name="">
             <a:extLst xmlns:a="http://schemas.openxmlformats.org/drawingml/2006/main">
               <a:ext uri="{FF2B5EF4-FFF2-40B4-BE49-F238E27FC236}">
-                <a16:creationId xmlns:a16="http://schemas.microsoft.com/office/drawing/2014/main" id="{7239A87F-62CC-4503-84CA-C37F84AADB55}"/>
+                <a16:creationId xmlns:a16="http://schemas.microsoft.com/office/drawing/2014/main" id="{60E0DA01-1D3C-4836-929D-467F0AAC7CA7}"/>
               </a:ext>
             </a:extLst>
           </p:cNvPr>
@@ -16442,7 +15929,7 @@
                 <a:ea typeface="Arial"/>
                 <a:cs typeface="Arial"/>
               </a:rPr>
-              <a:t>4 · КОРЗИНА И ПРОВЕРКА</a:t>
+              <a:t>4 · КОРЗИНА, ПРОВЕРКА И КРИТИК</a:t>
             </a:r>
           </a:p>
         </p:txBody>
@@ -16452,7 +15939,7 @@
           <p:cNvPr id="2" name="">
             <a:extLst xmlns:a="http://schemas.openxmlformats.org/drawingml/2006/main">
               <a:ext uri="{FF2B5EF4-FFF2-40B4-BE49-F238E27FC236}">
-                <a16:creationId xmlns:a16="http://schemas.microsoft.com/office/drawing/2014/main" id="{8B2EC1C8-8418-471F-9CBD-8C39F2351AEE}"/>
+                <a16:creationId xmlns:a16="http://schemas.microsoft.com/office/drawing/2014/main" id="{23B31C6F-2E4A-4EAA-A35D-2873CEA28136}"/>
               </a:ext>
             </a:extLst>
           </p:cNvPr>
@@ -16605,7 +16092,7 @@
                 <a:ea typeface="Arial"/>
                 <a:cs typeface="Arial"/>
               </a:rPr>
-              <a:t>Факты проверяет Python, рекомендации даёт Gemini</a:t>
+              <a:t>Python проверяет, Gemini советует</a:t>
             </a:r>
           </a:p>
         </p:txBody>
@@ -16615,7 +16102,7 @@
           <p:cNvPr id="3" name="">
             <a:extLst xmlns:a="http://schemas.openxmlformats.org/drawingml/2006/main">
               <a:ext uri="{FF2B5EF4-FFF2-40B4-BE49-F238E27FC236}">
-                <a16:creationId xmlns:a16="http://schemas.microsoft.com/office/drawing/2014/main" id="{6FEE4B2A-AB32-4DFB-BAA3-363943A75620}"/>
+                <a16:creationId xmlns:a16="http://schemas.microsoft.com/office/drawing/2014/main" id="{0B673538-9BB0-4DBA-970F-55687CB712F5}"/>
               </a:ext>
             </a:extLst>
           </p:cNvPr>
@@ -16768,7 +16255,7 @@
                 <a:ea typeface="Arial"/>
                 <a:cs typeface="Arial"/>
               </a:rPr>
-              <a:t>Модель получает найденные нарушения и предлагает, как пересобрать меню.</a:t>
+              <a:t>Критик получает нарушения и возвращает рекомендацию планировщику.</a:t>
             </a:r>
           </a:p>
         </p:txBody>
@@ -16778,7 +16265,7 @@
           <p:cNvPr id="4" name="">
             <a:extLst xmlns:a="http://schemas.openxmlformats.org/drawingml/2006/main">
               <a:ext uri="{FF2B5EF4-FFF2-40B4-BE49-F238E27FC236}">
-                <a16:creationId xmlns:a16="http://schemas.microsoft.com/office/drawing/2014/main" id="{43182F24-B05C-49E6-8051-A3CF2BC161F8}"/>
+                <a16:creationId xmlns:a16="http://schemas.microsoft.com/office/drawing/2014/main" id="{A4DC4DA4-8F2D-457C-9D83-790E7CD03865}"/>
               </a:ext>
             </a:extLst>
           </p:cNvPr>
@@ -16813,7 +16300,7 @@
           <p:cNvPr id="5" name="">
             <a:extLst xmlns:a="http://schemas.openxmlformats.org/drawingml/2006/main">
               <a:ext uri="{FF2B5EF4-FFF2-40B4-BE49-F238E27FC236}">
-                <a16:creationId xmlns:a16="http://schemas.microsoft.com/office/drawing/2014/main" id="{E1461C86-D288-49A3-9981-39697F63CC83}"/>
+                <a16:creationId xmlns:a16="http://schemas.microsoft.com/office/drawing/2014/main" id="{C88A8AA6-2ABA-4EA0-A791-D9196668245F}"/>
               </a:ext>
             </a:extLst>
           </p:cNvPr>
@@ -16976,7 +16463,7 @@
           <p:cNvPr id="6" name="">
             <a:extLst xmlns:a="http://schemas.openxmlformats.org/drawingml/2006/main">
               <a:ext uri="{FF2B5EF4-FFF2-40B4-BE49-F238E27FC236}">
-                <a16:creationId xmlns:a16="http://schemas.microsoft.com/office/drawing/2014/main" id="{C7A8CC2C-D27C-4E50-9001-2B2EF0051D7A}"/>
+                <a16:creationId xmlns:a16="http://schemas.microsoft.com/office/drawing/2014/main" id="{9B27611B-A0FB-422C-A5E6-808ED082284D}"/>
               </a:ext>
             </a:extLst>
           </p:cNvPr>
@@ -17139,7 +16626,7 @@
           <p:cNvPr id="7" name="">
             <a:extLst xmlns:a="http://schemas.openxmlformats.org/drawingml/2006/main">
               <a:ext uri="{FF2B5EF4-FFF2-40B4-BE49-F238E27FC236}">
-                <a16:creationId xmlns:a16="http://schemas.microsoft.com/office/drawing/2014/main" id="{370D686F-A10E-44A8-8CA1-5E6BC931B8A2}"/>
+                <a16:creationId xmlns:a16="http://schemas.microsoft.com/office/drawing/2014/main" id="{ED3FC022-D3E2-435A-9170-7CEE4C2F4FE1}"/>
               </a:ext>
             </a:extLst>
           </p:cNvPr>
@@ -17174,7 +16661,7 @@
           <p:cNvPr id="8" name="">
             <a:extLst xmlns:a="http://schemas.openxmlformats.org/drawingml/2006/main">
               <a:ext uri="{FF2B5EF4-FFF2-40B4-BE49-F238E27FC236}">
-                <a16:creationId xmlns:a16="http://schemas.microsoft.com/office/drawing/2014/main" id="{F581CFD6-91CC-4503-8776-C086D81E8A4E}"/>
+                <a16:creationId xmlns:a16="http://schemas.microsoft.com/office/drawing/2014/main" id="{FD8C9B64-BF4E-4318-8382-5FB63F851038}"/>
               </a:ext>
             </a:extLst>
           </p:cNvPr>
@@ -17337,7 +16824,7 @@
           <p:cNvPr id="9" name="">
             <a:extLst xmlns:a="http://schemas.openxmlformats.org/drawingml/2006/main">
               <a:ext uri="{FF2B5EF4-FFF2-40B4-BE49-F238E27FC236}">
-                <a16:creationId xmlns:a16="http://schemas.microsoft.com/office/drawing/2014/main" id="{7E72C391-88F0-4BC5-9AF6-3D945F80327B}"/>
+                <a16:creationId xmlns:a16="http://schemas.microsoft.com/office/drawing/2014/main" id="{601C17A7-EDE9-4AD2-8429-4B30ED406A81}"/>
               </a:ext>
             </a:extLst>
           </p:cNvPr>
@@ -17500,7 +16987,7 @@
           <p:cNvPr id="10" name="">
             <a:extLst xmlns:a="http://schemas.openxmlformats.org/drawingml/2006/main">
               <a:ext uri="{FF2B5EF4-FFF2-40B4-BE49-F238E27FC236}">
-                <a16:creationId xmlns:a16="http://schemas.microsoft.com/office/drawing/2014/main" id="{508FE8F9-EB2D-4A0F-95A6-6A59DC6F7985}"/>
+                <a16:creationId xmlns:a16="http://schemas.microsoft.com/office/drawing/2014/main" id="{AE546E6F-5F2A-4D8F-AADE-7AAF7C682412}"/>
               </a:ext>
             </a:extLst>
           </p:cNvPr>
@@ -17535,7 +17022,7 @@
           <p:cNvPr id="11" name="">
             <a:extLst xmlns:a="http://schemas.openxmlformats.org/drawingml/2006/main">
               <a:ext uri="{FF2B5EF4-FFF2-40B4-BE49-F238E27FC236}">
-                <a16:creationId xmlns:a16="http://schemas.microsoft.com/office/drawing/2014/main" id="{7A1EBEFF-80FD-4582-8033-86C7E15F8D1D}"/>
+                <a16:creationId xmlns:a16="http://schemas.microsoft.com/office/drawing/2014/main" id="{710B98A4-A4E2-424F-81FF-E76D9607CCDF}"/>
               </a:ext>
             </a:extLst>
           </p:cNvPr>
@@ -17698,7 +17185,7 @@
           <p:cNvPr id="12" name="">
             <a:extLst xmlns:a="http://schemas.openxmlformats.org/drawingml/2006/main">
               <a:ext uri="{FF2B5EF4-FFF2-40B4-BE49-F238E27FC236}">
-                <a16:creationId xmlns:a16="http://schemas.microsoft.com/office/drawing/2014/main" id="{A38A1D91-A463-4503-95B7-A79C1DC60288}"/>
+                <a16:creationId xmlns:a16="http://schemas.microsoft.com/office/drawing/2014/main" id="{E0577F4E-8953-4DD4-A950-1DBA7F19C806}"/>
               </a:ext>
             </a:extLst>
           </p:cNvPr>
@@ -17861,7 +17348,7 @@
           <p:cNvPr id="13" name="">
             <a:extLst xmlns:a="http://schemas.openxmlformats.org/drawingml/2006/main">
               <a:ext uri="{FF2B5EF4-FFF2-40B4-BE49-F238E27FC236}">
-                <a16:creationId xmlns:a16="http://schemas.microsoft.com/office/drawing/2014/main" id="{BAACA875-3083-49A7-A294-5B5D4E779184}"/>
+                <a16:creationId xmlns:a16="http://schemas.microsoft.com/office/drawing/2014/main" id="{AE782245-913B-430A-9274-6E6DC88CBBD3}"/>
               </a:ext>
             </a:extLst>
           </p:cNvPr>
@@ -17896,7 +17383,7 @@
           <p:cNvPr id="14" name="">
             <a:extLst xmlns:a="http://schemas.openxmlformats.org/drawingml/2006/main">
               <a:ext uri="{FF2B5EF4-FFF2-40B4-BE49-F238E27FC236}">
-                <a16:creationId xmlns:a16="http://schemas.microsoft.com/office/drawing/2014/main" id="{4C6DA6E7-5C88-41E0-95FF-8D8904A987E3}"/>
+                <a16:creationId xmlns:a16="http://schemas.microsoft.com/office/drawing/2014/main" id="{5AC0D54E-F0D5-406C-9668-D5BFF8234375}"/>
               </a:ext>
             </a:extLst>
           </p:cNvPr>
@@ -18059,7 +17546,7 @@
           <p:cNvPr id="15" name="">
             <a:extLst xmlns:a="http://schemas.openxmlformats.org/drawingml/2006/main">
               <a:ext uri="{FF2B5EF4-FFF2-40B4-BE49-F238E27FC236}">
-                <a16:creationId xmlns:a16="http://schemas.microsoft.com/office/drawing/2014/main" id="{E6C6F260-6259-4CC9-9D54-C88ECF2E9146}"/>
+                <a16:creationId xmlns:a16="http://schemas.microsoft.com/office/drawing/2014/main" id="{5DF649C8-06E5-481E-BB80-D96D1DE89A96}"/>
               </a:ext>
             </a:extLst>
           </p:cNvPr>
@@ -18222,7 +17709,7 @@
           <p:cNvPr id="19" name="">
             <a:extLst xmlns:a="http://schemas.openxmlformats.org/drawingml/2006/main">
               <a:ext uri="{FF2B5EF4-FFF2-40B4-BE49-F238E27FC236}">
-                <a16:creationId xmlns:a16="http://schemas.microsoft.com/office/drawing/2014/main" id="{D1DE0952-4912-4725-AD92-4D7EE2FDA9BD}"/>
+                <a16:creationId xmlns:a16="http://schemas.microsoft.com/office/drawing/2014/main" id="{F128FAFF-61E6-4114-9394-77597B44DEBB}"/>
               </a:ext>
             </a:extLst>
           </p:cNvPr>
@@ -18385,7 +17872,7 @@
           <p:cNvPr id="20" name="">
             <a:extLst xmlns:a="http://schemas.openxmlformats.org/drawingml/2006/main">
               <a:ext uri="{FF2B5EF4-FFF2-40B4-BE49-F238E27FC236}">
-                <a16:creationId xmlns:a16="http://schemas.microsoft.com/office/drawing/2014/main" id="{C152BAB5-B523-4666-808A-84B0C77B9D75}"/>
+                <a16:creationId xmlns:a16="http://schemas.microsoft.com/office/drawing/2014/main" id="{2EE9746D-D490-47CC-8DD4-A5C5C139AF06}"/>
               </a:ext>
             </a:extLst>
           </p:cNvPr>
@@ -18418,7 +17905,7 @@
           <p:cNvPr id="21" name="">
             <a:extLst xmlns:a="http://schemas.openxmlformats.org/drawingml/2006/main">
               <a:ext uri="{FF2B5EF4-FFF2-40B4-BE49-F238E27FC236}">
-                <a16:creationId xmlns:a16="http://schemas.microsoft.com/office/drawing/2014/main" id="{34BEB5F4-C09B-4426-BFA2-E3D20814CB67}"/>
+                <a16:creationId xmlns:a16="http://schemas.microsoft.com/office/drawing/2014/main" id="{71DFBDFB-9EA3-472C-A5DF-B92E1239EC2A}"/>
               </a:ext>
             </a:extLst>
           </p:cNvPr>
@@ -18581,7 +18068,7 @@
           <p:cNvPr id="22" name="">
             <a:extLst xmlns:a="http://schemas.openxmlformats.org/drawingml/2006/main">
               <a:ext uri="{FF2B5EF4-FFF2-40B4-BE49-F238E27FC236}">
-                <a16:creationId xmlns:a16="http://schemas.microsoft.com/office/drawing/2014/main" id="{C1C5A528-2B93-4B3A-B88F-0718D45791E1}"/>
+                <a16:creationId xmlns:a16="http://schemas.microsoft.com/office/drawing/2014/main" id="{1835A2B4-C297-4DAF-9D7B-0F4FB15FCE9A}"/>
               </a:ext>
             </a:extLst>
           </p:cNvPr>
@@ -18614,7 +18101,7 @@
           <p:cNvPr id="23" name="">
             <a:extLst xmlns:a="http://schemas.openxmlformats.org/drawingml/2006/main">
               <a:ext uri="{FF2B5EF4-FFF2-40B4-BE49-F238E27FC236}">
-                <a16:creationId xmlns:a16="http://schemas.microsoft.com/office/drawing/2014/main" id="{FE5CDE7B-3361-421C-9322-4C73767B385E}"/>
+                <a16:creationId xmlns:a16="http://schemas.microsoft.com/office/drawing/2014/main" id="{4767244D-4EC1-4D15-A1E2-D911F8F8CBCB}"/>
               </a:ext>
             </a:extLst>
           </p:cNvPr>
@@ -18777,7 +18264,7 @@
           <p:cNvPr id="24" name="">
             <a:extLst xmlns:a="http://schemas.openxmlformats.org/drawingml/2006/main">
               <a:ext uri="{FF2B5EF4-FFF2-40B4-BE49-F238E27FC236}">
-                <a16:creationId xmlns:a16="http://schemas.microsoft.com/office/drawing/2014/main" id="{68A1F89E-CC7A-4E90-8758-43BC5CD4FCEC}"/>
+                <a16:creationId xmlns:a16="http://schemas.microsoft.com/office/drawing/2014/main" id="{9DF5B178-E35E-4967-8B9D-AA5452A5670D}"/>
               </a:ext>
             </a:extLst>
           </p:cNvPr>
@@ -18810,7 +18297,7 @@
           <p:cNvPr id="25" name="">
             <a:extLst xmlns:a="http://schemas.openxmlformats.org/drawingml/2006/main">
               <a:ext uri="{FF2B5EF4-FFF2-40B4-BE49-F238E27FC236}">
-                <a16:creationId xmlns:a16="http://schemas.microsoft.com/office/drawing/2014/main" id="{91A46E30-EE7E-440C-8510-D21056826A09}"/>
+                <a16:creationId xmlns:a16="http://schemas.microsoft.com/office/drawing/2014/main" id="{A831F40F-7282-497F-B83C-D9BCE5C3442E}"/>
               </a:ext>
             </a:extLst>
           </p:cNvPr>
@@ -18973,7 +18460,7 @@
           <p:cNvPr id="26" name="">
             <a:extLst xmlns:a="http://schemas.openxmlformats.org/drawingml/2006/main">
               <a:ext uri="{FF2B5EF4-FFF2-40B4-BE49-F238E27FC236}">
-                <a16:creationId xmlns:a16="http://schemas.microsoft.com/office/drawing/2014/main" id="{C2B09889-D3E6-4F8C-AABE-76850E3CB3D6}"/>
+                <a16:creationId xmlns:a16="http://schemas.microsoft.com/office/drawing/2014/main" id="{FF13591D-85C9-48F4-8035-8F0E0525DCA0}"/>
               </a:ext>
             </a:extLst>
           </p:cNvPr>
@@ -19006,7 +18493,7 @@
           <p:cNvPr id="27" name="">
             <a:extLst xmlns:a="http://schemas.openxmlformats.org/drawingml/2006/main">
               <a:ext uri="{FF2B5EF4-FFF2-40B4-BE49-F238E27FC236}">
-                <a16:creationId xmlns:a16="http://schemas.microsoft.com/office/drawing/2014/main" id="{1EEAB9A4-3DE9-4191-8AD2-62FDE440472B}"/>
+                <a16:creationId xmlns:a16="http://schemas.microsoft.com/office/drawing/2014/main" id="{AB5C5C81-F7D6-4041-9AA1-D145FD29FC7F}"/>
               </a:ext>
             </a:extLst>
           </p:cNvPr>
@@ -19250,170 +18737,7 @@
           <p:cNvPr id="28" name="">
             <a:extLst xmlns:a="http://schemas.openxmlformats.org/drawingml/2006/main">
               <a:ext uri="{FF2B5EF4-FFF2-40B4-BE49-F238E27FC236}">
-                <a16:creationId xmlns:a16="http://schemas.microsoft.com/office/drawing/2014/main" id="{76FC8104-2033-4885-A8FD-8D672A5267CC}"/>
-              </a:ext>
-            </a:extLst>
-          </p:cNvPr>
-          <p:cNvSpPr>
-            <a:spLocks xmlns:a="http://schemas.openxmlformats.org/drawingml/2006/main" noGrp="1"/>
-          </p:cNvSpPr>
-          <p:nvPr/>
-        </p:nvSpPr>
-        <p:spPr>
-          <a:xfrm xmlns:a="http://schemas.openxmlformats.org/drawingml/2006/main">
-            <a:off x="666750" y="6419850"/>
-            <a:ext cx="4762500" cy="190500"/>
-          </a:xfrm>
-          <a:prstGeom xmlns:a="http://schemas.openxmlformats.org/drawingml/2006/main" prst="rect">
-            <a:avLst/>
-          </a:prstGeom>
-          <a:noFill xmlns:a="http://schemas.openxmlformats.org/drawingml/2006/main"/>
-          <a:ln xmlns:a="http://schemas.openxmlformats.org/drawingml/2006/main" w="0">
-            <a:noFill/>
-            <a:prstDash val="solid"/>
-          </a:ln>
-        </p:spPr>
-        <p:txBody>
-          <a:bodyPr xmlns:a="http://schemas.openxmlformats.org/drawingml/2006/main" wrap="square" lIns="0" tIns="0" rIns="0" bIns="0" anchor="t">
-            <a:normAutofit fontScale="100000"/>
-          </a:bodyPr>
-          <a:lstStyle xmlns:a="http://schemas.openxmlformats.org/drawingml/2006/main">
-            <a:defPPr algn="l">
-              <a:defRPr sz="975" b="0">
-                <a:solidFill>
-                  <a:srgbClr val="6B7280"/>
-                </a:solidFill>
-                <a:latin typeface="Arial"/>
-                <a:ea typeface="Arial"/>
-                <a:cs typeface="Arial"/>
-              </a:defRPr>
-            </a:defPPr>
-            <a:lvl1pPr algn="l">
-              <a:defRPr sz="975" b="0">
-                <a:solidFill>
-                  <a:srgbClr val="6B7280"/>
-                </a:solidFill>
-                <a:latin typeface="Arial"/>
-                <a:ea typeface="Arial"/>
-                <a:cs typeface="Arial"/>
-              </a:defRPr>
-            </a:lvl1pPr>
-            <a:lvl2pPr algn="l">
-              <a:defRPr sz="975" b="0">
-                <a:solidFill>
-                  <a:srgbClr val="6B7280"/>
-                </a:solidFill>
-                <a:latin typeface="Arial"/>
-                <a:ea typeface="Arial"/>
-                <a:cs typeface="Arial"/>
-              </a:defRPr>
-            </a:lvl2pPr>
-            <a:lvl3pPr algn="l">
-              <a:defRPr sz="975" b="0">
-                <a:solidFill>
-                  <a:srgbClr val="6B7280"/>
-                </a:solidFill>
-                <a:latin typeface="Arial"/>
-                <a:ea typeface="Arial"/>
-                <a:cs typeface="Arial"/>
-              </a:defRPr>
-            </a:lvl3pPr>
-            <a:lvl4pPr algn="l">
-              <a:defRPr sz="975" b="0">
-                <a:solidFill>
-                  <a:srgbClr val="6B7280"/>
-                </a:solidFill>
-                <a:latin typeface="Arial"/>
-                <a:ea typeface="Arial"/>
-                <a:cs typeface="Arial"/>
-              </a:defRPr>
-            </a:lvl4pPr>
-            <a:lvl5pPr algn="l">
-              <a:defRPr sz="975" b="0">
-                <a:solidFill>
-                  <a:srgbClr val="6B7280"/>
-                </a:solidFill>
-                <a:latin typeface="Arial"/>
-                <a:ea typeface="Arial"/>
-                <a:cs typeface="Arial"/>
-              </a:defRPr>
-            </a:lvl5pPr>
-            <a:lvl6pPr algn="l">
-              <a:defRPr sz="975" b="0">
-                <a:solidFill>
-                  <a:srgbClr val="6B7280"/>
-                </a:solidFill>
-                <a:latin typeface="Arial"/>
-                <a:ea typeface="Arial"/>
-                <a:cs typeface="Arial"/>
-              </a:defRPr>
-            </a:lvl6pPr>
-            <a:lvl7pPr algn="l">
-              <a:defRPr sz="975" b="0">
-                <a:solidFill>
-                  <a:srgbClr val="6B7280"/>
-                </a:solidFill>
-                <a:latin typeface="Arial"/>
-                <a:ea typeface="Arial"/>
-                <a:cs typeface="Arial"/>
-              </a:defRPr>
-            </a:lvl7pPr>
-            <a:lvl8pPr algn="l">
-              <a:defRPr sz="975" b="0">
-                <a:solidFill>
-                  <a:srgbClr val="6B7280"/>
-                </a:solidFill>
-                <a:latin typeface="Arial"/>
-                <a:ea typeface="Arial"/>
-                <a:cs typeface="Arial"/>
-              </a:defRPr>
-            </a:lvl8pPr>
-            <a:lvl9pPr algn="l">
-              <a:defRPr sz="975" b="0">
-                <a:solidFill>
-                  <a:srgbClr val="6B7280"/>
-                </a:solidFill>
-                <a:latin typeface="Arial"/>
-                <a:ea typeface="Arial"/>
-                <a:cs typeface="Arial"/>
-              </a:defRPr>
-            </a:lvl9pPr>
-          </a:lstStyle>
-          <a:p xmlns:a="http://schemas.openxmlformats.org/drawingml/2006/main">
-            <a:pPr algn="l">
-              <a:lnSpc>
-                <a:spcPct val="105000"/>
-              </a:lnSpc>
-              <a:buNone/>
-              <a:defRPr sz="975" b="0">
-                <a:solidFill>
-                  <a:srgbClr val="6B7280"/>
-                </a:solidFill>
-                <a:latin typeface="Arial"/>
-                <a:ea typeface="Arial"/>
-                <a:cs typeface="Arial"/>
-              </a:defRPr>
-            </a:pPr>
-            <a:r>
-              <a:rPr sz="975" b="0">
-                <a:solidFill>
-                  <a:srgbClr val="6B7280"/>
-                </a:solidFill>
-                <a:latin typeface="Arial"/>
-                <a:ea typeface="Arial"/>
-                <a:cs typeface="Arial"/>
-              </a:rPr>
-              <a:t>Спикер · Александра</a:t>
-            </a:r>
-          </a:p>
-        </p:txBody>
-      </p:sp>
-      <p:sp>
-        <p:nvSpPr>
-          <p:cNvPr id="29" name="">
-            <a:extLst xmlns:a="http://schemas.openxmlformats.org/drawingml/2006/main">
-              <a:ext uri="{FF2B5EF4-FFF2-40B4-BE49-F238E27FC236}">
-                <a16:creationId xmlns:a16="http://schemas.microsoft.com/office/drawing/2014/main" id="{7B958802-5C77-4DFC-BE1E-F46DA7C2CC48}"/>
+                <a16:creationId xmlns:a16="http://schemas.microsoft.com/office/drawing/2014/main" id="{8B801E20-FEB9-436B-BF78-5FE74F52896F}"/>
               </a:ext>
             </a:extLst>
           </p:cNvPr>
@@ -19574,7 +18898,7 @@
     </p:spTree>
     <p:extLst>
       <p:ext uri="{BB962C8B-B14F-4D97-AF65-F5344CB8AC3E}">
-        <p14:creationId xmlns:p14="http://schemas.microsoft.com/office/powerpoint/2010/main" val="445541404"/>
+        <p14:creationId xmlns:p14="http://schemas.microsoft.com/office/powerpoint/2010/main" val="182477256"/>
       </p:ext>
     </p:extLst>
   </p:cSld>
@@ -19605,7 +18929,7 @@
           <p:cNvPr id="27" name="">
             <a:extLst xmlns:a="http://schemas.openxmlformats.org/drawingml/2006/main">
               <a:ext uri="{FF2B5EF4-FFF2-40B4-BE49-F238E27FC236}">
-                <a16:creationId xmlns:a16="http://schemas.microsoft.com/office/drawing/2014/main" id="{52C708E4-F01F-4BCE-92B8-E26175E9FE3C}"/>
+                <a16:creationId xmlns:a16="http://schemas.microsoft.com/office/drawing/2014/main" id="{C7901942-AED2-4A06-BBD1-8D8BBEB74CEC}"/>
               </a:ext>
             </a:extLst>
           </p:cNvPr>
@@ -19640,7 +18964,7 @@
           <p:cNvPr id="26" name="">
             <a:extLst xmlns:a="http://schemas.openxmlformats.org/drawingml/2006/main">
               <a:ext uri="{FF2B5EF4-FFF2-40B4-BE49-F238E27FC236}">
-                <a16:creationId xmlns:a16="http://schemas.microsoft.com/office/drawing/2014/main" id="{1ABC1C91-26B6-4759-9C1D-CF0C1AC692E6}"/>
+                <a16:creationId xmlns:a16="http://schemas.microsoft.com/office/drawing/2014/main" id="{27932DE7-AFA7-4B19-A843-DFB13284D58D}"/>
               </a:ext>
             </a:extLst>
           </p:cNvPr>
@@ -19675,7 +18999,7 @@
           <p:cNvPr id="25" name="">
             <a:extLst xmlns:a="http://schemas.openxmlformats.org/drawingml/2006/main">
               <a:ext uri="{FF2B5EF4-FFF2-40B4-BE49-F238E27FC236}">
-                <a16:creationId xmlns:a16="http://schemas.microsoft.com/office/drawing/2014/main" id="{6F8D4A19-CA44-4A7F-8043-0809FC00075F}"/>
+                <a16:creationId xmlns:a16="http://schemas.microsoft.com/office/drawing/2014/main" id="{709B87A5-424C-4216-9BE9-C47D0396E303}"/>
               </a:ext>
             </a:extLst>
           </p:cNvPr>
@@ -19707,7 +19031,7 @@
           <p:cNvPr id="24" name="">
             <a:extLst xmlns:a="http://schemas.openxmlformats.org/drawingml/2006/main">
               <a:ext uri="{FF2B5EF4-FFF2-40B4-BE49-F238E27FC236}">
-                <a16:creationId xmlns:a16="http://schemas.microsoft.com/office/drawing/2014/main" id="{E20875C5-8F2A-46E0-A485-48120BA90DD6}"/>
+                <a16:creationId xmlns:a16="http://schemas.microsoft.com/office/drawing/2014/main" id="{DB8D5E4E-1335-42FE-B222-3EDEDCE1082A}"/>
               </a:ext>
             </a:extLst>
           </p:cNvPr>
@@ -19739,7 +19063,7 @@
           <p:cNvPr id="23" name="">
             <a:extLst xmlns:a="http://schemas.openxmlformats.org/drawingml/2006/main">
               <a:ext uri="{FF2B5EF4-FFF2-40B4-BE49-F238E27FC236}">
-                <a16:creationId xmlns:a16="http://schemas.microsoft.com/office/drawing/2014/main" id="{9934B723-7BD5-4BC0-8833-3D3D3502D4E0}"/>
+                <a16:creationId xmlns:a16="http://schemas.microsoft.com/office/drawing/2014/main" id="{28A25A88-6A2A-467E-9A2B-FF0143E707FA}"/>
               </a:ext>
             </a:extLst>
           </p:cNvPr>
@@ -19771,7 +19095,7 @@
           <p:cNvPr id="22" name="">
             <a:extLst xmlns:a="http://schemas.openxmlformats.org/drawingml/2006/main">
               <a:ext uri="{FF2B5EF4-FFF2-40B4-BE49-F238E27FC236}">
-                <a16:creationId xmlns:a16="http://schemas.microsoft.com/office/drawing/2014/main" id="{13F7EAAF-BAB8-4ECB-BA3A-C4967CCD3388}"/>
+                <a16:creationId xmlns:a16="http://schemas.microsoft.com/office/drawing/2014/main" id="{EC8C7E07-2351-4C4B-8755-9300DA8FFDE4}"/>
               </a:ext>
             </a:extLst>
           </p:cNvPr>
@@ -19800,10 +19124,10 @@
       </p:cxnSp>
       <p:sp>
         <p:nvSpPr>
-          <p:cNvPr id="36" name="">
+          <p:cNvPr id="35" name="">
             <a:extLst xmlns:a="http://schemas.openxmlformats.org/drawingml/2006/main">
               <a:ext uri="{FF2B5EF4-FFF2-40B4-BE49-F238E27FC236}">
-                <a16:creationId xmlns:a16="http://schemas.microsoft.com/office/drawing/2014/main" id="{B6CC149A-3B00-44AD-848E-68D8267545C8}"/>
+                <a16:creationId xmlns:a16="http://schemas.microsoft.com/office/drawing/2014/main" id="{552E7304-8B70-466B-AB77-5690AC24A72A}"/>
               </a:ext>
             </a:extLst>
           </p:cNvPr>
@@ -19956,7 +19280,7 @@
                 <a:ea typeface="Arial"/>
                 <a:cs typeface="Arial"/>
               </a:rPr>
-              <a:t>5 · АРХИТЕКТУРА</a:t>
+              <a:t>5 · АРХИТЕКТУРА И ИНСТРУМЕНТЫ</a:t>
             </a:r>
           </a:p>
         </p:txBody>
@@ -19966,7 +19290,7 @@
           <p:cNvPr id="2" name="">
             <a:extLst xmlns:a="http://schemas.openxmlformats.org/drawingml/2006/main">
               <a:ext uri="{FF2B5EF4-FFF2-40B4-BE49-F238E27FC236}">
-                <a16:creationId xmlns:a16="http://schemas.microsoft.com/office/drawing/2014/main" id="{32D45AC0-DC88-43E4-954A-BD69A72FD1FA}"/>
+                <a16:creationId xmlns:a16="http://schemas.microsoft.com/office/drawing/2014/main" id="{31770D09-86FD-4DAA-977A-0F1A7F62829E}"/>
               </a:ext>
             </a:extLst>
           </p:cNvPr>
@@ -20119,7 +19443,7 @@
                 <a:ea typeface="Arial"/>
                 <a:cs typeface="Arial"/>
               </a:rPr>
-              <a:t>Короткий управляемый цикл</a:t>
+              <a:t>Короткий цикл с одной повторной попыткой</a:t>
             </a:r>
           </a:p>
         </p:txBody>
@@ -20129,7 +19453,7 @@
           <p:cNvPr id="3" name="">
             <a:extLst xmlns:a="http://schemas.openxmlformats.org/drawingml/2006/main">
               <a:ext uri="{FF2B5EF4-FFF2-40B4-BE49-F238E27FC236}">
-                <a16:creationId xmlns:a16="http://schemas.microsoft.com/office/drawing/2014/main" id="{5E9E963A-B2C2-47EE-8EC3-8B782AFF3C37}"/>
+                <a16:creationId xmlns:a16="http://schemas.microsoft.com/office/drawing/2014/main" id="{232EFCC7-F670-447F-860A-A9CCCFB63D3C}"/>
               </a:ext>
             </a:extLst>
           </p:cNvPr>
@@ -20282,7 +19606,7 @@
                 <a:ea typeface="Arial"/>
                 <a:cs typeface="Arial"/>
               </a:rPr>
-              <a:t>Две роли Gemini, один детерминированный контроль и максимум две попытки.</a:t>
+              <a:t>Gemini планирует и советует, Python проверяет результат.</a:t>
             </a:r>
           </a:p>
         </p:txBody>
@@ -20292,7 +19616,7 @@
           <p:cNvPr id="4" name="">
             <a:extLst xmlns:a="http://schemas.openxmlformats.org/drawingml/2006/main">
               <a:ext uri="{FF2B5EF4-FFF2-40B4-BE49-F238E27FC236}">
-                <a16:creationId xmlns:a16="http://schemas.microsoft.com/office/drawing/2014/main" id="{C99A34F8-4750-4F30-8024-3ACC0169C890}"/>
+                <a16:creationId xmlns:a16="http://schemas.microsoft.com/office/drawing/2014/main" id="{AA420125-F9B9-4F46-9375-B27221E996C2}"/>
               </a:ext>
             </a:extLst>
           </p:cNvPr>
@@ -20327,7 +19651,7 @@
           <p:cNvPr id="5" name="">
             <a:extLst xmlns:a="http://schemas.openxmlformats.org/drawingml/2006/main">
               <a:ext uri="{FF2B5EF4-FFF2-40B4-BE49-F238E27FC236}">
-                <a16:creationId xmlns:a16="http://schemas.microsoft.com/office/drawing/2014/main" id="{8273628F-A56D-45BA-A9D6-3083E638F286}"/>
+                <a16:creationId xmlns:a16="http://schemas.microsoft.com/office/drawing/2014/main" id="{0DE08AF3-34FC-49B5-95A0-FE3C59E24945}"/>
               </a:ext>
             </a:extLst>
           </p:cNvPr>
@@ -20490,7 +19814,7 @@
           <p:cNvPr id="6" name="">
             <a:extLst xmlns:a="http://schemas.openxmlformats.org/drawingml/2006/main">
               <a:ext uri="{FF2B5EF4-FFF2-40B4-BE49-F238E27FC236}">
-                <a16:creationId xmlns:a16="http://schemas.microsoft.com/office/drawing/2014/main" id="{16C7C4C3-81B5-4751-9BD7-AC91030A731B}"/>
+                <a16:creationId xmlns:a16="http://schemas.microsoft.com/office/drawing/2014/main" id="{98C26927-821F-4F37-AAC2-CD55C17F2DC3}"/>
               </a:ext>
             </a:extLst>
           </p:cNvPr>
@@ -20653,7 +19977,7 @@
           <p:cNvPr id="7" name="">
             <a:extLst xmlns:a="http://schemas.openxmlformats.org/drawingml/2006/main">
               <a:ext uri="{FF2B5EF4-FFF2-40B4-BE49-F238E27FC236}">
-                <a16:creationId xmlns:a16="http://schemas.microsoft.com/office/drawing/2014/main" id="{939DF0E4-7A00-4659-8F80-4ECBF88BC66E}"/>
+                <a16:creationId xmlns:a16="http://schemas.microsoft.com/office/drawing/2014/main" id="{39FDBF62-6CE7-4F3E-AB9D-F7D7BF09BD0E}"/>
               </a:ext>
             </a:extLst>
           </p:cNvPr>
@@ -20688,7 +20012,7 @@
           <p:cNvPr id="8" name="">
             <a:extLst xmlns:a="http://schemas.openxmlformats.org/drawingml/2006/main">
               <a:ext uri="{FF2B5EF4-FFF2-40B4-BE49-F238E27FC236}">
-                <a16:creationId xmlns:a16="http://schemas.microsoft.com/office/drawing/2014/main" id="{ED1B62B4-2D02-4ECF-9187-13BAEAEBDFA1}"/>
+                <a16:creationId xmlns:a16="http://schemas.microsoft.com/office/drawing/2014/main" id="{DB9B069C-6B96-49D3-8843-7C2D6CC627FB}"/>
               </a:ext>
             </a:extLst>
           </p:cNvPr>
@@ -20851,7 +20175,7 @@
           <p:cNvPr id="9" name="">
             <a:extLst xmlns:a="http://schemas.openxmlformats.org/drawingml/2006/main">
               <a:ext uri="{FF2B5EF4-FFF2-40B4-BE49-F238E27FC236}">
-                <a16:creationId xmlns:a16="http://schemas.microsoft.com/office/drawing/2014/main" id="{7ED2CAF9-6418-4059-B9CF-3FF9871FE705}"/>
+                <a16:creationId xmlns:a16="http://schemas.microsoft.com/office/drawing/2014/main" id="{54C207BE-FE6B-4FA2-8389-0E693923D866}"/>
               </a:ext>
             </a:extLst>
           </p:cNvPr>
@@ -21014,7 +20338,7 @@
           <p:cNvPr id="10" name="">
             <a:extLst xmlns:a="http://schemas.openxmlformats.org/drawingml/2006/main">
               <a:ext uri="{FF2B5EF4-FFF2-40B4-BE49-F238E27FC236}">
-                <a16:creationId xmlns:a16="http://schemas.microsoft.com/office/drawing/2014/main" id="{FE86C041-5489-4041-BE59-050638CF33EC}"/>
+                <a16:creationId xmlns:a16="http://schemas.microsoft.com/office/drawing/2014/main" id="{C5A8EAD0-9BEF-4DF1-A6DD-E0DA9516D9B9}"/>
               </a:ext>
             </a:extLst>
           </p:cNvPr>
@@ -21049,7 +20373,7 @@
           <p:cNvPr id="11" name="">
             <a:extLst xmlns:a="http://schemas.openxmlformats.org/drawingml/2006/main">
               <a:ext uri="{FF2B5EF4-FFF2-40B4-BE49-F238E27FC236}">
-                <a16:creationId xmlns:a16="http://schemas.microsoft.com/office/drawing/2014/main" id="{D488EA42-2B03-44D0-A508-86CE385E354D}"/>
+                <a16:creationId xmlns:a16="http://schemas.microsoft.com/office/drawing/2014/main" id="{16E683AA-063E-4239-A055-FB7282309247}"/>
               </a:ext>
             </a:extLst>
           </p:cNvPr>
@@ -21212,7 +20536,7 @@
           <p:cNvPr id="12" name="">
             <a:extLst xmlns:a="http://schemas.openxmlformats.org/drawingml/2006/main">
               <a:ext uri="{FF2B5EF4-FFF2-40B4-BE49-F238E27FC236}">
-                <a16:creationId xmlns:a16="http://schemas.microsoft.com/office/drawing/2014/main" id="{FE36D44F-A6CF-48CC-BF61-46FE4DDB8D80}"/>
+                <a16:creationId xmlns:a16="http://schemas.microsoft.com/office/drawing/2014/main" id="{1BB3E6B9-60E3-45A8-9021-AE38D09C0576}"/>
               </a:ext>
             </a:extLst>
           </p:cNvPr>
@@ -21375,7 +20699,7 @@
           <p:cNvPr id="13" name="">
             <a:extLst xmlns:a="http://schemas.openxmlformats.org/drawingml/2006/main">
               <a:ext uri="{FF2B5EF4-FFF2-40B4-BE49-F238E27FC236}">
-                <a16:creationId xmlns:a16="http://schemas.microsoft.com/office/drawing/2014/main" id="{26AB2E9D-DB21-4493-BCA3-987F8D8E0E34}"/>
+                <a16:creationId xmlns:a16="http://schemas.microsoft.com/office/drawing/2014/main" id="{5D5784E6-FF04-4707-BF1F-0CA4452370A0}"/>
               </a:ext>
             </a:extLst>
           </p:cNvPr>
@@ -21410,7 +20734,7 @@
           <p:cNvPr id="14" name="">
             <a:extLst xmlns:a="http://schemas.openxmlformats.org/drawingml/2006/main">
               <a:ext uri="{FF2B5EF4-FFF2-40B4-BE49-F238E27FC236}">
-                <a16:creationId xmlns:a16="http://schemas.microsoft.com/office/drawing/2014/main" id="{DB0DE6FA-DB16-4D90-B456-7C3BE3419AAE}"/>
+                <a16:creationId xmlns:a16="http://schemas.microsoft.com/office/drawing/2014/main" id="{20156FDE-E119-4042-828B-C0DD44378B90}"/>
               </a:ext>
             </a:extLst>
           </p:cNvPr>
@@ -21573,7 +20897,7 @@
           <p:cNvPr id="15" name="">
             <a:extLst xmlns:a="http://schemas.openxmlformats.org/drawingml/2006/main">
               <a:ext uri="{FF2B5EF4-FFF2-40B4-BE49-F238E27FC236}">
-                <a16:creationId xmlns:a16="http://schemas.microsoft.com/office/drawing/2014/main" id="{22EB7106-3A6F-4FE9-81EA-A9D15016F5F0}"/>
+                <a16:creationId xmlns:a16="http://schemas.microsoft.com/office/drawing/2014/main" id="{73659C55-AC8E-44D9-8618-02C833F386B9}"/>
               </a:ext>
             </a:extLst>
           </p:cNvPr>
@@ -21736,7 +21060,7 @@
           <p:cNvPr id="16" name="">
             <a:extLst xmlns:a="http://schemas.openxmlformats.org/drawingml/2006/main">
               <a:ext uri="{FF2B5EF4-FFF2-40B4-BE49-F238E27FC236}">
-                <a16:creationId xmlns:a16="http://schemas.microsoft.com/office/drawing/2014/main" id="{6DE11E5F-2E92-4778-A3CB-CE25BF2C7707}"/>
+                <a16:creationId xmlns:a16="http://schemas.microsoft.com/office/drawing/2014/main" id="{93A55757-3937-4D4C-A6D8-4ABE28615603}"/>
               </a:ext>
             </a:extLst>
           </p:cNvPr>
@@ -21771,7 +21095,7 @@
           <p:cNvPr id="17" name="">
             <a:extLst xmlns:a="http://schemas.openxmlformats.org/drawingml/2006/main">
               <a:ext uri="{FF2B5EF4-FFF2-40B4-BE49-F238E27FC236}">
-                <a16:creationId xmlns:a16="http://schemas.microsoft.com/office/drawing/2014/main" id="{708157BC-E489-469D-A1BC-25C5ED40ADB7}"/>
+                <a16:creationId xmlns:a16="http://schemas.microsoft.com/office/drawing/2014/main" id="{4A282575-081B-459C-A548-F91AF13EEF07}"/>
               </a:ext>
             </a:extLst>
           </p:cNvPr>
@@ -21934,7 +21258,7 @@
           <p:cNvPr id="18" name="">
             <a:extLst xmlns:a="http://schemas.openxmlformats.org/drawingml/2006/main">
               <a:ext uri="{FF2B5EF4-FFF2-40B4-BE49-F238E27FC236}">
-                <a16:creationId xmlns:a16="http://schemas.microsoft.com/office/drawing/2014/main" id="{CBBF207B-E611-415B-8CFC-36F7EF8A993A}"/>
+                <a16:creationId xmlns:a16="http://schemas.microsoft.com/office/drawing/2014/main" id="{06F97D07-50AD-4852-BD51-ECE4D85EA537}"/>
               </a:ext>
             </a:extLst>
           </p:cNvPr>
@@ -22097,7 +21421,7 @@
           <p:cNvPr id="19" name="">
             <a:extLst xmlns:a="http://schemas.openxmlformats.org/drawingml/2006/main">
               <a:ext uri="{FF2B5EF4-FFF2-40B4-BE49-F238E27FC236}">
-                <a16:creationId xmlns:a16="http://schemas.microsoft.com/office/drawing/2014/main" id="{8BBEC0AA-EB08-470F-936B-6DC85B2C86C6}"/>
+                <a16:creationId xmlns:a16="http://schemas.microsoft.com/office/drawing/2014/main" id="{EAFF2471-2294-47CE-80F5-A4957983C918}"/>
               </a:ext>
             </a:extLst>
           </p:cNvPr>
@@ -22132,7 +21456,7 @@
           <p:cNvPr id="20" name="">
             <a:extLst xmlns:a="http://schemas.openxmlformats.org/drawingml/2006/main">
               <a:ext uri="{FF2B5EF4-FFF2-40B4-BE49-F238E27FC236}">
-                <a16:creationId xmlns:a16="http://schemas.microsoft.com/office/drawing/2014/main" id="{F3BDAD7F-4CFC-4DE7-BEA5-800804AE95A1}"/>
+                <a16:creationId xmlns:a16="http://schemas.microsoft.com/office/drawing/2014/main" id="{86E4A93D-B36B-4D1E-A0D9-83AC3B58C853}"/>
               </a:ext>
             </a:extLst>
           </p:cNvPr>
@@ -22295,7 +21619,7 @@
           <p:cNvPr id="21" name="">
             <a:extLst xmlns:a="http://schemas.openxmlformats.org/drawingml/2006/main">
               <a:ext uri="{FF2B5EF4-FFF2-40B4-BE49-F238E27FC236}">
-                <a16:creationId xmlns:a16="http://schemas.microsoft.com/office/drawing/2014/main" id="{8748F709-F338-4771-9DB3-CEF85292DDF2}"/>
+                <a16:creationId xmlns:a16="http://schemas.microsoft.com/office/drawing/2014/main" id="{740D2B2E-4F4C-4313-B316-6BCF494CE128}"/>
               </a:ext>
             </a:extLst>
           </p:cNvPr>
@@ -22458,7 +21782,7 @@
           <p:cNvPr id="28" name="">
             <a:extLst xmlns:a="http://schemas.openxmlformats.org/drawingml/2006/main">
               <a:ext uri="{FF2B5EF4-FFF2-40B4-BE49-F238E27FC236}">
-                <a16:creationId xmlns:a16="http://schemas.microsoft.com/office/drawing/2014/main" id="{3AB75B92-8403-4945-A790-F859BFCC7962}"/>
+                <a16:creationId xmlns:a16="http://schemas.microsoft.com/office/drawing/2014/main" id="{1A62CE0F-6767-4ED0-89CF-9CDB5D6B0ECA}"/>
               </a:ext>
             </a:extLst>
           </p:cNvPr>
@@ -22491,7 +21815,7 @@
           <p:cNvPr id="29" name="">
             <a:extLst xmlns:a="http://schemas.openxmlformats.org/drawingml/2006/main">
               <a:ext uri="{FF2B5EF4-FFF2-40B4-BE49-F238E27FC236}">
-                <a16:creationId xmlns:a16="http://schemas.microsoft.com/office/drawing/2014/main" id="{80D53784-FE2B-4BF3-9BF8-533A9E346C4C}"/>
+                <a16:creationId xmlns:a16="http://schemas.microsoft.com/office/drawing/2014/main" id="{8284E3A7-5C3B-4706-8E91-F7D5F968A107}"/>
               </a:ext>
             </a:extLst>
           </p:cNvPr>
@@ -22654,7 +21978,7 @@
           <p:cNvPr id="30" name="">
             <a:extLst xmlns:a="http://schemas.openxmlformats.org/drawingml/2006/main">
               <a:ext uri="{FF2B5EF4-FFF2-40B4-BE49-F238E27FC236}">
-                <a16:creationId xmlns:a16="http://schemas.microsoft.com/office/drawing/2014/main" id="{A68650CC-438E-424C-BECA-E7C5855AAD2B}"/>
+                <a16:creationId xmlns:a16="http://schemas.microsoft.com/office/drawing/2014/main" id="{BF6998A7-4AEC-4CE5-A6B7-873755E4F208}"/>
               </a:ext>
             </a:extLst>
           </p:cNvPr>
@@ -22687,7 +22011,7 @@
           <p:cNvPr id="31" name="">
             <a:extLst xmlns:a="http://schemas.openxmlformats.org/drawingml/2006/main">
               <a:ext uri="{FF2B5EF4-FFF2-40B4-BE49-F238E27FC236}">
-                <a16:creationId xmlns:a16="http://schemas.microsoft.com/office/drawing/2014/main" id="{50DCDA14-BEA5-415B-BFB5-029F3BEA2A0A}"/>
+                <a16:creationId xmlns:a16="http://schemas.microsoft.com/office/drawing/2014/main" id="{12CEED7F-EC4E-495C-81A9-D8C1447CC4A4}"/>
               </a:ext>
             </a:extLst>
           </p:cNvPr>
@@ -22850,7 +22174,7 @@
           <p:cNvPr id="32" name="">
             <a:extLst xmlns:a="http://schemas.openxmlformats.org/drawingml/2006/main">
               <a:ext uri="{FF2B5EF4-FFF2-40B4-BE49-F238E27FC236}">
-                <a16:creationId xmlns:a16="http://schemas.microsoft.com/office/drawing/2014/main" id="{D87AFCB9-DE9E-4CA9-9C0E-6D688D2C7133}"/>
+                <a16:creationId xmlns:a16="http://schemas.microsoft.com/office/drawing/2014/main" id="{CD8AE873-A346-478B-BF92-5B83AC23C819}"/>
               </a:ext>
             </a:extLst>
           </p:cNvPr>
@@ -23003,7 +22327,7 @@
                 <a:ea typeface="Arial"/>
                 <a:cs typeface="Arial"/>
               </a:rPr>
-              <a:t>Почему без LangGraph</a:t>
+              <a:t>Почему обычный Python</a:t>
             </a:r>
           </a:p>
         </p:txBody>
@@ -23013,7 +22337,7 @@
           <p:cNvPr id="33" name="">
             <a:extLst xmlns:a="http://schemas.openxmlformats.org/drawingml/2006/main">
               <a:ext uri="{FF2B5EF4-FFF2-40B4-BE49-F238E27FC236}">
-                <a16:creationId xmlns:a16="http://schemas.microsoft.com/office/drawing/2014/main" id="{8869B955-B250-4AC0-9EC8-50D6A2E94C6E}"/>
+                <a16:creationId xmlns:a16="http://schemas.microsoft.com/office/drawing/2014/main" id="{0D8B9000-4115-4247-8B81-D46BA2B42F00}"/>
               </a:ext>
             </a:extLst>
           </p:cNvPr>
@@ -23166,7 +22490,7 @@
                 <a:ea typeface="Arial"/>
                 <a:cs typeface="Arial"/>
               </a:rPr>
-              <a:t>Один условный переход, две попытки, состояние живёт внутри одного запроса. Обычный Python-код короче и легче тестируется.</a:t>
+              <a:t>В цикле один переход и максимум две попытки. Отдельный граф усложнил бы код без пользы для MVP.</a:t>
             </a:r>
           </a:p>
         </p:txBody>
@@ -23176,170 +22500,7 @@
           <p:cNvPr id="34" name="">
             <a:extLst xmlns:a="http://schemas.openxmlformats.org/drawingml/2006/main">
               <a:ext uri="{FF2B5EF4-FFF2-40B4-BE49-F238E27FC236}">
-                <a16:creationId xmlns:a16="http://schemas.microsoft.com/office/drawing/2014/main" id="{37869D86-EE01-4CB3-857B-8F2F385DA9ED}"/>
-              </a:ext>
-            </a:extLst>
-          </p:cNvPr>
-          <p:cNvSpPr>
-            <a:spLocks xmlns:a="http://schemas.openxmlformats.org/drawingml/2006/main" noGrp="1"/>
-          </p:cNvSpPr>
-          <p:nvPr/>
-        </p:nvSpPr>
-        <p:spPr>
-          <a:xfrm xmlns:a="http://schemas.openxmlformats.org/drawingml/2006/main">
-            <a:off x="666750" y="6419850"/>
-            <a:ext cx="4762500" cy="190500"/>
-          </a:xfrm>
-          <a:prstGeom xmlns:a="http://schemas.openxmlformats.org/drawingml/2006/main" prst="rect">
-            <a:avLst/>
-          </a:prstGeom>
-          <a:noFill xmlns:a="http://schemas.openxmlformats.org/drawingml/2006/main"/>
-          <a:ln xmlns:a="http://schemas.openxmlformats.org/drawingml/2006/main" w="0">
-            <a:noFill/>
-            <a:prstDash val="solid"/>
-          </a:ln>
-        </p:spPr>
-        <p:txBody>
-          <a:bodyPr xmlns:a="http://schemas.openxmlformats.org/drawingml/2006/main" wrap="square" lIns="0" tIns="0" rIns="0" bIns="0" anchor="t">
-            <a:normAutofit fontScale="100000"/>
-          </a:bodyPr>
-          <a:lstStyle xmlns:a="http://schemas.openxmlformats.org/drawingml/2006/main">
-            <a:defPPr algn="l">
-              <a:defRPr sz="975" b="0">
-                <a:solidFill>
-                  <a:srgbClr val="6B7280"/>
-                </a:solidFill>
-                <a:latin typeface="Arial"/>
-                <a:ea typeface="Arial"/>
-                <a:cs typeface="Arial"/>
-              </a:defRPr>
-            </a:defPPr>
-            <a:lvl1pPr algn="l">
-              <a:defRPr sz="975" b="0">
-                <a:solidFill>
-                  <a:srgbClr val="6B7280"/>
-                </a:solidFill>
-                <a:latin typeface="Arial"/>
-                <a:ea typeface="Arial"/>
-                <a:cs typeface="Arial"/>
-              </a:defRPr>
-            </a:lvl1pPr>
-            <a:lvl2pPr algn="l">
-              <a:defRPr sz="975" b="0">
-                <a:solidFill>
-                  <a:srgbClr val="6B7280"/>
-                </a:solidFill>
-                <a:latin typeface="Arial"/>
-                <a:ea typeface="Arial"/>
-                <a:cs typeface="Arial"/>
-              </a:defRPr>
-            </a:lvl2pPr>
-            <a:lvl3pPr algn="l">
-              <a:defRPr sz="975" b="0">
-                <a:solidFill>
-                  <a:srgbClr val="6B7280"/>
-                </a:solidFill>
-                <a:latin typeface="Arial"/>
-                <a:ea typeface="Arial"/>
-                <a:cs typeface="Arial"/>
-              </a:defRPr>
-            </a:lvl3pPr>
-            <a:lvl4pPr algn="l">
-              <a:defRPr sz="975" b="0">
-                <a:solidFill>
-                  <a:srgbClr val="6B7280"/>
-                </a:solidFill>
-                <a:latin typeface="Arial"/>
-                <a:ea typeface="Arial"/>
-                <a:cs typeface="Arial"/>
-              </a:defRPr>
-            </a:lvl4pPr>
-            <a:lvl5pPr algn="l">
-              <a:defRPr sz="975" b="0">
-                <a:solidFill>
-                  <a:srgbClr val="6B7280"/>
-                </a:solidFill>
-                <a:latin typeface="Arial"/>
-                <a:ea typeface="Arial"/>
-                <a:cs typeface="Arial"/>
-              </a:defRPr>
-            </a:lvl5pPr>
-            <a:lvl6pPr algn="l">
-              <a:defRPr sz="975" b="0">
-                <a:solidFill>
-                  <a:srgbClr val="6B7280"/>
-                </a:solidFill>
-                <a:latin typeface="Arial"/>
-                <a:ea typeface="Arial"/>
-                <a:cs typeface="Arial"/>
-              </a:defRPr>
-            </a:lvl6pPr>
-            <a:lvl7pPr algn="l">
-              <a:defRPr sz="975" b="0">
-                <a:solidFill>
-                  <a:srgbClr val="6B7280"/>
-                </a:solidFill>
-                <a:latin typeface="Arial"/>
-                <a:ea typeface="Arial"/>
-                <a:cs typeface="Arial"/>
-              </a:defRPr>
-            </a:lvl7pPr>
-            <a:lvl8pPr algn="l">
-              <a:defRPr sz="975" b="0">
-                <a:solidFill>
-                  <a:srgbClr val="6B7280"/>
-                </a:solidFill>
-                <a:latin typeface="Arial"/>
-                <a:ea typeface="Arial"/>
-                <a:cs typeface="Arial"/>
-              </a:defRPr>
-            </a:lvl8pPr>
-            <a:lvl9pPr algn="l">
-              <a:defRPr sz="975" b="0">
-                <a:solidFill>
-                  <a:srgbClr val="6B7280"/>
-                </a:solidFill>
-                <a:latin typeface="Arial"/>
-                <a:ea typeface="Arial"/>
-                <a:cs typeface="Arial"/>
-              </a:defRPr>
-            </a:lvl9pPr>
-          </a:lstStyle>
-          <a:p xmlns:a="http://schemas.openxmlformats.org/drawingml/2006/main">
-            <a:pPr algn="l">
-              <a:lnSpc>
-                <a:spcPct val="105000"/>
-              </a:lnSpc>
-              <a:buNone/>
-              <a:defRPr sz="975" b="0">
-                <a:solidFill>
-                  <a:srgbClr val="6B7280"/>
-                </a:solidFill>
-                <a:latin typeface="Arial"/>
-                <a:ea typeface="Arial"/>
-                <a:cs typeface="Arial"/>
-              </a:defRPr>
-            </a:pPr>
-            <a:r>
-              <a:rPr sz="975" b="0">
-                <a:solidFill>
-                  <a:srgbClr val="6B7280"/>
-                </a:solidFill>
-                <a:latin typeface="Arial"/>
-                <a:ea typeface="Arial"/>
-                <a:cs typeface="Arial"/>
-              </a:rPr>
-              <a:t>Спикер · Анастасия</a:t>
-            </a:r>
-          </a:p>
-        </p:txBody>
-      </p:sp>
-      <p:sp>
-        <p:nvSpPr>
-          <p:cNvPr id="35" name="">
-            <a:extLst xmlns:a="http://schemas.openxmlformats.org/drawingml/2006/main">
-              <a:ext uri="{FF2B5EF4-FFF2-40B4-BE49-F238E27FC236}">
-                <a16:creationId xmlns:a16="http://schemas.microsoft.com/office/drawing/2014/main" id="{1F93A05F-62AE-4296-B286-DF3B7E4FA895}"/>
+                <a16:creationId xmlns:a16="http://schemas.microsoft.com/office/drawing/2014/main" id="{6E7987C3-CD36-419C-958A-EE4338CDFF38}"/>
               </a:ext>
             </a:extLst>
           </p:cNvPr>
@@ -23500,7 +22661,7 @@
     </p:spTree>
     <p:extLst>
       <p:ext uri="{BB962C8B-B14F-4D97-AF65-F5344CB8AC3E}">
-        <p14:creationId xmlns:p14="http://schemas.microsoft.com/office/powerpoint/2010/main" val="1375729944"/>
+        <p14:creationId xmlns:p14="http://schemas.microsoft.com/office/powerpoint/2010/main" val="1733278928"/>
       </p:ext>
     </p:extLst>
   </p:cSld>
@@ -23528,10 +22689,10 @@
       </p:grpSpPr>
       <p:sp>
         <p:nvSpPr>
-          <p:cNvPr id="21" name="">
+          <p:cNvPr id="20" name="">
             <a:extLst xmlns:a="http://schemas.openxmlformats.org/drawingml/2006/main">
               <a:ext uri="{FF2B5EF4-FFF2-40B4-BE49-F238E27FC236}">
-                <a16:creationId xmlns:a16="http://schemas.microsoft.com/office/drawing/2014/main" id="{215C8358-08D0-43C0-88A0-AECA2192201A}"/>
+                <a16:creationId xmlns:a16="http://schemas.microsoft.com/office/drawing/2014/main" id="{A6683E63-D8F5-4D62-8B44-E829596C8BE8}"/>
               </a:ext>
             </a:extLst>
           </p:cNvPr>
@@ -23694,7 +22855,7 @@
           <p:cNvPr id="2" name="">
             <a:extLst xmlns:a="http://schemas.openxmlformats.org/drawingml/2006/main">
               <a:ext uri="{FF2B5EF4-FFF2-40B4-BE49-F238E27FC236}">
-                <a16:creationId xmlns:a16="http://schemas.microsoft.com/office/drawing/2014/main" id="{6C49F297-7F9D-49B1-B3D0-7DB455CBD7C3}"/>
+                <a16:creationId xmlns:a16="http://schemas.microsoft.com/office/drawing/2014/main" id="{CA29BF22-1985-4F5D-BFFD-D6BCE7950449}"/>
               </a:ext>
             </a:extLst>
           </p:cNvPr>
@@ -23847,7 +23008,7 @@
                 <a:ea typeface="Arial"/>
                 <a:cs typeface="Arial"/>
               </a:rPr>
-              <a:t>Показываем нормальный и граничный сценарий</a:t>
+              <a:t>Два сценария работы MVP</a:t>
             </a:r>
           </a:p>
         </p:txBody>
@@ -23857,7 +23018,7 @@
           <p:cNvPr id="3" name="">
             <a:extLst xmlns:a="http://schemas.openxmlformats.org/drawingml/2006/main">
               <a:ext uri="{FF2B5EF4-FFF2-40B4-BE49-F238E27FC236}">
-                <a16:creationId xmlns:a16="http://schemas.microsoft.com/office/drawing/2014/main" id="{05106D66-EF75-4EC0-99AE-EF93CE153729}"/>
+                <a16:creationId xmlns:a16="http://schemas.microsoft.com/office/drawing/2014/main" id="{E58C4B95-8CDE-4399-B8A3-923D5B68D721}"/>
               </a:ext>
             </a:extLst>
           </p:cNvPr>
@@ -24010,7 +23171,7 @@
                 <a:ea typeface="Arial"/>
                 <a:cs typeface="Arial"/>
               </a:rPr>
-              <a:t>Вверху интерфейса указан режим Gemini 3.5 Flash Lite.</a:t>
+              <a:t>Обычный бюджет и случай, когда допустимое меню не найдено.</a:t>
             </a:r>
           </a:p>
         </p:txBody>
@@ -24020,7 +23181,7 @@
           <p:cNvPr id="4" name="">
             <a:extLst xmlns:a="http://schemas.openxmlformats.org/drawingml/2006/main">
               <a:ext uri="{FF2B5EF4-FFF2-40B4-BE49-F238E27FC236}">
-                <a16:creationId xmlns:a16="http://schemas.microsoft.com/office/drawing/2014/main" id="{382005B8-2785-44B1-977D-211F83A72BAF}"/>
+                <a16:creationId xmlns:a16="http://schemas.microsoft.com/office/drawing/2014/main" id="{2F8D435C-0EAA-4470-ADA4-444614D6922A}"/>
               </a:ext>
             </a:extLst>
           </p:cNvPr>
@@ -24053,7 +23214,7 @@
           <p:cNvPr id="5" name="">
             <a:extLst xmlns:a="http://schemas.openxmlformats.org/drawingml/2006/main">
               <a:ext uri="{FF2B5EF4-FFF2-40B4-BE49-F238E27FC236}">
-                <a16:creationId xmlns:a16="http://schemas.microsoft.com/office/drawing/2014/main" id="{50BD340B-8AFF-4A9D-8BE6-67899BDF66E9}"/>
+                <a16:creationId xmlns:a16="http://schemas.microsoft.com/office/drawing/2014/main" id="{155CA80D-4892-4ADD-8918-6C0B11CE0C8F}"/>
               </a:ext>
             </a:extLst>
           </p:cNvPr>
@@ -24063,7 +23224,7 @@
           <p:nvPr/>
         </p:nvPicPr>
         <p:blipFill>
-          <a:blip xmlns:r="http://schemas.openxmlformats.org/officeDocument/2006/relationships" xmlns:a="http://schemas.openxmlformats.org/drawingml/2006/main" r:embed="Ra8677164b4ef4c1b"/>
+          <a:blip xmlns:r="http://schemas.openxmlformats.org/officeDocument/2006/relationships" xmlns:a="http://schemas.openxmlformats.org/drawingml/2006/main" r:embed="Rc2f5a04e348a4cde"/>
           <a:srcRect xmlns:a="http://schemas.openxmlformats.org/drawingml/2006/main" l="0" t="0" r="0" b="12000"/>
           <a:stretch xmlns:a="http://schemas.openxmlformats.org/drawingml/2006/main"/>
         </p:blipFill>
@@ -24084,7 +23245,7 @@
           <p:cNvPr id="6" name="">
             <a:extLst xmlns:a="http://schemas.openxmlformats.org/drawingml/2006/main">
               <a:ext uri="{FF2B5EF4-FFF2-40B4-BE49-F238E27FC236}">
-                <a16:creationId xmlns:a16="http://schemas.microsoft.com/office/drawing/2014/main" id="{6E1711FF-9E0B-48B2-A9E7-8540184A4D26}"/>
+                <a16:creationId xmlns:a16="http://schemas.microsoft.com/office/drawing/2014/main" id="{851AD172-9D7E-4D14-8EC2-2134AB6F545D}"/>
               </a:ext>
             </a:extLst>
           </p:cNvPr>
@@ -24117,7 +23278,7 @@
           <p:cNvPr id="7" name="">
             <a:extLst xmlns:a="http://schemas.openxmlformats.org/drawingml/2006/main">
               <a:ext uri="{FF2B5EF4-FFF2-40B4-BE49-F238E27FC236}">
-                <a16:creationId xmlns:a16="http://schemas.microsoft.com/office/drawing/2014/main" id="{5E45B8F5-2F3C-46D1-8AE6-6E5136F7F99B}"/>
+                <a16:creationId xmlns:a16="http://schemas.microsoft.com/office/drawing/2014/main" id="{3900935A-251B-4D79-90F5-34EADB6383FB}"/>
               </a:ext>
             </a:extLst>
           </p:cNvPr>
@@ -24142,7 +23303,7 @@
         </p:spPr>
         <p:txBody>
           <a:bodyPr xmlns:a="http://schemas.openxmlformats.org/drawingml/2006/main" wrap="square" lIns="0" tIns="0" rIns="0" bIns="0" anchor="t">
-            <a:normAutofit fontScale="97268"/>
+            <a:normAutofit fontScale="100000"/>
           </a:bodyPr>
           <a:lstStyle xmlns:a="http://schemas.openxmlformats.org/drawingml/2006/main">
             <a:defPPr algn="ctr">
@@ -24270,7 +23431,7 @@
                 <a:ea typeface="Arial"/>
                 <a:cs typeface="Arial"/>
               </a:rPr>
-              <a:t>GEMINI · В РЕАЛЬНОМ ВРЕМЕНИ</a:t>
+              <a:t>GEMINI · ПОДКЛЮЧЁН</a:t>
             </a:r>
           </a:p>
         </p:txBody>
@@ -24280,7 +23441,7 @@
           <p:cNvPr id="8" name="">
             <a:extLst xmlns:a="http://schemas.openxmlformats.org/drawingml/2006/main">
               <a:ext uri="{FF2B5EF4-FFF2-40B4-BE49-F238E27FC236}">
-                <a16:creationId xmlns:a16="http://schemas.microsoft.com/office/drawing/2014/main" id="{3B26A1D8-BB81-4766-BAF6-8A2A3E6A5C67}"/>
+                <a16:creationId xmlns:a16="http://schemas.microsoft.com/office/drawing/2014/main" id="{6C16F25B-C7C3-4E87-8E9F-3369A4D8DCC5}"/>
               </a:ext>
             </a:extLst>
           </p:cNvPr>
@@ -24443,7 +23604,7 @@
           <p:cNvPr id="9" name="">
             <a:extLst xmlns:a="http://schemas.openxmlformats.org/drawingml/2006/main">
               <a:ext uri="{FF2B5EF4-FFF2-40B4-BE49-F238E27FC236}">
-                <a16:creationId xmlns:a16="http://schemas.microsoft.com/office/drawing/2014/main" id="{BA362704-6FAE-4E0B-9647-F5E33B13E002}"/>
+                <a16:creationId xmlns:a16="http://schemas.microsoft.com/office/drawing/2014/main" id="{4ABC0194-B683-4193-8E40-80E6071CB38D}"/>
               </a:ext>
             </a:extLst>
           </p:cNvPr>
@@ -24606,7 +23767,7 @@
           <p:cNvPr id="10" name="">
             <a:extLst xmlns:a="http://schemas.openxmlformats.org/drawingml/2006/main">
               <a:ext uri="{FF2B5EF4-FFF2-40B4-BE49-F238E27FC236}">
-                <a16:creationId xmlns:a16="http://schemas.microsoft.com/office/drawing/2014/main" id="{8A4B4ED4-2F5E-4804-B88F-86D3071C4E13}"/>
+                <a16:creationId xmlns:a16="http://schemas.microsoft.com/office/drawing/2014/main" id="{A2EE095C-C0E8-43F8-BF4B-FF25D707AE69}"/>
               </a:ext>
             </a:extLst>
           </p:cNvPr>
@@ -24769,7 +23930,7 @@
           <p:cNvPr id="11" name="">
             <a:extLst xmlns:a="http://schemas.openxmlformats.org/drawingml/2006/main">
               <a:ext uri="{FF2B5EF4-FFF2-40B4-BE49-F238E27FC236}">
-                <a16:creationId xmlns:a16="http://schemas.microsoft.com/office/drawing/2014/main" id="{6AB8C3E6-D4AF-4852-AD44-5144CD7F10E9}"/>
+                <a16:creationId xmlns:a16="http://schemas.microsoft.com/office/drawing/2014/main" id="{B1D5FD7D-2677-4400-B6BB-60F69F227725}"/>
               </a:ext>
             </a:extLst>
           </p:cNvPr>
@@ -24932,7 +24093,7 @@
           <p:cNvPr id="12" name="">
             <a:extLst xmlns:a="http://schemas.openxmlformats.org/drawingml/2006/main">
               <a:ext uri="{FF2B5EF4-FFF2-40B4-BE49-F238E27FC236}">
-                <a16:creationId xmlns:a16="http://schemas.microsoft.com/office/drawing/2014/main" id="{B5E6762F-BE4D-4B2D-A283-326C5C279E72}"/>
+                <a16:creationId xmlns:a16="http://schemas.microsoft.com/office/drawing/2014/main" id="{64446F38-356A-4715-B5AC-46E1737B8906}"/>
               </a:ext>
             </a:extLst>
           </p:cNvPr>
@@ -25095,7 +24256,7 @@
           <p:cNvPr id="13" name="">
             <a:extLst xmlns:a="http://schemas.openxmlformats.org/drawingml/2006/main">
               <a:ext uri="{FF2B5EF4-FFF2-40B4-BE49-F238E27FC236}">
-                <a16:creationId xmlns:a16="http://schemas.microsoft.com/office/drawing/2014/main" id="{32F89B47-B305-4671-A00A-98AB60807F8E}"/>
+                <a16:creationId xmlns:a16="http://schemas.microsoft.com/office/drawing/2014/main" id="{018A905A-41BB-45EA-AA15-AB31A0E4A2C4}"/>
               </a:ext>
             </a:extLst>
           </p:cNvPr>
@@ -25258,7 +24419,7 @@
           <p:cNvPr id="14" name="">
             <a:extLst xmlns:a="http://schemas.openxmlformats.org/drawingml/2006/main">
               <a:ext uri="{FF2B5EF4-FFF2-40B4-BE49-F238E27FC236}">
-                <a16:creationId xmlns:a16="http://schemas.microsoft.com/office/drawing/2014/main" id="{F88B8FAB-2DC1-486C-B9A5-99C9CC006968}"/>
+                <a16:creationId xmlns:a16="http://schemas.microsoft.com/office/drawing/2014/main" id="{950D295E-B328-4BF8-A951-8D2CE82BA899}"/>
               </a:ext>
             </a:extLst>
           </p:cNvPr>
@@ -25421,7 +24582,7 @@
           <p:cNvPr id="15" name="">
             <a:extLst xmlns:a="http://schemas.openxmlformats.org/drawingml/2006/main">
               <a:ext uri="{FF2B5EF4-FFF2-40B4-BE49-F238E27FC236}">
-                <a16:creationId xmlns:a16="http://schemas.microsoft.com/office/drawing/2014/main" id="{9181BE74-D98D-4465-91F9-55E51AAE3B33}"/>
+                <a16:creationId xmlns:a16="http://schemas.microsoft.com/office/drawing/2014/main" id="{CBB91B1D-DA7E-4BB1-898E-3264DFF5982A}"/>
               </a:ext>
             </a:extLst>
           </p:cNvPr>
@@ -25584,7 +24745,7 @@
           <p:cNvPr id="16" name="">
             <a:extLst xmlns:a="http://schemas.openxmlformats.org/drawingml/2006/main">
               <a:ext uri="{FF2B5EF4-FFF2-40B4-BE49-F238E27FC236}">
-                <a16:creationId xmlns:a16="http://schemas.microsoft.com/office/drawing/2014/main" id="{51ECD3B2-205A-4853-A975-012D40786A71}"/>
+                <a16:creationId xmlns:a16="http://schemas.microsoft.com/office/drawing/2014/main" id="{845C6875-BA0A-47E0-BBDF-A7FB20EA10C0}"/>
               </a:ext>
             </a:extLst>
           </p:cNvPr>
@@ -25737,7 +24898,7 @@
                 <a:ea typeface="Arial"/>
                 <a:cs typeface="Arial"/>
               </a:rPr>
-              <a:t>превышение бюджета → рекомендация → попытка 2</a:t>
+              <a:t>превышение бюджета, рекомендация, вторая попытка</a:t>
             </a:r>
           </a:p>
         </p:txBody>
@@ -25747,7 +24908,7 @@
           <p:cNvPr id="17" name="">
             <a:extLst xmlns:a="http://schemas.openxmlformats.org/drawingml/2006/main">
               <a:ext uri="{FF2B5EF4-FFF2-40B4-BE49-F238E27FC236}">
-                <a16:creationId xmlns:a16="http://schemas.microsoft.com/office/drawing/2014/main" id="{94721CC6-59B4-4932-A3BD-C0D08022C01E}"/>
+                <a16:creationId xmlns:a16="http://schemas.microsoft.com/office/drawing/2014/main" id="{ACB7B4F4-9ACA-45BE-86CE-3FB840CFD015}"/>
               </a:ext>
             </a:extLst>
           </p:cNvPr>
@@ -25782,7 +24943,7 @@
           <p:cNvPr id="18" name="">
             <a:extLst xmlns:a="http://schemas.openxmlformats.org/drawingml/2006/main">
               <a:ext uri="{FF2B5EF4-FFF2-40B4-BE49-F238E27FC236}">
-                <a16:creationId xmlns:a16="http://schemas.microsoft.com/office/drawing/2014/main" id="{0ED1F06B-783D-4209-AC53-FCEDA14DC2DD}"/>
+                <a16:creationId xmlns:a16="http://schemas.microsoft.com/office/drawing/2014/main" id="{B3C44E5D-1174-4429-AD7D-7F496667164E}"/>
               </a:ext>
             </a:extLst>
           </p:cNvPr>
@@ -25935,7 +25096,7 @@
                 <a:ea typeface="Arial"/>
                 <a:cs typeface="Arial"/>
               </a:rPr>
-              <a:t>Отказ при бюджете 0 — честный результат, а не сбой.</a:t>
+              <a:t>При бюджете 0 система сообщает, что меню не найдено.</a:t>
             </a:r>
           </a:p>
         </p:txBody>
@@ -25945,170 +25106,7 @@
           <p:cNvPr id="19" name="">
             <a:extLst xmlns:a="http://schemas.openxmlformats.org/drawingml/2006/main">
               <a:ext uri="{FF2B5EF4-FFF2-40B4-BE49-F238E27FC236}">
-                <a16:creationId xmlns:a16="http://schemas.microsoft.com/office/drawing/2014/main" id="{F14B1FC3-68EF-4065-97AD-E6C4B43447D4}"/>
-              </a:ext>
-            </a:extLst>
-          </p:cNvPr>
-          <p:cNvSpPr>
-            <a:spLocks xmlns:a="http://schemas.openxmlformats.org/drawingml/2006/main" noGrp="1"/>
-          </p:cNvSpPr>
-          <p:nvPr/>
-        </p:nvSpPr>
-        <p:spPr>
-          <a:xfrm xmlns:a="http://schemas.openxmlformats.org/drawingml/2006/main">
-            <a:off x="666750" y="6419850"/>
-            <a:ext cx="4762500" cy="190500"/>
-          </a:xfrm>
-          <a:prstGeom xmlns:a="http://schemas.openxmlformats.org/drawingml/2006/main" prst="rect">
-            <a:avLst/>
-          </a:prstGeom>
-          <a:noFill xmlns:a="http://schemas.openxmlformats.org/drawingml/2006/main"/>
-          <a:ln xmlns:a="http://schemas.openxmlformats.org/drawingml/2006/main" w="0">
-            <a:noFill/>
-            <a:prstDash val="solid"/>
-          </a:ln>
-        </p:spPr>
-        <p:txBody>
-          <a:bodyPr xmlns:a="http://schemas.openxmlformats.org/drawingml/2006/main" wrap="square" lIns="0" tIns="0" rIns="0" bIns="0" anchor="t">
-            <a:normAutofit fontScale="100000"/>
-          </a:bodyPr>
-          <a:lstStyle xmlns:a="http://schemas.openxmlformats.org/drawingml/2006/main">
-            <a:defPPr algn="l">
-              <a:defRPr sz="975" b="0">
-                <a:solidFill>
-                  <a:srgbClr val="6B7280"/>
-                </a:solidFill>
-                <a:latin typeface="Arial"/>
-                <a:ea typeface="Arial"/>
-                <a:cs typeface="Arial"/>
-              </a:defRPr>
-            </a:defPPr>
-            <a:lvl1pPr algn="l">
-              <a:defRPr sz="975" b="0">
-                <a:solidFill>
-                  <a:srgbClr val="6B7280"/>
-                </a:solidFill>
-                <a:latin typeface="Arial"/>
-                <a:ea typeface="Arial"/>
-                <a:cs typeface="Arial"/>
-              </a:defRPr>
-            </a:lvl1pPr>
-            <a:lvl2pPr algn="l">
-              <a:defRPr sz="975" b="0">
-                <a:solidFill>
-                  <a:srgbClr val="6B7280"/>
-                </a:solidFill>
-                <a:latin typeface="Arial"/>
-                <a:ea typeface="Arial"/>
-                <a:cs typeface="Arial"/>
-              </a:defRPr>
-            </a:lvl2pPr>
-            <a:lvl3pPr algn="l">
-              <a:defRPr sz="975" b="0">
-                <a:solidFill>
-                  <a:srgbClr val="6B7280"/>
-                </a:solidFill>
-                <a:latin typeface="Arial"/>
-                <a:ea typeface="Arial"/>
-                <a:cs typeface="Arial"/>
-              </a:defRPr>
-            </a:lvl3pPr>
-            <a:lvl4pPr algn="l">
-              <a:defRPr sz="975" b="0">
-                <a:solidFill>
-                  <a:srgbClr val="6B7280"/>
-                </a:solidFill>
-                <a:latin typeface="Arial"/>
-                <a:ea typeface="Arial"/>
-                <a:cs typeface="Arial"/>
-              </a:defRPr>
-            </a:lvl4pPr>
-            <a:lvl5pPr algn="l">
-              <a:defRPr sz="975" b="0">
-                <a:solidFill>
-                  <a:srgbClr val="6B7280"/>
-                </a:solidFill>
-                <a:latin typeface="Arial"/>
-                <a:ea typeface="Arial"/>
-                <a:cs typeface="Arial"/>
-              </a:defRPr>
-            </a:lvl5pPr>
-            <a:lvl6pPr algn="l">
-              <a:defRPr sz="975" b="0">
-                <a:solidFill>
-                  <a:srgbClr val="6B7280"/>
-                </a:solidFill>
-                <a:latin typeface="Arial"/>
-                <a:ea typeface="Arial"/>
-                <a:cs typeface="Arial"/>
-              </a:defRPr>
-            </a:lvl6pPr>
-            <a:lvl7pPr algn="l">
-              <a:defRPr sz="975" b="0">
-                <a:solidFill>
-                  <a:srgbClr val="6B7280"/>
-                </a:solidFill>
-                <a:latin typeface="Arial"/>
-                <a:ea typeface="Arial"/>
-                <a:cs typeface="Arial"/>
-              </a:defRPr>
-            </a:lvl7pPr>
-            <a:lvl8pPr algn="l">
-              <a:defRPr sz="975" b="0">
-                <a:solidFill>
-                  <a:srgbClr val="6B7280"/>
-                </a:solidFill>
-                <a:latin typeface="Arial"/>
-                <a:ea typeface="Arial"/>
-                <a:cs typeface="Arial"/>
-              </a:defRPr>
-            </a:lvl8pPr>
-            <a:lvl9pPr algn="l">
-              <a:defRPr sz="975" b="0">
-                <a:solidFill>
-                  <a:srgbClr val="6B7280"/>
-                </a:solidFill>
-                <a:latin typeface="Arial"/>
-                <a:ea typeface="Arial"/>
-                <a:cs typeface="Arial"/>
-              </a:defRPr>
-            </a:lvl9pPr>
-          </a:lstStyle>
-          <a:p xmlns:a="http://schemas.openxmlformats.org/drawingml/2006/main">
-            <a:pPr algn="l">
-              <a:lnSpc>
-                <a:spcPct val="105000"/>
-              </a:lnSpc>
-              <a:buNone/>
-              <a:defRPr sz="975" b="0">
-                <a:solidFill>
-                  <a:srgbClr val="6B7280"/>
-                </a:solidFill>
-                <a:latin typeface="Arial"/>
-                <a:ea typeface="Arial"/>
-                <a:cs typeface="Arial"/>
-              </a:defRPr>
-            </a:pPr>
-            <a:r>
-              <a:rPr sz="975" b="0">
-                <a:solidFill>
-                  <a:srgbClr val="6B7280"/>
-                </a:solidFill>
-                <a:latin typeface="Arial"/>
-                <a:ea typeface="Arial"/>
-                <a:cs typeface="Arial"/>
-              </a:rPr>
-              <a:t>Демо · все участники по своей части</a:t>
-            </a:r>
-          </a:p>
-        </p:txBody>
-      </p:sp>
-      <p:sp>
-        <p:nvSpPr>
-          <p:cNvPr id="20" name="">
-            <a:extLst xmlns:a="http://schemas.openxmlformats.org/drawingml/2006/main">
-              <a:ext uri="{FF2B5EF4-FFF2-40B4-BE49-F238E27FC236}">
-                <a16:creationId xmlns:a16="http://schemas.microsoft.com/office/drawing/2014/main" id="{A889E153-0349-4656-B3B9-BCD58C0FCE2C}"/>
+                <a16:creationId xmlns:a16="http://schemas.microsoft.com/office/drawing/2014/main" id="{0B8710AC-D3F0-4DA7-8980-204D8667329F}"/>
               </a:ext>
             </a:extLst>
           </p:cNvPr>
@@ -26269,7 +25267,7 @@
     </p:spTree>
     <p:extLst>
       <p:ext uri="{BB962C8B-B14F-4D97-AF65-F5344CB8AC3E}">
-        <p14:creationId xmlns:p14="http://schemas.microsoft.com/office/powerpoint/2010/main" val="434831781"/>
+        <p14:creationId xmlns:p14="http://schemas.microsoft.com/office/powerpoint/2010/main" val="1910653751"/>
       </p:ext>
     </p:extLst>
   </p:cSld>
@@ -26297,10 +25295,10 @@
       </p:grpSpPr>
       <p:sp>
         <p:nvSpPr>
-          <p:cNvPr id="28" name="">
+          <p:cNvPr id="27" name="">
             <a:extLst xmlns:a="http://schemas.openxmlformats.org/drawingml/2006/main">
               <a:ext uri="{FF2B5EF4-FFF2-40B4-BE49-F238E27FC236}">
-                <a16:creationId xmlns:a16="http://schemas.microsoft.com/office/drawing/2014/main" id="{728F1AF3-F437-46FC-B42F-F506BE50CCCF}"/>
+                <a16:creationId xmlns:a16="http://schemas.microsoft.com/office/drawing/2014/main" id="{8B8642BD-33BE-4E7E-B5ED-F1348BAB5C30}"/>
               </a:ext>
             </a:extLst>
           </p:cNvPr>
@@ -26463,7 +25461,7 @@
           <p:cNvPr id="2" name="">
             <a:extLst xmlns:a="http://schemas.openxmlformats.org/drawingml/2006/main">
               <a:ext uri="{FF2B5EF4-FFF2-40B4-BE49-F238E27FC236}">
-                <a16:creationId xmlns:a16="http://schemas.microsoft.com/office/drawing/2014/main" id="{E18E08A7-22FB-4217-AF5A-F51D09713C1E}"/>
+                <a16:creationId xmlns:a16="http://schemas.microsoft.com/office/drawing/2014/main" id="{03B0F097-18ED-41C4-938D-CE0CB2D9B688}"/>
               </a:ext>
             </a:extLst>
           </p:cNvPr>
@@ -26616,7 +25614,7 @@
                 <a:ea typeface="Arial"/>
                 <a:cs typeface="Arial"/>
               </a:rPr>
-              <a:t>Стабильная база для итоговой защиты</a:t>
+              <a:t>MVP готов к защите</a:t>
             </a:r>
           </a:p>
         </p:txBody>
@@ -26626,7 +25624,7 @@
           <p:cNvPr id="3" name="">
             <a:extLst xmlns:a="http://schemas.openxmlformats.org/drawingml/2006/main">
               <a:ext uri="{FF2B5EF4-FFF2-40B4-BE49-F238E27FC236}">
-                <a16:creationId xmlns:a16="http://schemas.microsoft.com/office/drawing/2014/main" id="{82F9C2AB-8D87-446B-AFFC-92136E0EC0C2}"/>
+                <a16:creationId xmlns:a16="http://schemas.microsoft.com/office/drawing/2014/main" id="{C85C76B3-A8C6-4EF8-916D-F0DC4707F626}"/>
               </a:ext>
             </a:extLst>
           </p:cNvPr>
@@ -26779,7 +25777,7 @@
                 <a:ea typeface="Arial"/>
                 <a:cs typeface="Arial"/>
               </a:rPr>
-              <a:t>Проект воспроизводится локально и честно показывает границы текущих данных.</a:t>
+              <a:t>Приложение запускается локально, репозиторий открыт и документирован.</a:t>
             </a:r>
           </a:p>
         </p:txBody>
@@ -26789,7 +25787,7 @@
           <p:cNvPr id="4" name="">
             <a:extLst xmlns:a="http://schemas.openxmlformats.org/drawingml/2006/main">
               <a:ext uri="{FF2B5EF4-FFF2-40B4-BE49-F238E27FC236}">
-                <a16:creationId xmlns:a16="http://schemas.microsoft.com/office/drawing/2014/main" id="{D9DBB39C-BBCA-4F62-87DE-96BC84A0A1C9}"/>
+                <a16:creationId xmlns:a16="http://schemas.microsoft.com/office/drawing/2014/main" id="{DA209F81-FA38-4896-96F7-2611FC38FA6F}"/>
               </a:ext>
             </a:extLst>
           </p:cNvPr>
@@ -26952,7 +25950,7 @@
           <p:cNvPr id="5" name="">
             <a:extLst xmlns:a="http://schemas.openxmlformats.org/drawingml/2006/main">
               <a:ext uri="{FF2B5EF4-FFF2-40B4-BE49-F238E27FC236}">
-                <a16:creationId xmlns:a16="http://schemas.microsoft.com/office/drawing/2014/main" id="{5A271CC9-EC03-400D-A03C-9DAA4800CD80}"/>
+                <a16:creationId xmlns:a16="http://schemas.microsoft.com/office/drawing/2014/main" id="{C596575B-B5C2-4BA1-8D8A-CB5B270096F9}"/>
               </a:ext>
             </a:extLst>
           </p:cNvPr>
@@ -27115,7 +26113,7 @@
           <p:cNvPr id="6" name="">
             <a:extLst xmlns:a="http://schemas.openxmlformats.org/drawingml/2006/main">
               <a:ext uri="{FF2B5EF4-FFF2-40B4-BE49-F238E27FC236}">
-                <a16:creationId xmlns:a16="http://schemas.microsoft.com/office/drawing/2014/main" id="{E7EC0AF9-AB99-4062-846C-AEDCC46A331D}"/>
+                <a16:creationId xmlns:a16="http://schemas.microsoft.com/office/drawing/2014/main" id="{7FA91FDB-2364-46CB-BC9F-7F361C1F15CA}"/>
               </a:ext>
             </a:extLst>
           </p:cNvPr>
@@ -27278,7 +26276,7 @@
           <p:cNvPr id="7" name="">
             <a:extLst xmlns:a="http://schemas.openxmlformats.org/drawingml/2006/main">
               <a:ext uri="{FF2B5EF4-FFF2-40B4-BE49-F238E27FC236}">
-                <a16:creationId xmlns:a16="http://schemas.microsoft.com/office/drawing/2014/main" id="{76D82137-6E26-4B7F-9897-9EE3FC2985D2}"/>
+                <a16:creationId xmlns:a16="http://schemas.microsoft.com/office/drawing/2014/main" id="{D213C60C-D6A9-4C91-89BC-1996A1F7C6D1}"/>
               </a:ext>
             </a:extLst>
           </p:cNvPr>
@@ -27441,7 +26439,7 @@
           <p:cNvPr id="8" name="">
             <a:extLst xmlns:a="http://schemas.openxmlformats.org/drawingml/2006/main">
               <a:ext uri="{FF2B5EF4-FFF2-40B4-BE49-F238E27FC236}">
-                <a16:creationId xmlns:a16="http://schemas.microsoft.com/office/drawing/2014/main" id="{E208DEB6-BFD3-48BB-B86E-87305A0BBD15}"/>
+                <a16:creationId xmlns:a16="http://schemas.microsoft.com/office/drawing/2014/main" id="{E14CFB57-5201-4B73-8C5A-C7136D9E19C3}"/>
               </a:ext>
             </a:extLst>
           </p:cNvPr>
@@ -27604,7 +26602,7 @@
           <p:cNvPr id="9" name="">
             <a:extLst xmlns:a="http://schemas.openxmlformats.org/drawingml/2006/main">
               <a:ext uri="{FF2B5EF4-FFF2-40B4-BE49-F238E27FC236}">
-                <a16:creationId xmlns:a16="http://schemas.microsoft.com/office/drawing/2014/main" id="{7886C6AC-9551-4B60-90D6-428BBB40F11A}"/>
+                <a16:creationId xmlns:a16="http://schemas.microsoft.com/office/drawing/2014/main" id="{B4475309-0CA9-457E-92BA-366EBC0F487F}"/>
               </a:ext>
             </a:extLst>
           </p:cNvPr>
@@ -27767,7 +26765,7 @@
           <p:cNvPr id="10" name="">
             <a:extLst xmlns:a="http://schemas.openxmlformats.org/drawingml/2006/main">
               <a:ext uri="{FF2B5EF4-FFF2-40B4-BE49-F238E27FC236}">
-                <a16:creationId xmlns:a16="http://schemas.microsoft.com/office/drawing/2014/main" id="{28B28DD5-6B3C-4E1B-9C08-852B9672E6E7}"/>
+                <a16:creationId xmlns:a16="http://schemas.microsoft.com/office/drawing/2014/main" id="{E5A38C84-CDF7-481B-AFE5-766E1D855F94}"/>
               </a:ext>
             </a:extLst>
           </p:cNvPr>
@@ -27930,7 +26928,7 @@
           <p:cNvPr id="11" name="">
             <a:extLst xmlns:a="http://schemas.openxmlformats.org/drawingml/2006/main">
               <a:ext uri="{FF2B5EF4-FFF2-40B4-BE49-F238E27FC236}">
-                <a16:creationId xmlns:a16="http://schemas.microsoft.com/office/drawing/2014/main" id="{B9946DA0-4959-4452-AEA0-53148F7D3BC4}"/>
+                <a16:creationId xmlns:a16="http://schemas.microsoft.com/office/drawing/2014/main" id="{097EBEDD-491F-4F39-B546-8FC5D0803012}"/>
               </a:ext>
             </a:extLst>
           </p:cNvPr>
@@ -28093,7 +27091,7 @@
           <p:cNvPr id="12" name="">
             <a:extLst xmlns:a="http://schemas.openxmlformats.org/drawingml/2006/main">
               <a:ext uri="{FF2B5EF4-FFF2-40B4-BE49-F238E27FC236}">
-                <a16:creationId xmlns:a16="http://schemas.microsoft.com/office/drawing/2014/main" id="{AD900690-8DB4-4C74-84CB-17208B96DFB5}"/>
+                <a16:creationId xmlns:a16="http://schemas.microsoft.com/office/drawing/2014/main" id="{B47D21FA-0C67-4E33-B68D-AEFE4872065E}"/>
               </a:ext>
             </a:extLst>
           </p:cNvPr>
@@ -28256,7 +27254,7 @@
           <p:cNvPr id="13" name="">
             <a:extLst xmlns:a="http://schemas.openxmlformats.org/drawingml/2006/main">
               <a:ext uri="{FF2B5EF4-FFF2-40B4-BE49-F238E27FC236}">
-                <a16:creationId xmlns:a16="http://schemas.microsoft.com/office/drawing/2014/main" id="{7830DC82-E331-44A0-93CA-37D1F8F8AC26}"/>
+                <a16:creationId xmlns:a16="http://schemas.microsoft.com/office/drawing/2014/main" id="{A2A98690-0E6C-41FC-948C-49D8E41B77C2}"/>
               </a:ext>
             </a:extLst>
           </p:cNvPr>
@@ -28289,7 +27287,7 @@
           <p:cNvPr id="14" name="">
             <a:extLst xmlns:a="http://schemas.openxmlformats.org/drawingml/2006/main">
               <a:ext uri="{FF2B5EF4-FFF2-40B4-BE49-F238E27FC236}">
-                <a16:creationId xmlns:a16="http://schemas.microsoft.com/office/drawing/2014/main" id="{E843D8F2-DC6E-4562-BD01-14C9959AEEE8}"/>
+                <a16:creationId xmlns:a16="http://schemas.microsoft.com/office/drawing/2014/main" id="{B0EC4944-8365-47A7-9413-D8D5621BBF8A}"/>
               </a:ext>
             </a:extLst>
           </p:cNvPr>
@@ -28452,7 +27450,7 @@
           <p:cNvPr id="15" name="">
             <a:extLst xmlns:a="http://schemas.openxmlformats.org/drawingml/2006/main">
               <a:ext uri="{FF2B5EF4-FFF2-40B4-BE49-F238E27FC236}">
-                <a16:creationId xmlns:a16="http://schemas.microsoft.com/office/drawing/2014/main" id="{BBB3904B-CC34-4706-8CCC-3CA75FFC9661}"/>
+                <a16:creationId xmlns:a16="http://schemas.microsoft.com/office/drawing/2014/main" id="{BE05DC84-1179-4CCD-9C67-BD890B9C5388}"/>
               </a:ext>
             </a:extLst>
           </p:cNvPr>
@@ -28485,7 +27483,7 @@
           <p:cNvPr id="16" name="">
             <a:extLst xmlns:a="http://schemas.openxmlformats.org/drawingml/2006/main">
               <a:ext uri="{FF2B5EF4-FFF2-40B4-BE49-F238E27FC236}">
-                <a16:creationId xmlns:a16="http://schemas.microsoft.com/office/drawing/2014/main" id="{46D83772-6ADE-4850-AEA8-899563E84A2E}"/>
+                <a16:creationId xmlns:a16="http://schemas.microsoft.com/office/drawing/2014/main" id="{5BEF9C0B-8CEA-4B56-B313-265B9592FA53}"/>
               </a:ext>
             </a:extLst>
           </p:cNvPr>
@@ -28648,7 +27646,7 @@
           <p:cNvPr id="17" name="">
             <a:extLst xmlns:a="http://schemas.openxmlformats.org/drawingml/2006/main">
               <a:ext uri="{FF2B5EF4-FFF2-40B4-BE49-F238E27FC236}">
-                <a16:creationId xmlns:a16="http://schemas.microsoft.com/office/drawing/2014/main" id="{AB899DD2-AF43-4225-B2E0-00F2D9FD7BDF}"/>
+                <a16:creationId xmlns:a16="http://schemas.microsoft.com/office/drawing/2014/main" id="{000624F9-B561-40E7-BA33-E49C4CED6A2D}"/>
               </a:ext>
             </a:extLst>
           </p:cNvPr>
@@ -28681,7 +27679,7 @@
           <p:cNvPr id="18" name="">
             <a:extLst xmlns:a="http://schemas.openxmlformats.org/drawingml/2006/main">
               <a:ext uri="{FF2B5EF4-FFF2-40B4-BE49-F238E27FC236}">
-                <a16:creationId xmlns:a16="http://schemas.microsoft.com/office/drawing/2014/main" id="{7AE57D50-24F6-43AE-B0E7-68B2EB0D646E}"/>
+                <a16:creationId xmlns:a16="http://schemas.microsoft.com/office/drawing/2014/main" id="{80CA2BE0-0C9B-4926-8F33-E3B22882D1E5}"/>
               </a:ext>
             </a:extLst>
           </p:cNvPr>
@@ -28844,7 +27842,7 @@
           <p:cNvPr id="19" name="">
             <a:extLst xmlns:a="http://schemas.openxmlformats.org/drawingml/2006/main">
               <a:ext uri="{FF2B5EF4-FFF2-40B4-BE49-F238E27FC236}">
-                <a16:creationId xmlns:a16="http://schemas.microsoft.com/office/drawing/2014/main" id="{F67A6B12-6BD8-4E21-90C3-11D9732908C4}"/>
+                <a16:creationId xmlns:a16="http://schemas.microsoft.com/office/drawing/2014/main" id="{E94F52BD-22F0-4E0D-A714-7CEF23E177A6}"/>
               </a:ext>
             </a:extLst>
           </p:cNvPr>
@@ -28997,7 +27995,7 @@
                 <a:ea typeface="Arial"/>
                 <a:cs typeface="Arial"/>
               </a:rPr>
-              <a:t>Следующий этап</a:t>
+              <a:t>После защиты проекта</a:t>
             </a:r>
           </a:p>
         </p:txBody>
@@ -29007,7 +28005,7 @@
           <p:cNvPr id="20" name="">
             <a:extLst xmlns:a="http://schemas.openxmlformats.org/drawingml/2006/main">
               <a:ext uri="{FF2B5EF4-FFF2-40B4-BE49-F238E27FC236}">
-                <a16:creationId xmlns:a16="http://schemas.microsoft.com/office/drawing/2014/main" id="{FD56C8BF-C728-4F0B-9702-4D0CDAF32B57}"/>
+                <a16:creationId xmlns:a16="http://schemas.microsoft.com/office/drawing/2014/main" id="{F370824B-03F2-424A-B4F9-983C6F5F1256}"/>
               </a:ext>
             </a:extLst>
           </p:cNvPr>
@@ -29040,7 +28038,7 @@
           <p:cNvPr id="21" name="">
             <a:extLst xmlns:a="http://schemas.openxmlformats.org/drawingml/2006/main">
               <a:ext uri="{FF2B5EF4-FFF2-40B4-BE49-F238E27FC236}">
-                <a16:creationId xmlns:a16="http://schemas.microsoft.com/office/drawing/2014/main" id="{9D85EC39-DBBF-42CD-B833-2B14C21A0EB7}"/>
+                <a16:creationId xmlns:a16="http://schemas.microsoft.com/office/drawing/2014/main" id="{BAC7FD75-1D81-40E9-86F6-F361708B2E31}"/>
               </a:ext>
             </a:extLst>
           </p:cNvPr>
@@ -29203,7 +28201,7 @@
           <p:cNvPr id="22" name="">
             <a:extLst xmlns:a="http://schemas.openxmlformats.org/drawingml/2006/main">
               <a:ext uri="{FF2B5EF4-FFF2-40B4-BE49-F238E27FC236}">
-                <a16:creationId xmlns:a16="http://schemas.microsoft.com/office/drawing/2014/main" id="{7BC8C75C-F87E-4B89-992A-4FD62A19D3D5}"/>
+                <a16:creationId xmlns:a16="http://schemas.microsoft.com/office/drawing/2014/main" id="{E13D9AF8-946D-4666-9B60-D911446722FE}"/>
               </a:ext>
             </a:extLst>
           </p:cNvPr>
@@ -29236,7 +28234,7 @@
           <p:cNvPr id="23" name="">
             <a:extLst xmlns:a="http://schemas.openxmlformats.org/drawingml/2006/main">
               <a:ext uri="{FF2B5EF4-FFF2-40B4-BE49-F238E27FC236}">
-                <a16:creationId xmlns:a16="http://schemas.microsoft.com/office/drawing/2014/main" id="{10B39041-17FF-4CFC-870F-7682D16C5639}"/>
+                <a16:creationId xmlns:a16="http://schemas.microsoft.com/office/drawing/2014/main" id="{0E4A3A4E-9E84-4881-AC04-876C7C749470}"/>
               </a:ext>
             </a:extLst>
           </p:cNvPr>
@@ -29399,7 +28397,7 @@
           <p:cNvPr id="24" name="">
             <a:extLst xmlns:a="http://schemas.openxmlformats.org/drawingml/2006/main">
               <a:ext uri="{FF2B5EF4-FFF2-40B4-BE49-F238E27FC236}">
-                <a16:creationId xmlns:a16="http://schemas.microsoft.com/office/drawing/2014/main" id="{76E29B50-6C8A-4A2C-AB47-E605163E9CA3}"/>
+                <a16:creationId xmlns:a16="http://schemas.microsoft.com/office/drawing/2014/main" id="{8B0C9BEA-9F93-4338-9EAA-7466645EA975}"/>
               </a:ext>
             </a:extLst>
           </p:cNvPr>
@@ -29432,7 +28430,7 @@
           <p:cNvPr id="25" name="">
             <a:extLst xmlns:a="http://schemas.openxmlformats.org/drawingml/2006/main">
               <a:ext uri="{FF2B5EF4-FFF2-40B4-BE49-F238E27FC236}">
-                <a16:creationId xmlns:a16="http://schemas.microsoft.com/office/drawing/2014/main" id="{9CE76231-53BD-4C3C-8378-0FDECF7062A8}"/>
+                <a16:creationId xmlns:a16="http://schemas.microsoft.com/office/drawing/2014/main" id="{348670AF-DC26-45F7-8DE3-4EB821F8B050}"/>
               </a:ext>
             </a:extLst>
           </p:cNvPr>
@@ -29595,170 +28593,7 @@
           <p:cNvPr id="26" name="">
             <a:extLst xmlns:a="http://schemas.openxmlformats.org/drawingml/2006/main">
               <a:ext uri="{FF2B5EF4-FFF2-40B4-BE49-F238E27FC236}">
-                <a16:creationId xmlns:a16="http://schemas.microsoft.com/office/drawing/2014/main" id="{9F4E2C38-62B5-4478-96EA-290EFB998A81}"/>
-              </a:ext>
-            </a:extLst>
-          </p:cNvPr>
-          <p:cNvSpPr>
-            <a:spLocks xmlns:a="http://schemas.openxmlformats.org/drawingml/2006/main" noGrp="1"/>
-          </p:cNvSpPr>
-          <p:nvPr/>
-        </p:nvSpPr>
-        <p:spPr>
-          <a:xfrm xmlns:a="http://schemas.openxmlformats.org/drawingml/2006/main">
-            <a:off x="666750" y="6419850"/>
-            <a:ext cx="4762500" cy="190500"/>
-          </a:xfrm>
-          <a:prstGeom xmlns:a="http://schemas.openxmlformats.org/drawingml/2006/main" prst="rect">
-            <a:avLst/>
-          </a:prstGeom>
-          <a:noFill xmlns:a="http://schemas.openxmlformats.org/drawingml/2006/main"/>
-          <a:ln xmlns:a="http://schemas.openxmlformats.org/drawingml/2006/main" w="0">
-            <a:noFill/>
-            <a:prstDash val="solid"/>
-          </a:ln>
-        </p:spPr>
-        <p:txBody>
-          <a:bodyPr xmlns:a="http://schemas.openxmlformats.org/drawingml/2006/main" wrap="square" lIns="0" tIns="0" rIns="0" bIns="0" anchor="t">
-            <a:normAutofit fontScale="100000"/>
-          </a:bodyPr>
-          <a:lstStyle xmlns:a="http://schemas.openxmlformats.org/drawingml/2006/main">
-            <a:defPPr algn="l">
-              <a:defRPr sz="975" b="0">
-                <a:solidFill>
-                  <a:srgbClr val="6B7280"/>
-                </a:solidFill>
-                <a:latin typeface="Arial"/>
-                <a:ea typeface="Arial"/>
-                <a:cs typeface="Arial"/>
-              </a:defRPr>
-            </a:defPPr>
-            <a:lvl1pPr algn="l">
-              <a:defRPr sz="975" b="0">
-                <a:solidFill>
-                  <a:srgbClr val="6B7280"/>
-                </a:solidFill>
-                <a:latin typeface="Arial"/>
-                <a:ea typeface="Arial"/>
-                <a:cs typeface="Arial"/>
-              </a:defRPr>
-            </a:lvl1pPr>
-            <a:lvl2pPr algn="l">
-              <a:defRPr sz="975" b="0">
-                <a:solidFill>
-                  <a:srgbClr val="6B7280"/>
-                </a:solidFill>
-                <a:latin typeface="Arial"/>
-                <a:ea typeface="Arial"/>
-                <a:cs typeface="Arial"/>
-              </a:defRPr>
-            </a:lvl2pPr>
-            <a:lvl3pPr algn="l">
-              <a:defRPr sz="975" b="0">
-                <a:solidFill>
-                  <a:srgbClr val="6B7280"/>
-                </a:solidFill>
-                <a:latin typeface="Arial"/>
-                <a:ea typeface="Arial"/>
-                <a:cs typeface="Arial"/>
-              </a:defRPr>
-            </a:lvl3pPr>
-            <a:lvl4pPr algn="l">
-              <a:defRPr sz="975" b="0">
-                <a:solidFill>
-                  <a:srgbClr val="6B7280"/>
-                </a:solidFill>
-                <a:latin typeface="Arial"/>
-                <a:ea typeface="Arial"/>
-                <a:cs typeface="Arial"/>
-              </a:defRPr>
-            </a:lvl4pPr>
-            <a:lvl5pPr algn="l">
-              <a:defRPr sz="975" b="0">
-                <a:solidFill>
-                  <a:srgbClr val="6B7280"/>
-                </a:solidFill>
-                <a:latin typeface="Arial"/>
-                <a:ea typeface="Arial"/>
-                <a:cs typeface="Arial"/>
-              </a:defRPr>
-            </a:lvl5pPr>
-            <a:lvl6pPr algn="l">
-              <a:defRPr sz="975" b="0">
-                <a:solidFill>
-                  <a:srgbClr val="6B7280"/>
-                </a:solidFill>
-                <a:latin typeface="Arial"/>
-                <a:ea typeface="Arial"/>
-                <a:cs typeface="Arial"/>
-              </a:defRPr>
-            </a:lvl6pPr>
-            <a:lvl7pPr algn="l">
-              <a:defRPr sz="975" b="0">
-                <a:solidFill>
-                  <a:srgbClr val="6B7280"/>
-                </a:solidFill>
-                <a:latin typeface="Arial"/>
-                <a:ea typeface="Arial"/>
-                <a:cs typeface="Arial"/>
-              </a:defRPr>
-            </a:lvl7pPr>
-            <a:lvl8pPr algn="l">
-              <a:defRPr sz="975" b="0">
-                <a:solidFill>
-                  <a:srgbClr val="6B7280"/>
-                </a:solidFill>
-                <a:latin typeface="Arial"/>
-                <a:ea typeface="Arial"/>
-                <a:cs typeface="Arial"/>
-              </a:defRPr>
-            </a:lvl8pPr>
-            <a:lvl9pPr algn="l">
-              <a:defRPr sz="975" b="0">
-                <a:solidFill>
-                  <a:srgbClr val="6B7280"/>
-                </a:solidFill>
-                <a:latin typeface="Arial"/>
-                <a:ea typeface="Arial"/>
-                <a:cs typeface="Arial"/>
-              </a:defRPr>
-            </a:lvl9pPr>
-          </a:lstStyle>
-          <a:p xmlns:a="http://schemas.openxmlformats.org/drawingml/2006/main">
-            <a:pPr algn="l">
-              <a:lnSpc>
-                <a:spcPct val="105000"/>
-              </a:lnSpc>
-              <a:buNone/>
-              <a:defRPr sz="975" b="0">
-                <a:solidFill>
-                  <a:srgbClr val="6B7280"/>
-                </a:solidFill>
-                <a:latin typeface="Arial"/>
-                <a:ea typeface="Arial"/>
-                <a:cs typeface="Arial"/>
-              </a:defRPr>
-            </a:pPr>
-            <a:r>
-              <a:rPr sz="975" b="0">
-                <a:solidFill>
-                  <a:srgbClr val="6B7280"/>
-                </a:solidFill>
-                <a:latin typeface="Arial"/>
-                <a:ea typeface="Arial"/>
-                <a:cs typeface="Arial"/>
-              </a:rPr>
-              <a:t>Финал · Анастасия, затем вопросы</a:t>
-            </a:r>
-          </a:p>
-        </p:txBody>
-      </p:sp>
-      <p:sp>
-        <p:nvSpPr>
-          <p:cNvPr id="27" name="">
-            <a:extLst xmlns:a="http://schemas.openxmlformats.org/drawingml/2006/main">
-              <a:ext uri="{FF2B5EF4-FFF2-40B4-BE49-F238E27FC236}">
-                <a16:creationId xmlns:a16="http://schemas.microsoft.com/office/drawing/2014/main" id="{0E3A6034-42AD-48F2-8278-7AFDFF774084}"/>
+                <a16:creationId xmlns:a16="http://schemas.microsoft.com/office/drawing/2014/main" id="{21E82058-D0A7-4431-9C5E-92B8DAF6E405}"/>
               </a:ext>
             </a:extLst>
           </p:cNvPr>
@@ -29919,7 +28754,7 @@
     </p:spTree>
     <p:extLst>
       <p:ext uri="{BB962C8B-B14F-4D97-AF65-F5344CB8AC3E}">
-        <p14:creationId xmlns:p14="http://schemas.microsoft.com/office/powerpoint/2010/main" val="1321173260"/>
+        <p14:creationId xmlns:p14="http://schemas.microsoft.com/office/powerpoint/2010/main" val="2118529744"/>
       </p:ext>
     </p:extLst>
   </p:cSld>

</xml_diff>